<commit_message>
Release: bundled icon set (137 icons), npm footprint 120MB -> 24MB
</commit_message>
<xml_diff>
--- a/examples/golden-deck.pptx
+++ b/examples/golden-deck.pptx
@@ -5220,17 +5220,9 @@
               <a:gd name="adj" fmla="val 1462"/>
             </a:avLst>
           </a:prstGeom>
-          <a:gradFill rotWithShape="1">
-            <a:gsLst>
-              <a:gs pos="0">
-                <a:srgbClr val="346FD1"/>
-              </a:gs>
-              <a:gs pos="100000">
-                <a:srgbClr val="154493"/>
-              </a:gs>
-            </a:gsLst>
-            <a:lin scaled="0" ang="16200000"/>
-          </a:gradFill>
+          <a:solidFill>
+            <a:srgbClr val="1D5FCC"/>
+          </a:solidFill>
           <a:ln w="12700">
             <a:solidFill>
               <a:srgbClr val="CFCFCF"/>
@@ -8382,17 +8374,9 @@
               <a:gd name="adj" fmla="val 1552"/>
             </a:avLst>
           </a:prstGeom>
-          <a:gradFill rotWithShape="1">
-            <a:gsLst>
-              <a:gs pos="0">
-                <a:srgbClr val="346FD1"/>
-              </a:gs>
-              <a:gs pos="100000">
-                <a:srgbClr val="154493"/>
-              </a:gs>
-            </a:gsLst>
-            <a:lin scaled="0" ang="16200000"/>
-          </a:gradFill>
+          <a:solidFill>
+            <a:srgbClr val="1D5FCC"/>
+          </a:solidFill>
           <a:ln w="12700">
             <a:solidFill>
               <a:srgbClr val="CFCFCF"/>
@@ -16163,17 +16147,9 @@
               <a:gd name="adj" fmla="val 3871"/>
             </a:avLst>
           </a:prstGeom>
-          <a:gradFill rotWithShape="1">
-            <a:gsLst>
-              <a:gs pos="0">
-                <a:srgbClr val="346FD1"/>
-              </a:gs>
-              <a:gs pos="100000">
-                <a:srgbClr val="154493"/>
-              </a:gs>
-            </a:gsLst>
-            <a:lin scaled="0" ang="16200000"/>
-          </a:gradFill>
+          <a:solidFill>
+            <a:srgbClr val="1D5FCC"/>
+          </a:solidFill>
           <a:ln w="12700">
             <a:solidFill>
               <a:srgbClr val="CFCFCF"/>
@@ -25109,17 +25085,9 @@
               <a:gd name="adj" fmla="val 4295"/>
             </a:avLst>
           </a:prstGeom>
-          <a:gradFill rotWithShape="1">
-            <a:gsLst>
-              <a:gs pos="0">
-                <a:srgbClr val="346FD1"/>
-              </a:gs>
-              <a:gs pos="100000">
-                <a:srgbClr val="154493"/>
-              </a:gs>
-            </a:gsLst>
-            <a:lin scaled="0" ang="16200000"/>
-          </a:gradFill>
+          <a:solidFill>
+            <a:srgbClr val="1D5FCC"/>
+          </a:solidFill>
           <a:ln w="12700">
             <a:solidFill>
               <a:srgbClr val="CFCFCF"/>

</xml_diff>

<commit_message>
Release v1.4.0: golden deck 34 slides (icons, delivery primitives, quote+funnel)
</commit_message>
<xml_diff>
--- a/examples/golden-deck.pptx
+++ b/examples/golden-deck.pptx
@@ -36,9 +36,12 @@
     <p:sldId id="284" r:id="rId30"/>
     <p:sldId id="285" r:id="rId31"/>
     <p:sldId id="286" r:id="rId32"/>
+    <p:sldId id="287" r:id="rId33"/>
+    <p:sldId id="288" r:id="rId34"/>
+    <p:sldId id="289" r:id="rId35"/>
   </p:sldIdLst>
   <p:notesMasterIdLst>
-    <p:notesMasterId r:id="rId33"/>
+    <p:notesMasterId r:id="rId36"/>
   </p:notesMasterIdLst>
   <p:sldSz cx="12192000" cy="6858000"/>
   <p:notesSz cx="6858000" cy="12192000"/>
@@ -4210,6 +4213,270 @@
             <a:fld id="{F7021451-1387-4CA6-816F-3879F97B5CBC}" type="slidenum">
               <a:rPr lang="en-US"/>
               <a:t>31</a:t>
+            </a:fld>
+            <a:endParaRPr lang="en-US"/>
+          </a:p>
+        </p:txBody>
+      </p:sp>
+    </p:spTree>
+    <p:extLst>
+      <p:ext uri="{BB962C8B-B14F-4D97-AF65-F5344CB8AC3E}">
+        <p14:creationId xmlns:p14="http://schemas.microsoft.com/office/powerpoint/2010/main" val="1024086991"/>
+      </p:ext>
+    </p:extLst>
+  </p:cSld>
+  <p:clrMapOvr>
+    <a:masterClrMapping/>
+  </p:clrMapOvr>
+</p:notes>
+</file>
+
+<file path=ppt/notesSlides/notesSlide32.xml><?xml version="1.0" encoding="utf-8"?>
+<p:notes xmlns:a="http://schemas.openxmlformats.org/drawingml/2006/main" xmlns:r="http://schemas.openxmlformats.org/officeDocument/2006/relationships" xmlns:p="http://schemas.openxmlformats.org/presentationml/2006/main">
+  <p:cSld>
+    <p:spTree>
+      <p:nvGrpSpPr>
+        <p:cNvPr id="1" name=""/>
+        <p:cNvGrpSpPr/>
+        <p:nvPr/>
+      </p:nvGrpSpPr>
+      <p:grpSpPr>
+        <a:xfrm>
+          <a:off x="0" y="0"/>
+          <a:ext cx="0" cy="0"/>
+          <a:chOff x="0" y="0"/>
+          <a:chExt cx="0" cy="0"/>
+        </a:xfrm>
+      </p:grpSpPr>
+      <p:sp>
+        <p:nvSpPr>
+          <p:cNvPr id="2" name="Slide Image Placeholder 1"/>
+          <p:cNvSpPr>
+            <a:spLocks noGrp="1" noRot="1" noChangeAspect="1"/>
+          </p:cNvSpPr>
+          <p:nvPr>
+            <p:ph type="sldImg"/>
+          </p:nvPr>
+        </p:nvSpPr>
+        <p:spPr/>
+      </p:sp>
+      <p:sp>
+        <p:nvSpPr>
+          <p:cNvPr id="3" name="Notes Placeholder 2"/>
+          <p:cNvSpPr>
+            <a:spLocks noGrp="1"/>
+          </p:cNvSpPr>
+          <p:nvPr>
+            <p:ph type="body" idx="1"/>
+          </p:nvPr>
+        </p:nvSpPr>
+        <p:spPr/>
+        <p:txBody>
+          <a:bodyPr/>
+          <a:lstStyle/>
+          <a:p>
+            <a:r>
+              <a:rPr lang="en-US" dirty="0"/>
+              <a:t/>
+            </a:r>
+            <a:endParaRPr lang="en-US" dirty="0"/>
+          </a:p>
+        </p:txBody>
+      </p:sp>
+      <p:sp>
+        <p:nvSpPr>
+          <p:cNvPr id="4" name="Slide Number Placeholder 3"/>
+          <p:cNvSpPr>
+            <a:spLocks noGrp="1"/>
+          </p:cNvSpPr>
+          <p:nvPr>
+            <p:ph type="sldNum" sz="quarter" idx="10"/>
+          </p:nvPr>
+        </p:nvSpPr>
+        <p:spPr/>
+        <p:txBody>
+          <a:bodyPr/>
+          <a:lstStyle/>
+          <a:p>
+            <a:fld id="{F7021451-1387-4CA6-816F-3879F97B5CBC}" type="slidenum">
+              <a:rPr lang="en-US"/>
+              <a:t>32</a:t>
+            </a:fld>
+            <a:endParaRPr lang="en-US"/>
+          </a:p>
+        </p:txBody>
+      </p:sp>
+    </p:spTree>
+    <p:extLst>
+      <p:ext uri="{BB962C8B-B14F-4D97-AF65-F5344CB8AC3E}">
+        <p14:creationId xmlns:p14="http://schemas.microsoft.com/office/powerpoint/2010/main" val="1024086991"/>
+      </p:ext>
+    </p:extLst>
+  </p:cSld>
+  <p:clrMapOvr>
+    <a:masterClrMapping/>
+  </p:clrMapOvr>
+</p:notes>
+</file>
+
+<file path=ppt/notesSlides/notesSlide33.xml><?xml version="1.0" encoding="utf-8"?>
+<p:notes xmlns:a="http://schemas.openxmlformats.org/drawingml/2006/main" xmlns:r="http://schemas.openxmlformats.org/officeDocument/2006/relationships" xmlns:p="http://schemas.openxmlformats.org/presentationml/2006/main">
+  <p:cSld>
+    <p:spTree>
+      <p:nvGrpSpPr>
+        <p:cNvPr id="1" name=""/>
+        <p:cNvGrpSpPr/>
+        <p:nvPr/>
+      </p:nvGrpSpPr>
+      <p:grpSpPr>
+        <a:xfrm>
+          <a:off x="0" y="0"/>
+          <a:ext cx="0" cy="0"/>
+          <a:chOff x="0" y="0"/>
+          <a:chExt cx="0" cy="0"/>
+        </a:xfrm>
+      </p:grpSpPr>
+      <p:sp>
+        <p:nvSpPr>
+          <p:cNvPr id="2" name="Slide Image Placeholder 1"/>
+          <p:cNvSpPr>
+            <a:spLocks noGrp="1" noRot="1" noChangeAspect="1"/>
+          </p:cNvSpPr>
+          <p:nvPr>
+            <p:ph type="sldImg"/>
+          </p:nvPr>
+        </p:nvSpPr>
+        <p:spPr/>
+      </p:sp>
+      <p:sp>
+        <p:nvSpPr>
+          <p:cNvPr id="3" name="Notes Placeholder 2"/>
+          <p:cNvSpPr>
+            <a:spLocks noGrp="1"/>
+          </p:cNvSpPr>
+          <p:nvPr>
+            <p:ph type="body" idx="1"/>
+          </p:nvPr>
+        </p:nvSpPr>
+        <p:spPr/>
+        <p:txBody>
+          <a:bodyPr/>
+          <a:lstStyle/>
+          <a:p>
+            <a:r>
+              <a:rPr lang="en-US" dirty="0"/>
+              <a:t/>
+            </a:r>
+            <a:endParaRPr lang="en-US" dirty="0"/>
+          </a:p>
+        </p:txBody>
+      </p:sp>
+      <p:sp>
+        <p:nvSpPr>
+          <p:cNvPr id="4" name="Slide Number Placeholder 3"/>
+          <p:cNvSpPr>
+            <a:spLocks noGrp="1"/>
+          </p:cNvSpPr>
+          <p:nvPr>
+            <p:ph type="sldNum" sz="quarter" idx="10"/>
+          </p:nvPr>
+        </p:nvSpPr>
+        <p:spPr/>
+        <p:txBody>
+          <a:bodyPr/>
+          <a:lstStyle/>
+          <a:p>
+            <a:fld id="{F7021451-1387-4CA6-816F-3879F97B5CBC}" type="slidenum">
+              <a:rPr lang="en-US"/>
+              <a:t>33</a:t>
+            </a:fld>
+            <a:endParaRPr lang="en-US"/>
+          </a:p>
+        </p:txBody>
+      </p:sp>
+    </p:spTree>
+    <p:extLst>
+      <p:ext uri="{BB962C8B-B14F-4D97-AF65-F5344CB8AC3E}">
+        <p14:creationId xmlns:p14="http://schemas.microsoft.com/office/powerpoint/2010/main" val="1024086991"/>
+      </p:ext>
+    </p:extLst>
+  </p:cSld>
+  <p:clrMapOvr>
+    <a:masterClrMapping/>
+  </p:clrMapOvr>
+</p:notes>
+</file>
+
+<file path=ppt/notesSlides/notesSlide34.xml><?xml version="1.0" encoding="utf-8"?>
+<p:notes xmlns:a="http://schemas.openxmlformats.org/drawingml/2006/main" xmlns:r="http://schemas.openxmlformats.org/officeDocument/2006/relationships" xmlns:p="http://schemas.openxmlformats.org/presentationml/2006/main">
+  <p:cSld>
+    <p:spTree>
+      <p:nvGrpSpPr>
+        <p:cNvPr id="1" name=""/>
+        <p:cNvGrpSpPr/>
+        <p:nvPr/>
+      </p:nvGrpSpPr>
+      <p:grpSpPr>
+        <a:xfrm>
+          <a:off x="0" y="0"/>
+          <a:ext cx="0" cy="0"/>
+          <a:chOff x="0" y="0"/>
+          <a:chExt cx="0" cy="0"/>
+        </a:xfrm>
+      </p:grpSpPr>
+      <p:sp>
+        <p:nvSpPr>
+          <p:cNvPr id="2" name="Slide Image Placeholder 1"/>
+          <p:cNvSpPr>
+            <a:spLocks noGrp="1" noRot="1" noChangeAspect="1"/>
+          </p:cNvSpPr>
+          <p:nvPr>
+            <p:ph type="sldImg"/>
+          </p:nvPr>
+        </p:nvSpPr>
+        <p:spPr/>
+      </p:sp>
+      <p:sp>
+        <p:nvSpPr>
+          <p:cNvPr id="3" name="Notes Placeholder 2"/>
+          <p:cNvSpPr>
+            <a:spLocks noGrp="1"/>
+          </p:cNvSpPr>
+          <p:nvPr>
+            <p:ph type="body" idx="1"/>
+          </p:nvPr>
+        </p:nvSpPr>
+        <p:spPr/>
+        <p:txBody>
+          <a:bodyPr/>
+          <a:lstStyle/>
+          <a:p>
+            <a:r>
+              <a:rPr lang="en-US" dirty="0"/>
+              <a:t/>
+            </a:r>
+            <a:endParaRPr lang="en-US" dirty="0"/>
+          </a:p>
+        </p:txBody>
+      </p:sp>
+      <p:sp>
+        <p:nvSpPr>
+          <p:cNvPr id="4" name="Slide Number Placeholder 3"/>
+          <p:cNvSpPr>
+            <a:spLocks noGrp="1"/>
+          </p:cNvSpPr>
+          <p:nvPr>
+            <p:ph type="sldNum" sz="quarter" idx="10"/>
+          </p:nvPr>
+        </p:nvSpPr>
+        <p:spPr/>
+        <p:txBody>
+          <a:bodyPr/>
+          <a:lstStyle/>
+          <a:p>
+            <a:fld id="{F7021451-1387-4CA6-816F-3879F97B5CBC}" type="slidenum">
+              <a:rPr lang="en-US"/>
+              <a:t>34</a:t>
             </a:fld>
             <a:endParaRPr lang="en-US"/>
           </a:p>
@@ -29992,6 +30259,3436 @@
 <file path=ppt/slides/slide31.xml><?xml version="1.0" encoding="utf-8"?>
 <p:sld xmlns:a="http://schemas.openxmlformats.org/drawingml/2006/main" xmlns:r="http://schemas.openxmlformats.org/officeDocument/2006/relationships" xmlns:p="http://schemas.openxmlformats.org/presentationml/2006/main">
   <p:cSld name="Slide 31">
+    <p:bg>
+      <p:bgPr>
+        <a:solidFill>
+          <a:srgbClr val="FFFFFF"/>
+        </a:solidFill>
+      </p:bgPr>
+    </p:bg>
+    <p:spTree>
+      <p:nvGrpSpPr>
+        <p:cNvPr id="1" name=""/>
+        <p:cNvGrpSpPr/>
+        <p:nvPr/>
+      </p:nvGrpSpPr>
+      <p:grpSpPr>
+        <a:xfrm>
+          <a:off x="0" y="0"/>
+          <a:ext cx="0" cy="0"/>
+          <a:chOff x="0" y="0"/>
+          <a:chExt cx="0" cy="0"/>
+        </a:xfrm>
+      </p:grpSpPr>
+      <p:sp>
+        <p:nvSpPr>
+          <p:cNvPr id="2" name="Text 0"/>
+          <p:cNvSpPr/>
+          <p:nvPr/>
+        </p:nvSpPr>
+        <p:spPr>
+          <a:xfrm>
+            <a:off x="502920" y="310896"/>
+            <a:ext cx="11155680" cy="256032"/>
+          </a:xfrm>
+          <a:prstGeom prst="rect">
+            <a:avLst/>
+          </a:prstGeom>
+          <a:noFill/>
+          <a:ln/>
+        </p:spPr>
+        <p:txBody>
+          <a:bodyPr wrap="square" lIns="0" tIns="0" rIns="0" bIns="0" rtlCol="0" anchor="ctr"/>
+          <a:lstStyle/>
+          <a:p>
+            <a:pPr indent="0" marL="0">
+              <a:buNone/>
+            </a:pPr>
+            <a:r>
+              <a:rPr lang="en-US" sz="1050" b="1" spc="200" kern="0" dirty="0">
+                <a:solidFill>
+                  <a:srgbClr val="1D5FCC"/>
+                </a:solidFill>
+                <a:latin typeface="Arial" pitchFamily="34" charset="0"/>
+                <a:ea typeface="Arial" pitchFamily="34" charset="-122"/>
+                <a:cs typeface="Arial" pitchFamily="34" charset="-120"/>
+              </a:rPr>
+              <a:t>EXHIBITS — ICON COLUMNS</a:t>
+            </a:r>
+            <a:endParaRPr lang="en-US" sz="1050" dirty="0"/>
+          </a:p>
+        </p:txBody>
+      </p:sp>
+      <p:sp>
+        <p:nvSpPr>
+          <p:cNvPr id="3" name="Text 1"/>
+          <p:cNvSpPr/>
+          <p:nvPr/>
+        </p:nvSpPr>
+        <p:spPr>
+          <a:xfrm>
+            <a:off x="502920" y="585216"/>
+            <a:ext cx="11155680" cy="822960"/>
+          </a:xfrm>
+          <a:prstGeom prst="rect">
+            <a:avLst/>
+          </a:prstGeom>
+          <a:noFill/>
+          <a:ln/>
+        </p:spPr>
+        <p:txBody>
+          <a:bodyPr wrap="square" lIns="0" tIns="0" rIns="0" bIns="0" rtlCol="0" anchor="t"/>
+          <a:lstStyle/>
+          <a:p>
+            <a:pPr indent="0" marL="0">
+              <a:lnSpc>
+                <a:spcPct val="102000"/>
+              </a:lnSpc>
+              <a:buNone/>
+            </a:pPr>
+            <a:r>
+              <a:rPr lang="en-US" sz="2100" b="1" dirty="0">
+                <a:solidFill>
+                  <a:srgbClr val="1A1A1A"/>
+                </a:solidFill>
+                <a:latin typeface="Arial" pitchFamily="34" charset="0"/>
+                <a:ea typeface="Arial" pitchFamily="34" charset="-122"/>
+                <a:cs typeface="Arial" pitchFamily="34" charset="-120"/>
+              </a:rPr>
+              <a:t>Four levers carry the program, each with one owner and one number to watch</a:t>
+            </a:r>
+            <a:endParaRPr lang="en-US" sz="2100" dirty="0"/>
+          </a:p>
+        </p:txBody>
+      </p:sp>
+      <p:sp>
+        <p:nvSpPr>
+          <p:cNvPr id="4" name="Shape 2"/>
+          <p:cNvSpPr/>
+          <p:nvPr/>
+        </p:nvSpPr>
+        <p:spPr>
+          <a:xfrm>
+            <a:off x="502920" y="1435608"/>
+            <a:ext cx="11155680" cy="25603"/>
+          </a:xfrm>
+          <a:prstGeom prst="rect">
+            <a:avLst/>
+          </a:prstGeom>
+          <a:solidFill>
+            <a:srgbClr val="2E7CF6"/>
+          </a:solidFill>
+          <a:ln/>
+        </p:spPr>
+      </p:sp>
+      <p:sp>
+        <p:nvSpPr>
+          <p:cNvPr id="5" name="Text 3"/>
+          <p:cNvSpPr/>
+          <p:nvPr/>
+        </p:nvSpPr>
+        <p:spPr>
+          <a:xfrm>
+            <a:off x="502920" y="1499616"/>
+            <a:ext cx="11155680" cy="384048"/>
+          </a:xfrm>
+          <a:prstGeom prst="rect">
+            <a:avLst/>
+          </a:prstGeom>
+          <a:noFill/>
+          <a:ln/>
+        </p:spPr>
+        <p:txBody>
+          <a:bodyPr wrap="square" lIns="0" tIns="0" rIns="0" bIns="0" rtlCol="0" anchor="t"/>
+          <a:lstStyle/>
+          <a:p>
+            <a:pPr indent="0" marL="0">
+              <a:buNone/>
+            </a:pPr>
+            <a:r>
+              <a:rPr lang="en-US" sz="1350" i="1" dirty="0">
+                <a:solidFill>
+                  <a:srgbClr val="595959"/>
+                </a:solidFill>
+                <a:latin typeface="Arial" pitchFamily="34" charset="0"/>
+                <a:ea typeface="Arial" pitchFamily="34" charset="-122"/>
+                <a:cs typeface="Arial" pitchFamily="34" charset="-120"/>
+              </a:rPr>
+              <a:t>Icon columns with the BUNDLED icon set (137 icons, tinted to the brand accent, zero extra dependency).</a:t>
+            </a:r>
+            <a:endParaRPr lang="en-US" sz="1350" dirty="0"/>
+          </a:p>
+        </p:txBody>
+      </p:sp>
+      <p:pic>
+        <p:nvPicPr>
+          <p:cNvPr id="6" name="Image 0" descr="/Users/othmane_benkirane/.claude/skills/sprintospptx-v3/examples/gd-assets/FaClipboardCheck-1D5FCC-256.png">    </p:cNvPr>
+          <p:cNvPicPr>
+            <a:picLocks noChangeAspect="1"/>
+          </p:cNvPicPr>
+          <p:nvPr/>
+        </p:nvPicPr>
+        <p:blipFill>
+          <a:blip r:embed="rId1"/>
+          <a:stretch>
+            <a:fillRect/>
+          </a:stretch>
+        </p:blipFill>
+        <p:spPr>
+          <a:xfrm>
+            <a:off x="1565910" y="2194560"/>
+            <a:ext cx="457200" cy="457200"/>
+          </a:xfrm>
+          <a:prstGeom prst="rect">
+            <a:avLst/>
+          </a:prstGeom>
+        </p:spPr>
+      </p:pic>
+      <p:sp>
+        <p:nvSpPr>
+          <p:cNvPr id="7" name="Text 4"/>
+          <p:cNvSpPr/>
+          <p:nvPr/>
+        </p:nvSpPr>
+        <p:spPr>
+          <a:xfrm>
+            <a:off x="502920" y="2761488"/>
+            <a:ext cx="2583180" cy="365760"/>
+          </a:xfrm>
+          <a:prstGeom prst="rect">
+            <a:avLst/>
+          </a:prstGeom>
+          <a:noFill/>
+          <a:ln/>
+        </p:spPr>
+        <p:txBody>
+          <a:bodyPr wrap="square" lIns="0" tIns="0" rIns="0" bIns="0" rtlCol="0" anchor="ctr"/>
+          <a:lstStyle/>
+          <a:p>
+            <a:pPr algn="ctr" indent="0" marL="0">
+              <a:buNone/>
+            </a:pPr>
+            <a:r>
+              <a:rPr lang="en-US" sz="1300" b="1" dirty="0">
+                <a:solidFill>
+                  <a:srgbClr val="1A1A1A"/>
+                </a:solidFill>
+                <a:latin typeface="Arial" pitchFamily="34" charset="0"/>
+                <a:ea typeface="Arial" pitchFamily="34" charset="-122"/>
+                <a:cs typeface="Arial" pitchFamily="34" charset="-120"/>
+              </a:rPr>
+              <a:t>Contract attach</a:t>
+            </a:r>
+            <a:endParaRPr lang="en-US" sz="1300" dirty="0"/>
+          </a:p>
+        </p:txBody>
+      </p:sp>
+      <p:sp>
+        <p:nvSpPr>
+          <p:cNvPr id="8" name="Text 5"/>
+          <p:cNvSpPr/>
+          <p:nvPr/>
+        </p:nvSpPr>
+        <p:spPr>
+          <a:xfrm>
+            <a:off x="502920" y="3145536"/>
+            <a:ext cx="2583180" cy="1280160"/>
+          </a:xfrm>
+          <a:prstGeom prst="rect">
+            <a:avLst/>
+          </a:prstGeom>
+          <a:noFill/>
+          <a:ln/>
+        </p:spPr>
+        <p:txBody>
+          <a:bodyPr wrap="square" lIns="0" tIns="0" rIns="0" bIns="0" rtlCol="0" anchor="t"/>
+          <a:lstStyle/>
+          <a:p>
+            <a:pPr algn="ctr" indent="0" marL="0">
+              <a:lnSpc>
+                <a:spcPct val="120000"/>
+              </a:lnSpc>
+              <a:buNone/>
+            </a:pPr>
+            <a:r>
+              <a:rPr lang="en-US" sz="1100" dirty="0">
+                <a:solidFill>
+                  <a:srgbClr val="595959"/>
+                </a:solidFill>
+                <a:latin typeface="Arial" pitchFamily="34" charset="0"/>
+                <a:ea typeface="Arial" pitchFamily="34" charset="-122"/>
+                <a:cs typeface="Arial" pitchFamily="34" charset="-120"/>
+              </a:rPr>
+              <a:t>Every equipment sale carries a 5-year service contract offer. The pilot converts 26% of the installed base approached, against a 14% break-even.</a:t>
+            </a:r>
+            <a:endParaRPr lang="en-US" sz="1100" dirty="0"/>
+          </a:p>
+        </p:txBody>
+      </p:sp>
+      <p:pic>
+        <p:nvPicPr>
+          <p:cNvPr id="9" name="Image 1" descr="/Users/othmane_benkirane/.claude/skills/sprintospptx-v3/examples/gd-assets/FaDatabase-1D5FCC-256.png">    </p:cNvPr>
+          <p:cNvPicPr>
+            <a:picLocks noChangeAspect="1"/>
+          </p:cNvPicPr>
+          <p:nvPr/>
+        </p:nvPicPr>
+        <p:blipFill>
+          <a:blip r:embed="rId2"/>
+          <a:stretch>
+            <a:fillRect/>
+          </a:stretch>
+        </p:blipFill>
+        <p:spPr>
+          <a:xfrm>
+            <a:off x="4423410" y="2194560"/>
+            <a:ext cx="457200" cy="457200"/>
+          </a:xfrm>
+          <a:prstGeom prst="rect">
+            <a:avLst/>
+          </a:prstGeom>
+        </p:spPr>
+      </p:pic>
+      <p:sp>
+        <p:nvSpPr>
+          <p:cNvPr id="10" name="Text 6"/>
+          <p:cNvSpPr/>
+          <p:nvPr/>
+        </p:nvSpPr>
+        <p:spPr>
+          <a:xfrm>
+            <a:off x="3360420" y="2761488"/>
+            <a:ext cx="2583180" cy="365760"/>
+          </a:xfrm>
+          <a:prstGeom prst="rect">
+            <a:avLst/>
+          </a:prstGeom>
+          <a:noFill/>
+          <a:ln/>
+        </p:spPr>
+        <p:txBody>
+          <a:bodyPr wrap="square" lIns="0" tIns="0" rIns="0" bIns="0" rtlCol="0" anchor="ctr"/>
+          <a:lstStyle/>
+          <a:p>
+            <a:pPr algn="ctr" indent="0" marL="0">
+              <a:buNone/>
+            </a:pPr>
+            <a:r>
+              <a:rPr lang="en-US" sz="1300" b="1" dirty="0">
+                <a:solidFill>
+                  <a:srgbClr val="1A1A1A"/>
+                </a:solidFill>
+                <a:latin typeface="Arial" pitchFamily="34" charset="0"/>
+                <a:ea typeface="Arial" pitchFamily="34" charset="-122"/>
+                <a:cs typeface="Arial" pitchFamily="34" charset="-120"/>
+              </a:rPr>
+              <a:t>Usage data</a:t>
+            </a:r>
+            <a:endParaRPr lang="en-US" sz="1300" dirty="0"/>
+          </a:p>
+        </p:txBody>
+      </p:sp>
+      <p:sp>
+        <p:nvSpPr>
+          <p:cNvPr id="11" name="Text 7"/>
+          <p:cNvSpPr/>
+          <p:nvPr/>
+        </p:nvSpPr>
+        <p:spPr>
+          <a:xfrm>
+            <a:off x="3360420" y="3145536"/>
+            <a:ext cx="2583180" cy="1280160"/>
+          </a:xfrm>
+          <a:prstGeom prst="rect">
+            <a:avLst/>
+          </a:prstGeom>
+          <a:noFill/>
+          <a:ln/>
+        </p:spPr>
+        <p:txBody>
+          <a:bodyPr wrap="square" lIns="0" tIns="0" rIns="0" bIns="0" rtlCol="0" anchor="t"/>
+          <a:lstStyle/>
+          <a:p>
+            <a:pPr algn="ctr" indent="0" marL="0">
+              <a:lnSpc>
+                <a:spcPct val="120000"/>
+              </a:lnSpc>
+              <a:buNone/>
+            </a:pPr>
+            <a:r>
+              <a:rPr lang="en-US" sz="1100" dirty="0">
+                <a:solidFill>
+                  <a:srgbClr val="595959"/>
+                </a:solidFill>
+                <a:latin typeface="Arial" pitchFamily="34" charset="0"/>
+                <a:ea typeface="Arial" pitchFamily="34" charset="-122"/>
+                <a:cs typeface="Arial" pitchFamily="34" charset="-120"/>
+              </a:rPr>
+              <a:t>6,800 connected sites feed the predictive models: 38% of failures are flagged 90 days ahead, cutting intervention costs by 22%.</a:t>
+            </a:r>
+            <a:endParaRPr lang="en-US" sz="1100" dirty="0"/>
+          </a:p>
+        </p:txBody>
+      </p:sp>
+      <p:pic>
+        <p:nvPicPr>
+          <p:cNvPr id="12" name="Image 2" descr="/Users/othmane_benkirane/.claude/skills/sprintospptx-v3/examples/gd-assets/FaUsers-1D5FCC-256.png">    </p:cNvPr>
+          <p:cNvPicPr>
+            <a:picLocks noChangeAspect="1"/>
+          </p:cNvPicPr>
+          <p:nvPr/>
+        </p:nvPicPr>
+        <p:blipFill>
+          <a:blip r:embed="rId3"/>
+          <a:stretch>
+            <a:fillRect/>
+          </a:stretch>
+        </p:blipFill>
+        <p:spPr>
+          <a:xfrm>
+            <a:off x="7280910" y="2194560"/>
+            <a:ext cx="457200" cy="457200"/>
+          </a:xfrm>
+          <a:prstGeom prst="rect">
+            <a:avLst/>
+          </a:prstGeom>
+        </p:spPr>
+      </p:pic>
+      <p:sp>
+        <p:nvSpPr>
+          <p:cNvPr id="13" name="Text 8"/>
+          <p:cNvSpPr/>
+          <p:nvPr/>
+        </p:nvSpPr>
+        <p:spPr>
+          <a:xfrm>
+            <a:off x="6217920" y="2761488"/>
+            <a:ext cx="2583180" cy="365760"/>
+          </a:xfrm>
+          <a:prstGeom prst="rect">
+            <a:avLst/>
+          </a:prstGeom>
+          <a:noFill/>
+          <a:ln/>
+        </p:spPr>
+        <p:txBody>
+          <a:bodyPr wrap="square" lIns="0" tIns="0" rIns="0" bIns="0" rtlCol="0" anchor="ctr"/>
+          <a:lstStyle/>
+          <a:p>
+            <a:pPr algn="ctr" indent="0" marL="0">
+              <a:buNone/>
+            </a:pPr>
+            <a:r>
+              <a:rPr lang="en-US" sz="1300" b="1" dirty="0">
+                <a:solidFill>
+                  <a:srgbClr val="1A1A1A"/>
+                </a:solidFill>
+                <a:latin typeface="Arial" pitchFamily="34" charset="0"/>
+                <a:ea typeface="Arial" pitchFamily="34" charset="-122"/>
+                <a:cs typeface="Arial" pitchFamily="34" charset="-120"/>
+              </a:rPr>
+              <a:t>People</a:t>
+            </a:r>
+            <a:endParaRPr lang="en-US" sz="1300" dirty="0"/>
+          </a:p>
+        </p:txBody>
+      </p:sp>
+      <p:sp>
+        <p:nvSpPr>
+          <p:cNvPr id="14" name="Text 9"/>
+          <p:cNvSpPr/>
+          <p:nvPr/>
+        </p:nvSpPr>
+        <p:spPr>
+          <a:xfrm>
+            <a:off x="6217920" y="3145536"/>
+            <a:ext cx="2583180" cy="1280160"/>
+          </a:xfrm>
+          <a:prstGeom prst="rect">
+            <a:avLst/>
+          </a:prstGeom>
+          <a:noFill/>
+          <a:ln/>
+        </p:spPr>
+        <p:txBody>
+          <a:bodyPr wrap="square" lIns="0" tIns="0" rIns="0" bIns="0" rtlCol="0" anchor="t"/>
+          <a:lstStyle/>
+          <a:p>
+            <a:pPr algn="ctr" indent="0" marL="0">
+              <a:lnSpc>
+                <a:spcPct val="120000"/>
+              </a:lnSpc>
+              <a:buNone/>
+            </a:pPr>
+            <a:r>
+              <a:rPr lang="en-US" sz="1100" dirty="0">
+                <a:solidFill>
+                  <a:srgbClr val="595959"/>
+                </a:solidFill>
+                <a:latin typeface="Arial" pitchFamily="34" charset="0"/>
+                <a:ea typeface="Arial" pitchFamily="34" charset="-122"/>
+                <a:cs typeface="Arial" pitchFamily="34" charset="-120"/>
+              </a:rPr>
+              <a:t>300 technicians move to predictive maintenance by 2028, with an expert track and a certification bonus to hold attrition under 6%.</a:t>
+            </a:r>
+            <a:endParaRPr lang="en-US" sz="1100" dirty="0"/>
+          </a:p>
+        </p:txBody>
+      </p:sp>
+      <p:pic>
+        <p:nvPicPr>
+          <p:cNvPr id="15" name="Image 3" descr="/Users/othmane_benkirane/.claude/skills/sprintospptx-v3/examples/gd-assets/FaTruck-1D5FCC-256.png">    </p:cNvPr>
+          <p:cNvPicPr>
+            <a:picLocks noChangeAspect="1"/>
+          </p:cNvPicPr>
+          <p:nvPr/>
+        </p:nvPicPr>
+        <p:blipFill>
+          <a:blip r:embed="rId4"/>
+          <a:stretch>
+            <a:fillRect/>
+          </a:stretch>
+        </p:blipFill>
+        <p:spPr>
+          <a:xfrm>
+            <a:off x="10138410" y="2194560"/>
+            <a:ext cx="457200" cy="457200"/>
+          </a:xfrm>
+          <a:prstGeom prst="rect">
+            <a:avLst/>
+          </a:prstGeom>
+        </p:spPr>
+      </p:pic>
+      <p:sp>
+        <p:nvSpPr>
+          <p:cNvPr id="16" name="Text 10"/>
+          <p:cNvSpPr/>
+          <p:nvPr/>
+        </p:nvSpPr>
+        <p:spPr>
+          <a:xfrm>
+            <a:off x="9075420" y="2761488"/>
+            <a:ext cx="2583180" cy="365760"/>
+          </a:xfrm>
+          <a:prstGeom prst="rect">
+            <a:avLst/>
+          </a:prstGeom>
+          <a:noFill/>
+          <a:ln/>
+        </p:spPr>
+        <p:txBody>
+          <a:bodyPr wrap="square" lIns="0" tIns="0" rIns="0" bIns="0" rtlCol="0" anchor="ctr"/>
+          <a:lstStyle/>
+          <a:p>
+            <a:pPr algn="ctr" indent="0" marL="0">
+              <a:buNone/>
+            </a:pPr>
+            <a:r>
+              <a:rPr lang="en-US" sz="1300" b="1" dirty="0">
+                <a:solidFill>
+                  <a:srgbClr val="1A1A1A"/>
+                </a:solidFill>
+                <a:latin typeface="Arial" pitchFamily="34" charset="0"/>
+                <a:ea typeface="Arial" pitchFamily="34" charset="-122"/>
+                <a:cs typeface="Arial" pitchFamily="34" charset="-120"/>
+              </a:rPr>
+              <a:t>Parts logistics</a:t>
+            </a:r>
+            <a:endParaRPr lang="en-US" sz="1300" dirty="0"/>
+          </a:p>
+        </p:txBody>
+      </p:sp>
+      <p:sp>
+        <p:nvSpPr>
+          <p:cNvPr id="17" name="Text 11"/>
+          <p:cNvSpPr/>
+          <p:nvPr/>
+        </p:nvSpPr>
+        <p:spPr>
+          <a:xfrm>
+            <a:off x="9075420" y="3145536"/>
+            <a:ext cx="2583180" cy="1280160"/>
+          </a:xfrm>
+          <a:prstGeom prst="rect">
+            <a:avLst/>
+          </a:prstGeom>
+          <a:noFill/>
+          <a:ln/>
+        </p:spPr>
+        <p:txBody>
+          <a:bodyPr wrap="square" lIns="0" tIns="0" rIns="0" bIns="0" rtlCol="0" anchor="t"/>
+          <a:lstStyle/>
+          <a:p>
+            <a:pPr algn="ctr" indent="0" marL="0">
+              <a:lnSpc>
+                <a:spcPct val="120000"/>
+              </a:lnSpc>
+              <a:buNone/>
+            </a:pPr>
+            <a:r>
+              <a:rPr lang="en-US" sz="1100" dirty="0">
+                <a:solidFill>
+                  <a:srgbClr val="595959"/>
+                </a:solidFill>
+                <a:latin typeface="Arial" pitchFamily="34" charset="0"/>
+                <a:ea typeface="Arial" pitchFamily="34" charset="-122"/>
+                <a:cs typeface="Arial" pitchFamily="34" charset="-120"/>
+              </a:rPr>
+              <a:t>Forward stock in 12 regional hubs brings next-day delivery to 94% of the base, the argument that beats independent maintainers.</a:t>
+            </a:r>
+            <a:endParaRPr lang="en-US" sz="1100" dirty="0"/>
+          </a:p>
+        </p:txBody>
+      </p:sp>
+      <p:sp>
+        <p:nvSpPr>
+          <p:cNvPr id="18" name="Shape 12"/>
+          <p:cNvSpPr/>
+          <p:nvPr/>
+        </p:nvSpPr>
+        <p:spPr>
+          <a:xfrm>
+            <a:off x="502920" y="5779008"/>
+            <a:ext cx="11155680" cy="548640"/>
+          </a:xfrm>
+          <a:prstGeom prst="rect">
+            <a:avLst/>
+          </a:prstGeom>
+          <a:solidFill>
+            <a:srgbClr val="EFF4FE"/>
+          </a:solidFill>
+          <a:ln w="6350">
+            <a:solidFill>
+              <a:srgbClr val="CFCFCF"/>
+            </a:solidFill>
+            <a:prstDash val="solid"/>
+          </a:ln>
+        </p:spPr>
+      </p:sp>
+      <p:sp>
+        <p:nvSpPr>
+          <p:cNvPr id="19" name="Shape 13"/>
+          <p:cNvSpPr/>
+          <p:nvPr/>
+        </p:nvSpPr>
+        <p:spPr>
+          <a:xfrm>
+            <a:off x="502920" y="5779008"/>
+            <a:ext cx="73152" cy="548640"/>
+          </a:xfrm>
+          <a:prstGeom prst="rect">
+            <a:avLst/>
+          </a:prstGeom>
+          <a:solidFill>
+            <a:srgbClr val="2E7CF6"/>
+          </a:solidFill>
+          <a:ln/>
+        </p:spPr>
+      </p:sp>
+      <p:sp>
+        <p:nvSpPr>
+          <p:cNvPr id="20" name="Text 14"/>
+          <p:cNvSpPr/>
+          <p:nvPr/>
+        </p:nvSpPr>
+        <p:spPr>
+          <a:xfrm>
+            <a:off x="713232" y="5779008"/>
+            <a:ext cx="10835640" cy="548640"/>
+          </a:xfrm>
+          <a:prstGeom prst="rect">
+            <a:avLst/>
+          </a:prstGeom>
+          <a:noFill/>
+          <a:ln/>
+        </p:spPr>
+        <p:txBody>
+          <a:bodyPr wrap="square" lIns="0" tIns="0" rIns="0" bIns="0" rtlCol="0" anchor="ctr"/>
+          <a:lstStyle/>
+          <a:p>
+            <a:pPr indent="0" marL="0">
+              <a:lnSpc>
+                <a:spcPct val="105000"/>
+              </a:lnSpc>
+              <a:buNone/>
+            </a:pPr>
+            <a:r>
+              <a:rPr lang="en-US" sz="1200" b="1" dirty="0">
+                <a:solidFill>
+                  <a:srgbClr val="1D5FCC"/>
+                </a:solidFill>
+                <a:latin typeface="Arial" pitchFamily="34" charset="0"/>
+                <a:ea typeface="Arial" pitchFamily="34" charset="-122"/>
+                <a:cs typeface="Arial" pitchFamily="34" charset="-120"/>
+              </a:rPr>
+              <a:t>Key takeaway: </a:t>
+            </a:r>
+            <a:pPr indent="0" marL="0">
+              <a:lnSpc>
+                <a:spcPct val="105000"/>
+              </a:lnSpc>
+              <a:buNone/>
+            </a:pPr>
+            <a:r>
+              <a:rPr lang="en-US" sz="1200" dirty="0">
+                <a:solidFill>
+                  <a:srgbClr val="1A1A1A"/>
+                </a:solidFill>
+                <a:latin typeface="Arial" pitchFamily="34" charset="0"/>
+                <a:ea typeface="Arial" pitchFamily="34" charset="-122"/>
+                <a:cs typeface="Arial" pitchFamily="34" charset="-120"/>
+              </a:rPr>
+              <a:t>One owner per lever, one metric per owner: the program reviews four numbers, not forty.</a:t>
+            </a:r>
+            <a:endParaRPr lang="en-US" sz="1200" dirty="0"/>
+          </a:p>
+        </p:txBody>
+      </p:sp>
+      <p:sp>
+        <p:nvSpPr>
+          <p:cNvPr id="21" name="Text 15"/>
+          <p:cNvSpPr/>
+          <p:nvPr/>
+        </p:nvSpPr>
+        <p:spPr>
+          <a:xfrm>
+            <a:off x="502920" y="6419088"/>
+            <a:ext cx="10515600" cy="274320"/>
+          </a:xfrm>
+          <a:prstGeom prst="rect">
+            <a:avLst/>
+          </a:prstGeom>
+          <a:noFill/>
+          <a:ln/>
+        </p:spPr>
+        <p:txBody>
+          <a:bodyPr wrap="square" lIns="0" tIns="0" rIns="0" bIns="0" rtlCol="0" anchor="ctr"/>
+          <a:lstStyle/>
+          <a:p>
+            <a:pPr indent="0" marL="0">
+              <a:buNone/>
+            </a:pPr>
+            <a:r>
+              <a:rPr lang="en-US" sz="800" dirty="0">
+                <a:solidFill>
+                  <a:srgbClr val="8C8C8C"/>
+                </a:solidFill>
+                <a:latin typeface="Arial" pitchFamily="34" charset="0"/>
+                <a:ea typeface="Arial" pitchFamily="34" charset="-122"/>
+                <a:cs typeface="Arial" pitchFamily="34" charset="-120"/>
+              </a:rPr>
+              <a:t>Source: Meridio annual reports 2022-2025; management interviews; Sprint OS analysis</a:t>
+            </a:r>
+            <a:endParaRPr lang="en-US" sz="800" dirty="0"/>
+          </a:p>
+        </p:txBody>
+      </p:sp>
+      <p:sp>
+        <p:nvSpPr>
+          <p:cNvPr id="22" name="Text 16"/>
+          <p:cNvSpPr/>
+          <p:nvPr/>
+        </p:nvSpPr>
+        <p:spPr>
+          <a:xfrm>
+            <a:off x="11292840" y="6419088"/>
+            <a:ext cx="365760" cy="274320"/>
+          </a:xfrm>
+          <a:prstGeom prst="rect">
+            <a:avLst/>
+          </a:prstGeom>
+          <a:noFill/>
+          <a:ln/>
+        </p:spPr>
+        <p:txBody>
+          <a:bodyPr wrap="square" lIns="0" tIns="0" rIns="0" bIns="0" rtlCol="0" anchor="ctr"/>
+          <a:lstStyle/>
+          <a:p>
+            <a:pPr algn="r" indent="0" marL="0">
+              <a:buNone/>
+            </a:pPr>
+            <a:r>
+              <a:rPr lang="en-US" sz="850" b="1" dirty="0">
+                <a:solidFill>
+                  <a:srgbClr val="1D5FCC"/>
+                </a:solidFill>
+                <a:latin typeface="Arial" pitchFamily="34" charset="0"/>
+                <a:ea typeface="Arial" pitchFamily="34" charset="-122"/>
+                <a:cs typeface="Arial" pitchFamily="34" charset="-120"/>
+              </a:rPr>
+              <a:t>27</a:t>
+            </a:r>
+            <a:endParaRPr lang="en-US" sz="850" dirty="0"/>
+          </a:p>
+        </p:txBody>
+      </p:sp>
+    </p:spTree>
+  </p:cSld>
+  <p:clrMapOvr>
+    <a:masterClrMapping/>
+  </p:clrMapOvr>
+</p:sld>
+</file>
+
+<file path=ppt/slides/slide32.xml><?xml version="1.0" encoding="utf-8"?>
+<p:sld xmlns:a="http://schemas.openxmlformats.org/drawingml/2006/main" xmlns:r="http://schemas.openxmlformats.org/officeDocument/2006/relationships" xmlns:p="http://schemas.openxmlformats.org/presentationml/2006/main">
+  <p:cSld name="Slide 32">
+    <p:bg>
+      <p:bgPr>
+        <a:solidFill>
+          <a:srgbClr val="FFFFFF"/>
+        </a:solidFill>
+      </p:bgPr>
+    </p:bg>
+    <p:spTree>
+      <p:nvGrpSpPr>
+        <p:cNvPr id="1" name=""/>
+        <p:cNvGrpSpPr/>
+        <p:nvPr/>
+      </p:nvGrpSpPr>
+      <p:grpSpPr>
+        <a:xfrm>
+          <a:off x="0" y="0"/>
+          <a:ext cx="0" cy="0"/>
+          <a:chOff x="0" y="0"/>
+          <a:chExt cx="0" cy="0"/>
+        </a:xfrm>
+      </p:grpSpPr>
+      <p:sp>
+        <p:nvSpPr>
+          <p:cNvPr id="2" name="Text 0"/>
+          <p:cNvSpPr/>
+          <p:nvPr/>
+        </p:nvSpPr>
+        <p:spPr>
+          <a:xfrm>
+            <a:off x="502920" y="310896"/>
+            <a:ext cx="11155680" cy="256032"/>
+          </a:xfrm>
+          <a:prstGeom prst="rect">
+            <a:avLst/>
+          </a:prstGeom>
+          <a:noFill/>
+          <a:ln/>
+        </p:spPr>
+        <p:txBody>
+          <a:bodyPr wrap="square" lIns="0" tIns="0" rIns="0" bIns="0" rtlCol="0" anchor="ctr"/>
+          <a:lstStyle/>
+          <a:p>
+            <a:pPr indent="0" marL="0">
+              <a:buNone/>
+            </a:pPr>
+            <a:r>
+              <a:rPr lang="en-US" sz="1050" b="1" spc="200" kern="0" dirty="0">
+                <a:solidFill>
+                  <a:srgbClr val="1D5FCC"/>
+                </a:solidFill>
+                <a:latin typeface="Arial" pitchFamily="34" charset="0"/>
+                <a:ea typeface="Arial" pitchFamily="34" charset="-122"/>
+                <a:cs typeface="Arial" pitchFamily="34" charset="-120"/>
+              </a:rPr>
+              <a:t>EXHIBITS — DELIVERY PRIMITIVES</a:t>
+            </a:r>
+            <a:endParaRPr lang="en-US" sz="1050" dirty="0"/>
+          </a:p>
+        </p:txBody>
+      </p:sp>
+      <p:sp>
+        <p:nvSpPr>
+          <p:cNvPr id="3" name="Text 1"/>
+          <p:cNvSpPr/>
+          <p:nvPr/>
+        </p:nvSpPr>
+        <p:spPr>
+          <a:xfrm>
+            <a:off x="502920" y="585216"/>
+            <a:ext cx="11155680" cy="822960"/>
+          </a:xfrm>
+          <a:prstGeom prst="rect">
+            <a:avLst/>
+          </a:prstGeom>
+          <a:noFill/>
+          <a:ln/>
+        </p:spPr>
+        <p:txBody>
+          <a:bodyPr wrap="square" lIns="0" tIns="0" rIns="0" bIns="0" rtlCol="0" anchor="t"/>
+          <a:lstStyle/>
+          <a:p>
+            <a:pPr indent="0" marL="0">
+              <a:lnSpc>
+                <a:spcPct val="102000"/>
+              </a:lnSpc>
+              <a:buNone/>
+            </a:pPr>
+            <a:r>
+              <a:rPr lang="en-US" sz="2100" b="1" dirty="0">
+                <a:solidFill>
+                  <a:srgbClr val="1A1A1A"/>
+                </a:solidFill>
+                <a:latin typeface="Arial" pitchFamily="34" charset="0"/>
+                <a:ea typeface="Arial" pitchFamily="34" charset="-122"/>
+                <a:cs typeface="Arial" pitchFamily="34" charset="-120"/>
+              </a:rPr>
+              <a:t>The integrated plan holds on wave 1; training is the only workstream behind the curve</a:t>
+            </a:r>
+            <a:endParaRPr lang="en-US" sz="2100" dirty="0"/>
+          </a:p>
+        </p:txBody>
+      </p:sp>
+      <p:sp>
+        <p:nvSpPr>
+          <p:cNvPr id="4" name="Shape 2"/>
+          <p:cNvSpPr/>
+          <p:nvPr/>
+        </p:nvSpPr>
+        <p:spPr>
+          <a:xfrm>
+            <a:off x="502920" y="1435608"/>
+            <a:ext cx="11155680" cy="25603"/>
+          </a:xfrm>
+          <a:prstGeom prst="rect">
+            <a:avLst/>
+          </a:prstGeom>
+          <a:solidFill>
+            <a:srgbClr val="2E7CF6"/>
+          </a:solidFill>
+          <a:ln/>
+        </p:spPr>
+      </p:sp>
+      <p:sp>
+        <p:nvSpPr>
+          <p:cNvPr id="5" name="Text 3"/>
+          <p:cNvSpPr/>
+          <p:nvPr/>
+        </p:nvSpPr>
+        <p:spPr>
+          <a:xfrm>
+            <a:off x="502920" y="1499616"/>
+            <a:ext cx="11155680" cy="384048"/>
+          </a:xfrm>
+          <a:prstGeom prst="rect">
+            <a:avLst/>
+          </a:prstGeom>
+          <a:noFill/>
+          <a:ln/>
+        </p:spPr>
+        <p:txBody>
+          <a:bodyPr wrap="square" lIns="0" tIns="0" rIns="0" bIns="0" rtlCol="0" anchor="t"/>
+          <a:lstStyle/>
+          <a:p>
+            <a:pPr indent="0" marL="0">
+              <a:buNone/>
+            </a:pPr>
+            <a:r>
+              <a:rPr lang="en-US" sz="1350" i="1" dirty="0">
+                <a:solidFill>
+                  <a:srgbClr val="595959"/>
+                </a:solidFill>
+                <a:latin typeface="Arial" pitchFamily="34" charset="0"/>
+                <a:ea typeface="Arial" pitchFamily="34" charset="-122"/>
+                <a:cs typeface="Arial" pitchFamily="34" charset="-120"/>
+              </a:rPr>
+              <a:t>Gantt (integrated plan), harvey balls (delivery confidence), progress bars and RAG dots.</a:t>
+            </a:r>
+            <a:endParaRPr lang="en-US" sz="1350" dirty="0"/>
+          </a:p>
+        </p:txBody>
+      </p:sp>
+      <p:sp>
+        <p:nvSpPr>
+          <p:cNvPr id="6" name="Text 4"/>
+          <p:cNvSpPr/>
+          <p:nvPr/>
+        </p:nvSpPr>
+        <p:spPr>
+          <a:xfrm>
+            <a:off x="502920" y="2039112"/>
+            <a:ext cx="6528816" cy="237744"/>
+          </a:xfrm>
+          <a:prstGeom prst="rect">
+            <a:avLst/>
+          </a:prstGeom>
+          <a:noFill/>
+          <a:ln/>
+        </p:spPr>
+        <p:txBody>
+          <a:bodyPr wrap="square" lIns="0" tIns="0" rIns="0" bIns="0" rtlCol="0" anchor="ctr"/>
+          <a:lstStyle/>
+          <a:p>
+            <a:pPr indent="0" marL="0">
+              <a:buNone/>
+            </a:pPr>
+            <a:r>
+              <a:rPr lang="en-US" sz="1000" b="1" dirty="0">
+                <a:solidFill>
+                  <a:srgbClr val="595959"/>
+                </a:solidFill>
+                <a:latin typeface="Arial" pitchFamily="34" charset="0"/>
+                <a:ea typeface="Arial" pitchFamily="34" charset="-122"/>
+                <a:cs typeface="Arial" pitchFamily="34" charset="-120"/>
+              </a:rPr>
+              <a:t>Integrated plan 2027, by workstream</a:t>
+            </a:r>
+            <a:endParaRPr lang="en-US" sz="1000" dirty="0"/>
+          </a:p>
+        </p:txBody>
+      </p:sp>
+      <p:sp>
+        <p:nvSpPr>
+          <p:cNvPr id="7" name="Text 5"/>
+          <p:cNvSpPr/>
+          <p:nvPr/>
+        </p:nvSpPr>
+        <p:spPr>
+          <a:xfrm>
+            <a:off x="2514600" y="2377440"/>
+            <a:ext cx="1060704" cy="237744"/>
+          </a:xfrm>
+          <a:prstGeom prst="rect">
+            <a:avLst/>
+          </a:prstGeom>
+          <a:noFill/>
+          <a:ln/>
+        </p:spPr>
+        <p:txBody>
+          <a:bodyPr wrap="square" lIns="0" tIns="0" rIns="0" bIns="0" rtlCol="0" anchor="ctr"/>
+          <a:lstStyle/>
+          <a:p>
+            <a:pPr algn="ctr" indent="0" marL="0">
+              <a:buNone/>
+            </a:pPr>
+            <a:r>
+              <a:rPr lang="en-US" sz="900" dirty="0">
+                <a:solidFill>
+                  <a:srgbClr val="8C8C8C"/>
+                </a:solidFill>
+                <a:latin typeface="Arial" pitchFamily="34" charset="0"/>
+                <a:ea typeface="Arial" pitchFamily="34" charset="-122"/>
+                <a:cs typeface="Arial" pitchFamily="34" charset="-120"/>
+              </a:rPr>
+              <a:t>Q1 2027</a:t>
+            </a:r>
+            <a:endParaRPr lang="en-US" sz="900" dirty="0"/>
+          </a:p>
+        </p:txBody>
+      </p:sp>
+      <p:sp>
+        <p:nvSpPr>
+          <p:cNvPr id="8" name="Text 6"/>
+          <p:cNvSpPr/>
+          <p:nvPr/>
+        </p:nvSpPr>
+        <p:spPr>
+          <a:xfrm>
+            <a:off x="3575304" y="2377440"/>
+            <a:ext cx="1060704" cy="237744"/>
+          </a:xfrm>
+          <a:prstGeom prst="rect">
+            <a:avLst/>
+          </a:prstGeom>
+          <a:noFill/>
+          <a:ln/>
+        </p:spPr>
+        <p:txBody>
+          <a:bodyPr wrap="square" lIns="0" tIns="0" rIns="0" bIns="0" rtlCol="0" anchor="ctr"/>
+          <a:lstStyle/>
+          <a:p>
+            <a:pPr algn="ctr" indent="0" marL="0">
+              <a:buNone/>
+            </a:pPr>
+            <a:r>
+              <a:rPr lang="en-US" sz="900" dirty="0">
+                <a:solidFill>
+                  <a:srgbClr val="8C8C8C"/>
+                </a:solidFill>
+                <a:latin typeface="Arial" pitchFamily="34" charset="0"/>
+                <a:ea typeface="Arial" pitchFamily="34" charset="-122"/>
+                <a:cs typeface="Arial" pitchFamily="34" charset="-120"/>
+              </a:rPr>
+              <a:t>Q2 2027</a:t>
+            </a:r>
+            <a:endParaRPr lang="en-US" sz="900" dirty="0"/>
+          </a:p>
+        </p:txBody>
+      </p:sp>
+      <p:sp>
+        <p:nvSpPr>
+          <p:cNvPr id="9" name="Text 7"/>
+          <p:cNvSpPr/>
+          <p:nvPr/>
+        </p:nvSpPr>
+        <p:spPr>
+          <a:xfrm>
+            <a:off x="4636008" y="2377440"/>
+            <a:ext cx="1060704" cy="237744"/>
+          </a:xfrm>
+          <a:prstGeom prst="rect">
+            <a:avLst/>
+          </a:prstGeom>
+          <a:noFill/>
+          <a:ln/>
+        </p:spPr>
+        <p:txBody>
+          <a:bodyPr wrap="square" lIns="0" tIns="0" rIns="0" bIns="0" rtlCol="0" anchor="ctr"/>
+          <a:lstStyle/>
+          <a:p>
+            <a:pPr algn="ctr" indent="0" marL="0">
+              <a:buNone/>
+            </a:pPr>
+            <a:r>
+              <a:rPr lang="en-US" sz="900" dirty="0">
+                <a:solidFill>
+                  <a:srgbClr val="8C8C8C"/>
+                </a:solidFill>
+                <a:latin typeface="Arial" pitchFamily="34" charset="0"/>
+                <a:ea typeface="Arial" pitchFamily="34" charset="-122"/>
+                <a:cs typeface="Arial" pitchFamily="34" charset="-120"/>
+              </a:rPr>
+              <a:t>Q3 2027</a:t>
+            </a:r>
+            <a:endParaRPr lang="en-US" sz="900" dirty="0"/>
+          </a:p>
+        </p:txBody>
+      </p:sp>
+      <p:sp>
+        <p:nvSpPr>
+          <p:cNvPr id="10" name="Text 8"/>
+          <p:cNvSpPr/>
+          <p:nvPr/>
+        </p:nvSpPr>
+        <p:spPr>
+          <a:xfrm>
+            <a:off x="5696712" y="2377440"/>
+            <a:ext cx="1060704" cy="237744"/>
+          </a:xfrm>
+          <a:prstGeom prst="rect">
+            <a:avLst/>
+          </a:prstGeom>
+          <a:noFill/>
+          <a:ln/>
+        </p:spPr>
+        <p:txBody>
+          <a:bodyPr wrap="square" lIns="0" tIns="0" rIns="0" bIns="0" rtlCol="0" anchor="ctr"/>
+          <a:lstStyle/>
+          <a:p>
+            <a:pPr algn="ctr" indent="0" marL="0">
+              <a:buNone/>
+            </a:pPr>
+            <a:r>
+              <a:rPr lang="en-US" sz="900" dirty="0">
+                <a:solidFill>
+                  <a:srgbClr val="8C8C8C"/>
+                </a:solidFill>
+                <a:latin typeface="Arial" pitchFamily="34" charset="0"/>
+                <a:ea typeface="Arial" pitchFamily="34" charset="-122"/>
+                <a:cs typeface="Arial" pitchFamily="34" charset="-120"/>
+              </a:rPr>
+              <a:t>Q4 2027</a:t>
+            </a:r>
+            <a:endParaRPr lang="en-US" sz="900" dirty="0"/>
+          </a:p>
+        </p:txBody>
+      </p:sp>
+      <p:sp>
+        <p:nvSpPr>
+          <p:cNvPr id="11" name="Text 9"/>
+          <p:cNvSpPr/>
+          <p:nvPr/>
+        </p:nvSpPr>
+        <p:spPr>
+          <a:xfrm>
+            <a:off x="502920" y="2651760"/>
+            <a:ext cx="1920240" cy="442570"/>
+          </a:xfrm>
+          <a:prstGeom prst="rect">
+            <a:avLst/>
+          </a:prstGeom>
+          <a:noFill/>
+          <a:ln/>
+        </p:spPr>
+        <p:txBody>
+          <a:bodyPr wrap="square" lIns="0" tIns="0" rIns="0" bIns="0" rtlCol="0" anchor="ctr"/>
+          <a:lstStyle/>
+          <a:p>
+            <a:pPr indent="0" marL="0">
+              <a:buNone/>
+            </a:pPr>
+            <a:r>
+              <a:rPr lang="en-US" sz="1000" dirty="0">
+                <a:solidFill>
+                  <a:srgbClr val="1A1A1A"/>
+                </a:solidFill>
+                <a:latin typeface="Arial" pitchFamily="34" charset="0"/>
+                <a:ea typeface="Arial" pitchFamily="34" charset="-122"/>
+                <a:cs typeface="Arial" pitchFamily="34" charset="-120"/>
+              </a:rPr>
+              <a:t>M&amp;A &amp; integration</a:t>
+            </a:r>
+            <a:endParaRPr lang="en-US" sz="1000" dirty="0"/>
+          </a:p>
+        </p:txBody>
+      </p:sp>
+      <p:sp>
+        <p:nvSpPr>
+          <p:cNvPr id="12" name="Shape 10"/>
+          <p:cNvSpPr/>
+          <p:nvPr/>
+        </p:nvSpPr>
+        <p:spPr>
+          <a:xfrm>
+            <a:off x="2514600" y="3094330"/>
+            <a:ext cx="4242816" cy="0"/>
+          </a:xfrm>
+          <a:prstGeom prst="line">
+            <a:avLst/>
+          </a:prstGeom>
+          <a:noFill/>
+          <a:ln w="6350">
+            <a:solidFill>
+              <a:srgbClr val="EEEEEE"/>
+            </a:solidFill>
+            <a:prstDash val="solid"/>
+          </a:ln>
+        </p:spPr>
+      </p:sp>
+      <p:sp>
+        <p:nvSpPr>
+          <p:cNvPr id="13" name="Shape 11"/>
+          <p:cNvSpPr/>
+          <p:nvPr/>
+        </p:nvSpPr>
+        <p:spPr>
+          <a:xfrm>
+            <a:off x="2551176" y="2757977"/>
+            <a:ext cx="2048256" cy="230136"/>
+          </a:xfrm>
+          <a:prstGeom prst="roundRect">
+            <a:avLst>
+              <a:gd name="adj" fmla="val 15893"/>
+            </a:avLst>
+          </a:prstGeom>
+          <a:solidFill>
+            <a:srgbClr val="2E7CF6"/>
+          </a:solidFill>
+          <a:ln/>
+        </p:spPr>
+      </p:sp>
+      <p:sp>
+        <p:nvSpPr>
+          <p:cNvPr id="14" name="Text 12"/>
+          <p:cNvSpPr/>
+          <p:nvPr/>
+        </p:nvSpPr>
+        <p:spPr>
+          <a:xfrm>
+            <a:off x="502920" y="3094330"/>
+            <a:ext cx="1920240" cy="442570"/>
+          </a:xfrm>
+          <a:prstGeom prst="rect">
+            <a:avLst/>
+          </a:prstGeom>
+          <a:noFill/>
+          <a:ln/>
+        </p:spPr>
+        <p:txBody>
+          <a:bodyPr wrap="square" lIns="0" tIns="0" rIns="0" bIns="0" rtlCol="0" anchor="ctr"/>
+          <a:lstStyle/>
+          <a:p>
+            <a:pPr indent="0" marL="0">
+              <a:buNone/>
+            </a:pPr>
+            <a:r>
+              <a:rPr lang="en-US" sz="1000" dirty="0">
+                <a:solidFill>
+                  <a:srgbClr val="1A1A1A"/>
+                </a:solidFill>
+                <a:latin typeface="Arial" pitchFamily="34" charset="0"/>
+                <a:ea typeface="Arial" pitchFamily="34" charset="-122"/>
+                <a:cs typeface="Arial" pitchFamily="34" charset="-120"/>
+              </a:rPr>
+              <a:t>North pilot</a:t>
+            </a:r>
+            <a:endParaRPr lang="en-US" sz="1000" dirty="0"/>
+          </a:p>
+        </p:txBody>
+      </p:sp>
+      <p:sp>
+        <p:nvSpPr>
+          <p:cNvPr id="15" name="Shape 13"/>
+          <p:cNvSpPr/>
+          <p:nvPr/>
+        </p:nvSpPr>
+        <p:spPr>
+          <a:xfrm>
+            <a:off x="2514600" y="3536899"/>
+            <a:ext cx="4242816" cy="0"/>
+          </a:xfrm>
+          <a:prstGeom prst="line">
+            <a:avLst/>
+          </a:prstGeom>
+          <a:noFill/>
+          <a:ln w="6350">
+            <a:solidFill>
+              <a:srgbClr val="EEEEEE"/>
+            </a:solidFill>
+            <a:prstDash val="solid"/>
+          </a:ln>
+        </p:spPr>
+      </p:sp>
+      <p:sp>
+        <p:nvSpPr>
+          <p:cNvPr id="16" name="Shape 14"/>
+          <p:cNvSpPr/>
+          <p:nvPr/>
+        </p:nvSpPr>
+        <p:spPr>
+          <a:xfrm>
+            <a:off x="3081528" y="3200546"/>
+            <a:ext cx="1517904" cy="230136"/>
+          </a:xfrm>
+          <a:prstGeom prst="roundRect">
+            <a:avLst>
+              <a:gd name="adj" fmla="val 15893"/>
+            </a:avLst>
+          </a:prstGeom>
+          <a:solidFill>
+            <a:srgbClr val="2E7CF6"/>
+          </a:solidFill>
+          <a:ln/>
+        </p:spPr>
+      </p:sp>
+      <p:sp>
+        <p:nvSpPr>
+          <p:cNvPr id="17" name="Text 15"/>
+          <p:cNvSpPr/>
+          <p:nvPr/>
+        </p:nvSpPr>
+        <p:spPr>
+          <a:xfrm>
+            <a:off x="502920" y="3536899"/>
+            <a:ext cx="1920240" cy="442570"/>
+          </a:xfrm>
+          <a:prstGeom prst="rect">
+            <a:avLst/>
+          </a:prstGeom>
+          <a:noFill/>
+          <a:ln/>
+        </p:spPr>
+        <p:txBody>
+          <a:bodyPr wrap="square" lIns="0" tIns="0" rIns="0" bIns="0" rtlCol="0" anchor="ctr"/>
+          <a:lstStyle/>
+          <a:p>
+            <a:pPr indent="0" marL="0">
+              <a:buNone/>
+            </a:pPr>
+            <a:r>
+              <a:rPr lang="en-US" sz="1000" dirty="0">
+                <a:solidFill>
+                  <a:srgbClr val="1A1A1A"/>
+                </a:solidFill>
+                <a:latin typeface="Arial" pitchFamily="34" charset="0"/>
+                <a:ea typeface="Arial" pitchFamily="34" charset="-122"/>
+                <a:cs typeface="Arial" pitchFamily="34" charset="-120"/>
+              </a:rPr>
+              <a:t>Platform migration</a:t>
+            </a:r>
+            <a:endParaRPr lang="en-US" sz="1000" dirty="0"/>
+          </a:p>
+        </p:txBody>
+      </p:sp>
+      <p:sp>
+        <p:nvSpPr>
+          <p:cNvPr id="18" name="Shape 16"/>
+          <p:cNvSpPr/>
+          <p:nvPr/>
+        </p:nvSpPr>
+        <p:spPr>
+          <a:xfrm>
+            <a:off x="2514600" y="3979469"/>
+            <a:ext cx="4242816" cy="0"/>
+          </a:xfrm>
+          <a:prstGeom prst="line">
+            <a:avLst/>
+          </a:prstGeom>
+          <a:noFill/>
+          <a:ln w="6350">
+            <a:solidFill>
+              <a:srgbClr val="EEEEEE"/>
+            </a:solidFill>
+            <a:prstDash val="solid"/>
+          </a:ln>
+        </p:spPr>
+      </p:sp>
+      <p:sp>
+        <p:nvSpPr>
+          <p:cNvPr id="19" name="Shape 17"/>
+          <p:cNvSpPr/>
+          <p:nvPr/>
+        </p:nvSpPr>
+        <p:spPr>
+          <a:xfrm>
+            <a:off x="3611880" y="3643116"/>
+            <a:ext cx="2578608" cy="230136"/>
+          </a:xfrm>
+          <a:prstGeom prst="roundRect">
+            <a:avLst>
+              <a:gd name="adj" fmla="val 15893"/>
+            </a:avLst>
+          </a:prstGeom>
+          <a:solidFill>
+            <a:srgbClr val="2E7CF6"/>
+          </a:solidFill>
+          <a:ln/>
+        </p:spPr>
+      </p:sp>
+      <p:sp>
+        <p:nvSpPr>
+          <p:cNvPr id="20" name="Text 18"/>
+          <p:cNvSpPr/>
+          <p:nvPr/>
+        </p:nvSpPr>
+        <p:spPr>
+          <a:xfrm>
+            <a:off x="502920" y="3979469"/>
+            <a:ext cx="1920240" cy="442570"/>
+          </a:xfrm>
+          <a:prstGeom prst="rect">
+            <a:avLst/>
+          </a:prstGeom>
+          <a:noFill/>
+          <a:ln/>
+        </p:spPr>
+        <p:txBody>
+          <a:bodyPr wrap="square" lIns="0" tIns="0" rIns="0" bIns="0" rtlCol="0" anchor="ctr"/>
+          <a:lstStyle/>
+          <a:p>
+            <a:pPr indent="0" marL="0">
+              <a:buNone/>
+            </a:pPr>
+            <a:r>
+              <a:rPr lang="en-US" sz="1000" dirty="0">
+                <a:solidFill>
+                  <a:srgbClr val="1A1A1A"/>
+                </a:solidFill>
+                <a:latin typeface="Arial" pitchFamily="34" charset="0"/>
+                <a:ea typeface="Arial" pitchFamily="34" charset="-122"/>
+                <a:cs typeface="Arial" pitchFamily="34" charset="-120"/>
+              </a:rPr>
+              <a:t>Training waves</a:t>
+            </a:r>
+            <a:endParaRPr lang="en-US" sz="1000" dirty="0"/>
+          </a:p>
+        </p:txBody>
+      </p:sp>
+      <p:sp>
+        <p:nvSpPr>
+          <p:cNvPr id="21" name="Shape 19"/>
+          <p:cNvSpPr/>
+          <p:nvPr/>
+        </p:nvSpPr>
+        <p:spPr>
+          <a:xfrm>
+            <a:off x="2514600" y="4422038"/>
+            <a:ext cx="4242816" cy="0"/>
+          </a:xfrm>
+          <a:prstGeom prst="line">
+            <a:avLst/>
+          </a:prstGeom>
+          <a:noFill/>
+          <a:ln w="6350">
+            <a:solidFill>
+              <a:srgbClr val="EEEEEE"/>
+            </a:solidFill>
+            <a:prstDash val="solid"/>
+          </a:ln>
+        </p:spPr>
+      </p:sp>
+      <p:sp>
+        <p:nvSpPr>
+          <p:cNvPr id="22" name="Shape 20"/>
+          <p:cNvSpPr/>
+          <p:nvPr/>
+        </p:nvSpPr>
+        <p:spPr>
+          <a:xfrm>
+            <a:off x="4142232" y="4085686"/>
+            <a:ext cx="2578608" cy="230136"/>
+          </a:xfrm>
+          <a:prstGeom prst="roundRect">
+            <a:avLst>
+              <a:gd name="adj" fmla="val 15893"/>
+            </a:avLst>
+          </a:prstGeom>
+          <a:solidFill>
+            <a:srgbClr val="2E7CF6"/>
+          </a:solidFill>
+          <a:ln/>
+        </p:spPr>
+      </p:sp>
+      <p:sp>
+        <p:nvSpPr>
+          <p:cNvPr id="23" name="Text 21"/>
+          <p:cNvSpPr/>
+          <p:nvPr/>
+        </p:nvSpPr>
+        <p:spPr>
+          <a:xfrm>
+            <a:off x="502920" y="4422038"/>
+            <a:ext cx="1920240" cy="442570"/>
+          </a:xfrm>
+          <a:prstGeom prst="rect">
+            <a:avLst/>
+          </a:prstGeom>
+          <a:noFill/>
+          <a:ln/>
+        </p:spPr>
+        <p:txBody>
+          <a:bodyPr wrap="square" lIns="0" tIns="0" rIns="0" bIns="0" rtlCol="0" anchor="ctr"/>
+          <a:lstStyle/>
+          <a:p>
+            <a:pPr indent="0" marL="0">
+              <a:buNone/>
+            </a:pPr>
+            <a:r>
+              <a:rPr lang="en-US" sz="1000" dirty="0">
+                <a:solidFill>
+                  <a:srgbClr val="1A1A1A"/>
+                </a:solidFill>
+                <a:latin typeface="Arial" pitchFamily="34" charset="0"/>
+                <a:ea typeface="Arial" pitchFamily="34" charset="-122"/>
+                <a:cs typeface="Arial" pitchFamily="34" charset="-120"/>
+              </a:rPr>
+              <a:t>Regional roll-out</a:t>
+            </a:r>
+            <a:endParaRPr lang="en-US" sz="1000" dirty="0"/>
+          </a:p>
+        </p:txBody>
+      </p:sp>
+      <p:sp>
+        <p:nvSpPr>
+          <p:cNvPr id="24" name="Shape 22"/>
+          <p:cNvSpPr/>
+          <p:nvPr/>
+        </p:nvSpPr>
+        <p:spPr>
+          <a:xfrm>
+            <a:off x="2514600" y="4864608"/>
+            <a:ext cx="4242816" cy="0"/>
+          </a:xfrm>
+          <a:prstGeom prst="line">
+            <a:avLst/>
+          </a:prstGeom>
+          <a:noFill/>
+          <a:ln w="6350">
+            <a:solidFill>
+              <a:srgbClr val="EEEEEE"/>
+            </a:solidFill>
+            <a:prstDash val="solid"/>
+          </a:ln>
+        </p:spPr>
+      </p:sp>
+      <p:sp>
+        <p:nvSpPr>
+          <p:cNvPr id="25" name="Shape 23"/>
+          <p:cNvSpPr/>
+          <p:nvPr/>
+        </p:nvSpPr>
+        <p:spPr>
+          <a:xfrm>
+            <a:off x="5202936" y="4528255"/>
+            <a:ext cx="1517904" cy="230136"/>
+          </a:xfrm>
+          <a:prstGeom prst="roundRect">
+            <a:avLst>
+              <a:gd name="adj" fmla="val 15893"/>
+            </a:avLst>
+          </a:prstGeom>
+          <a:solidFill>
+            <a:srgbClr val="2E7CF6"/>
+          </a:solidFill>
+          <a:ln/>
+        </p:spPr>
+      </p:sp>
+      <p:sp>
+        <p:nvSpPr>
+          <p:cNvPr id="26" name="Shape 24"/>
+          <p:cNvSpPr/>
+          <p:nvPr/>
+        </p:nvSpPr>
+        <p:spPr>
+          <a:xfrm>
+            <a:off x="4562856" y="4919472"/>
+            <a:ext cx="146304" cy="146304"/>
+          </a:xfrm>
+          <a:prstGeom prst="diamond">
+            <a:avLst/>
+          </a:prstGeom>
+          <a:solidFill>
+            <a:srgbClr val="1D5FCC"/>
+          </a:solidFill>
+          <a:ln/>
+        </p:spPr>
+      </p:sp>
+      <p:sp>
+        <p:nvSpPr>
+          <p:cNvPr id="27" name="Text 25"/>
+          <p:cNvSpPr/>
+          <p:nvPr/>
+        </p:nvSpPr>
+        <p:spPr>
+          <a:xfrm>
+            <a:off x="4087368" y="5084064"/>
+            <a:ext cx="1097280" cy="274320"/>
+          </a:xfrm>
+          <a:prstGeom prst="rect">
+            <a:avLst/>
+          </a:prstGeom>
+          <a:noFill/>
+          <a:ln/>
+        </p:spPr>
+        <p:txBody>
+          <a:bodyPr wrap="square" lIns="0" tIns="0" rIns="0" bIns="0" rtlCol="0" anchor="ctr"/>
+          <a:lstStyle/>
+          <a:p>
+            <a:pPr algn="ctr" indent="0" marL="0">
+              <a:buNone/>
+            </a:pPr>
+            <a:r>
+              <a:rPr lang="en-US" sz="800" dirty="0">
+                <a:solidFill>
+                  <a:srgbClr val="595959"/>
+                </a:solidFill>
+                <a:latin typeface="Arial" pitchFamily="34" charset="0"/>
+                <a:ea typeface="Arial" pitchFamily="34" charset="-122"/>
+                <a:cs typeface="Arial" pitchFamily="34" charset="-120"/>
+              </a:rPr>
+              <a:t>Go/no-go</a:t>
+            </a:r>
+            <a:endParaRPr lang="en-US" sz="800" dirty="0"/>
+          </a:p>
+        </p:txBody>
+      </p:sp>
+      <p:sp>
+        <p:nvSpPr>
+          <p:cNvPr id="28" name="Shape 26"/>
+          <p:cNvSpPr/>
+          <p:nvPr/>
+        </p:nvSpPr>
+        <p:spPr>
+          <a:xfrm>
+            <a:off x="6047842" y="4919472"/>
+            <a:ext cx="146304" cy="146304"/>
+          </a:xfrm>
+          <a:prstGeom prst="diamond">
+            <a:avLst/>
+          </a:prstGeom>
+          <a:solidFill>
+            <a:srgbClr val="1D5FCC"/>
+          </a:solidFill>
+          <a:ln/>
+        </p:spPr>
+      </p:sp>
+      <p:sp>
+        <p:nvSpPr>
+          <p:cNvPr id="29" name="Text 27"/>
+          <p:cNvSpPr/>
+          <p:nvPr/>
+        </p:nvSpPr>
+        <p:spPr>
+          <a:xfrm>
+            <a:off x="5572354" y="5084064"/>
+            <a:ext cx="1097280" cy="274320"/>
+          </a:xfrm>
+          <a:prstGeom prst="rect">
+            <a:avLst/>
+          </a:prstGeom>
+          <a:noFill/>
+          <a:ln/>
+        </p:spPr>
+        <p:txBody>
+          <a:bodyPr wrap="square" lIns="0" tIns="0" rIns="0" bIns="0" rtlCol="0" anchor="ctr"/>
+          <a:lstStyle/>
+          <a:p>
+            <a:pPr algn="ctr" indent="0" marL="0">
+              <a:buNone/>
+            </a:pPr>
+            <a:r>
+              <a:rPr lang="en-US" sz="800" dirty="0">
+                <a:solidFill>
+                  <a:srgbClr val="595959"/>
+                </a:solidFill>
+                <a:latin typeface="Arial" pitchFamily="34" charset="0"/>
+                <a:ea typeface="Arial" pitchFamily="34" charset="-122"/>
+                <a:cs typeface="Arial" pitchFamily="34" charset="-120"/>
+              </a:rPr>
+              <a:t>Wave 2</a:t>
+            </a:r>
+            <a:endParaRPr lang="en-US" sz="800" dirty="0"/>
+          </a:p>
+        </p:txBody>
+      </p:sp>
+      <p:sp>
+        <p:nvSpPr>
+          <p:cNvPr id="30" name="Text 28"/>
+          <p:cNvSpPr/>
+          <p:nvPr/>
+        </p:nvSpPr>
+        <p:spPr>
+          <a:xfrm>
+            <a:off x="7306056" y="2039112"/>
+            <a:ext cx="4352544" cy="237744"/>
+          </a:xfrm>
+          <a:prstGeom prst="rect">
+            <a:avLst/>
+          </a:prstGeom>
+          <a:noFill/>
+          <a:ln/>
+        </p:spPr>
+        <p:txBody>
+          <a:bodyPr wrap="square" lIns="0" tIns="0" rIns="0" bIns="0" rtlCol="0" anchor="ctr"/>
+          <a:lstStyle/>
+          <a:p>
+            <a:pPr indent="0" marL="0">
+              <a:buNone/>
+            </a:pPr>
+            <a:r>
+              <a:rPr lang="en-US" sz="1000" b="1" dirty="0">
+                <a:solidFill>
+                  <a:srgbClr val="595959"/>
+                </a:solidFill>
+                <a:latin typeface="Arial" pitchFamily="34" charset="0"/>
+                <a:ea typeface="Arial" pitchFamily="34" charset="-122"/>
+                <a:cs typeface="Arial" pitchFamily="34" charset="-120"/>
+              </a:rPr>
+              <a:t>Workstream health, W28</a:t>
+            </a:r>
+            <a:endParaRPr lang="en-US" sz="1000" dirty="0"/>
+          </a:p>
+        </p:txBody>
+      </p:sp>
+      <p:sp>
+        <p:nvSpPr>
+          <p:cNvPr id="31" name="Shape 29"/>
+          <p:cNvSpPr/>
+          <p:nvPr/>
+        </p:nvSpPr>
+        <p:spPr>
+          <a:xfrm>
+            <a:off x="7306056" y="2542032"/>
+            <a:ext cx="164592" cy="164592"/>
+          </a:xfrm>
+          <a:prstGeom prst="ellipse">
+            <a:avLst/>
+          </a:prstGeom>
+          <a:solidFill>
+            <a:srgbClr val="2E7D32"/>
+          </a:solidFill>
+          <a:ln/>
+        </p:spPr>
+      </p:sp>
+      <p:sp>
+        <p:nvSpPr>
+          <p:cNvPr id="32" name="Text 30"/>
+          <p:cNvSpPr/>
+          <p:nvPr/>
+        </p:nvSpPr>
+        <p:spPr>
+          <a:xfrm>
+            <a:off x="7580376" y="2478024"/>
+            <a:ext cx="3346704" cy="274320"/>
+          </a:xfrm>
+          <a:prstGeom prst="rect">
+            <a:avLst/>
+          </a:prstGeom>
+          <a:noFill/>
+          <a:ln/>
+        </p:spPr>
+        <p:txBody>
+          <a:bodyPr wrap="square" lIns="0" tIns="0" rIns="0" bIns="0" rtlCol="0" anchor="ctr"/>
+          <a:lstStyle/>
+          <a:p>
+            <a:pPr indent="0" marL="0">
+              <a:buNone/>
+            </a:pPr>
+            <a:r>
+              <a:rPr lang="en-US" sz="1150" b="1" dirty="0">
+                <a:solidFill>
+                  <a:srgbClr val="1A1A1A"/>
+                </a:solidFill>
+                <a:latin typeface="Arial" pitchFamily="34" charset="0"/>
+                <a:ea typeface="Arial" pitchFamily="34" charset="-122"/>
+                <a:cs typeface="Arial" pitchFamily="34" charset="-120"/>
+              </a:rPr>
+              <a:t>M&amp;A &amp; integration</a:t>
+            </a:r>
+            <a:endParaRPr lang="en-US" sz="1150" dirty="0"/>
+          </a:p>
+        </p:txBody>
+      </p:sp>
+      <p:sp>
+        <p:nvSpPr>
+          <p:cNvPr id="33" name="Shape 31"/>
+          <p:cNvSpPr/>
+          <p:nvPr/>
+        </p:nvSpPr>
+        <p:spPr>
+          <a:xfrm>
+            <a:off x="11365992" y="2514600"/>
+            <a:ext cx="201168" cy="201168"/>
+          </a:xfrm>
+          <a:prstGeom prst="pie">
+            <a:avLst>
+              <a:gd name="adj1" fmla="val 16200000"/>
+              <a:gd name="adj2" fmla="val 10800000"/>
+            </a:avLst>
+          </a:prstGeom>
+          <a:solidFill>
+            <a:srgbClr val="1D5FCC"/>
+          </a:solidFill>
+          <a:ln w="6350">
+            <a:solidFill>
+              <a:srgbClr val="1D5FCC"/>
+            </a:solidFill>
+            <a:prstDash val="solid"/>
+          </a:ln>
+        </p:spPr>
+      </p:sp>
+      <p:sp>
+        <p:nvSpPr>
+          <p:cNvPr id="34" name="Shape 32"/>
+          <p:cNvSpPr/>
+          <p:nvPr/>
+        </p:nvSpPr>
+        <p:spPr>
+          <a:xfrm>
+            <a:off x="11365992" y="2514600"/>
+            <a:ext cx="201168" cy="201168"/>
+          </a:xfrm>
+          <a:prstGeom prst="ellipse">
+            <a:avLst/>
+          </a:prstGeom>
+          <a:ln w="12700">
+            <a:solidFill>
+              <a:srgbClr val="1D5FCC"/>
+            </a:solidFill>
+            <a:prstDash val="solid"/>
+          </a:ln>
+        </p:spPr>
+      </p:sp>
+      <p:sp>
+        <p:nvSpPr>
+          <p:cNvPr id="35" name="Shape 33"/>
+          <p:cNvSpPr/>
+          <p:nvPr/>
+        </p:nvSpPr>
+        <p:spPr>
+          <a:xfrm>
+            <a:off x="7580376" y="2807208"/>
+            <a:ext cx="3026664" cy="128016"/>
+          </a:xfrm>
+          <a:prstGeom prst="rect">
+            <a:avLst/>
+          </a:prstGeom>
+          <a:solidFill>
+            <a:srgbClr val="E8E8E8"/>
+          </a:solidFill>
+          <a:ln/>
+        </p:spPr>
+      </p:sp>
+      <p:sp>
+        <p:nvSpPr>
+          <p:cNvPr id="36" name="Shape 34"/>
+          <p:cNvSpPr/>
+          <p:nvPr/>
+        </p:nvSpPr>
+        <p:spPr>
+          <a:xfrm>
+            <a:off x="7580376" y="2807208"/>
+            <a:ext cx="2179198" cy="128016"/>
+          </a:xfrm>
+          <a:prstGeom prst="rect">
+            <a:avLst/>
+          </a:prstGeom>
+          <a:solidFill>
+            <a:srgbClr val="2E7CF6"/>
+          </a:solidFill>
+          <a:ln/>
+        </p:spPr>
+      </p:sp>
+      <p:sp>
+        <p:nvSpPr>
+          <p:cNvPr id="37" name="Text 35"/>
+          <p:cNvSpPr/>
+          <p:nvPr/>
+        </p:nvSpPr>
+        <p:spPr>
+          <a:xfrm>
+            <a:off x="10680192" y="2743200"/>
+            <a:ext cx="731520" cy="256032"/>
+          </a:xfrm>
+          <a:prstGeom prst="rect">
+            <a:avLst/>
+          </a:prstGeom>
+          <a:noFill/>
+          <a:ln/>
+        </p:spPr>
+        <p:txBody>
+          <a:bodyPr wrap="square" lIns="0" tIns="0" rIns="0" bIns="0" rtlCol="0" anchor="ctr"/>
+          <a:lstStyle/>
+          <a:p>
+            <a:pPr indent="0" marL="0">
+              <a:buNone/>
+            </a:pPr>
+            <a:r>
+              <a:rPr lang="en-US" sz="900" b="1" dirty="0">
+                <a:solidFill>
+                  <a:srgbClr val="1A1A1A"/>
+                </a:solidFill>
+                <a:latin typeface="Arial" pitchFamily="34" charset="0"/>
+                <a:ea typeface="Arial" pitchFamily="34" charset="-122"/>
+                <a:cs typeface="Arial" pitchFamily="34" charset="-120"/>
+              </a:rPr>
+              <a:t>72%</a:t>
+            </a:r>
+            <a:endParaRPr lang="en-US" sz="900" dirty="0"/>
+          </a:p>
+        </p:txBody>
+      </p:sp>
+      <p:sp>
+        <p:nvSpPr>
+          <p:cNvPr id="38" name="Shape 36"/>
+          <p:cNvSpPr/>
+          <p:nvPr/>
+        </p:nvSpPr>
+        <p:spPr>
+          <a:xfrm>
+            <a:off x="7306056" y="3255264"/>
+            <a:ext cx="164592" cy="164592"/>
+          </a:xfrm>
+          <a:prstGeom prst="ellipse">
+            <a:avLst/>
+          </a:prstGeom>
+          <a:solidFill>
+            <a:srgbClr val="2E7D32"/>
+          </a:solidFill>
+          <a:ln/>
+        </p:spPr>
+      </p:sp>
+      <p:sp>
+        <p:nvSpPr>
+          <p:cNvPr id="39" name="Text 37"/>
+          <p:cNvSpPr/>
+          <p:nvPr/>
+        </p:nvSpPr>
+        <p:spPr>
+          <a:xfrm>
+            <a:off x="7580376" y="3191256"/>
+            <a:ext cx="3346704" cy="274320"/>
+          </a:xfrm>
+          <a:prstGeom prst="rect">
+            <a:avLst/>
+          </a:prstGeom>
+          <a:noFill/>
+          <a:ln/>
+        </p:spPr>
+        <p:txBody>
+          <a:bodyPr wrap="square" lIns="0" tIns="0" rIns="0" bIns="0" rtlCol="0" anchor="ctr"/>
+          <a:lstStyle/>
+          <a:p>
+            <a:pPr indent="0" marL="0">
+              <a:buNone/>
+            </a:pPr>
+            <a:r>
+              <a:rPr lang="en-US" sz="1150" b="1" dirty="0">
+                <a:solidFill>
+                  <a:srgbClr val="1A1A1A"/>
+                </a:solidFill>
+                <a:latin typeface="Arial" pitchFamily="34" charset="0"/>
+                <a:ea typeface="Arial" pitchFamily="34" charset="-122"/>
+                <a:cs typeface="Arial" pitchFamily="34" charset="-120"/>
+              </a:rPr>
+              <a:t>North pilot</a:t>
+            </a:r>
+            <a:endParaRPr lang="en-US" sz="1150" dirty="0"/>
+          </a:p>
+        </p:txBody>
+      </p:sp>
+      <p:sp>
+        <p:nvSpPr>
+          <p:cNvPr id="40" name="Shape 38"/>
+          <p:cNvSpPr/>
+          <p:nvPr/>
+        </p:nvSpPr>
+        <p:spPr>
+          <a:xfrm>
+            <a:off x="11365992" y="3227832"/>
+            <a:ext cx="201168" cy="201168"/>
+          </a:xfrm>
+          <a:prstGeom prst="ellipse">
+            <a:avLst/>
+          </a:prstGeom>
+          <a:solidFill>
+            <a:srgbClr val="1D5FCC"/>
+          </a:solidFill>
+          <a:ln w="12700">
+            <a:solidFill>
+              <a:srgbClr val="1D5FCC"/>
+            </a:solidFill>
+            <a:prstDash val="solid"/>
+          </a:ln>
+        </p:spPr>
+      </p:sp>
+      <p:sp>
+        <p:nvSpPr>
+          <p:cNvPr id="41" name="Shape 39"/>
+          <p:cNvSpPr/>
+          <p:nvPr/>
+        </p:nvSpPr>
+        <p:spPr>
+          <a:xfrm>
+            <a:off x="7580376" y="3520440"/>
+            <a:ext cx="3026664" cy="128016"/>
+          </a:xfrm>
+          <a:prstGeom prst="rect">
+            <a:avLst/>
+          </a:prstGeom>
+          <a:solidFill>
+            <a:srgbClr val="E8E8E8"/>
+          </a:solidFill>
+          <a:ln/>
+        </p:spPr>
+      </p:sp>
+      <p:sp>
+        <p:nvSpPr>
+          <p:cNvPr id="42" name="Shape 40"/>
+          <p:cNvSpPr/>
+          <p:nvPr/>
+        </p:nvSpPr>
+        <p:spPr>
+          <a:xfrm>
+            <a:off x="7580376" y="3520440"/>
+            <a:ext cx="2663464" cy="128016"/>
+          </a:xfrm>
+          <a:prstGeom prst="rect">
+            <a:avLst/>
+          </a:prstGeom>
+          <a:solidFill>
+            <a:srgbClr val="2E7CF6"/>
+          </a:solidFill>
+          <a:ln/>
+        </p:spPr>
+      </p:sp>
+      <p:sp>
+        <p:nvSpPr>
+          <p:cNvPr id="43" name="Text 41"/>
+          <p:cNvSpPr/>
+          <p:nvPr/>
+        </p:nvSpPr>
+        <p:spPr>
+          <a:xfrm>
+            <a:off x="10680192" y="3456432"/>
+            <a:ext cx="731520" cy="256032"/>
+          </a:xfrm>
+          <a:prstGeom prst="rect">
+            <a:avLst/>
+          </a:prstGeom>
+          <a:noFill/>
+          <a:ln/>
+        </p:spPr>
+        <p:txBody>
+          <a:bodyPr wrap="square" lIns="0" tIns="0" rIns="0" bIns="0" rtlCol="0" anchor="ctr"/>
+          <a:lstStyle/>
+          <a:p>
+            <a:pPr indent="0" marL="0">
+              <a:buNone/>
+            </a:pPr>
+            <a:r>
+              <a:rPr lang="en-US" sz="900" b="1" dirty="0">
+                <a:solidFill>
+                  <a:srgbClr val="1A1A1A"/>
+                </a:solidFill>
+                <a:latin typeface="Arial" pitchFamily="34" charset="0"/>
+                <a:ea typeface="Arial" pitchFamily="34" charset="-122"/>
+                <a:cs typeface="Arial" pitchFamily="34" charset="-120"/>
+              </a:rPr>
+              <a:t>88%</a:t>
+            </a:r>
+            <a:endParaRPr lang="en-US" sz="900" dirty="0"/>
+          </a:p>
+        </p:txBody>
+      </p:sp>
+      <p:sp>
+        <p:nvSpPr>
+          <p:cNvPr id="44" name="Shape 42"/>
+          <p:cNvSpPr/>
+          <p:nvPr/>
+        </p:nvSpPr>
+        <p:spPr>
+          <a:xfrm>
+            <a:off x="7306056" y="3968496"/>
+            <a:ext cx="164592" cy="164592"/>
+          </a:xfrm>
+          <a:prstGeom prst="ellipse">
+            <a:avLst/>
+          </a:prstGeom>
+          <a:solidFill>
+            <a:srgbClr val="2E7D32"/>
+          </a:solidFill>
+          <a:ln/>
+        </p:spPr>
+      </p:sp>
+      <p:sp>
+        <p:nvSpPr>
+          <p:cNvPr id="45" name="Text 43"/>
+          <p:cNvSpPr/>
+          <p:nvPr/>
+        </p:nvSpPr>
+        <p:spPr>
+          <a:xfrm>
+            <a:off x="7580376" y="3904488"/>
+            <a:ext cx="3346704" cy="274320"/>
+          </a:xfrm>
+          <a:prstGeom prst="rect">
+            <a:avLst/>
+          </a:prstGeom>
+          <a:noFill/>
+          <a:ln/>
+        </p:spPr>
+        <p:txBody>
+          <a:bodyPr wrap="square" lIns="0" tIns="0" rIns="0" bIns="0" rtlCol="0" anchor="ctr"/>
+          <a:lstStyle/>
+          <a:p>
+            <a:pPr indent="0" marL="0">
+              <a:buNone/>
+            </a:pPr>
+            <a:r>
+              <a:rPr lang="en-US" sz="1150" b="1" dirty="0">
+                <a:solidFill>
+                  <a:srgbClr val="1A1A1A"/>
+                </a:solidFill>
+                <a:latin typeface="Arial" pitchFamily="34" charset="0"/>
+                <a:ea typeface="Arial" pitchFamily="34" charset="-122"/>
+                <a:cs typeface="Arial" pitchFamily="34" charset="-120"/>
+              </a:rPr>
+              <a:t>Platform migration</a:t>
+            </a:r>
+            <a:endParaRPr lang="en-US" sz="1150" dirty="0"/>
+          </a:p>
+        </p:txBody>
+      </p:sp>
+      <p:sp>
+        <p:nvSpPr>
+          <p:cNvPr id="46" name="Shape 44"/>
+          <p:cNvSpPr/>
+          <p:nvPr/>
+        </p:nvSpPr>
+        <p:spPr>
+          <a:xfrm>
+            <a:off x="11365992" y="3941064"/>
+            <a:ext cx="201168" cy="201168"/>
+          </a:xfrm>
+          <a:prstGeom prst="pie">
+            <a:avLst>
+              <a:gd name="adj1" fmla="val 16200000"/>
+              <a:gd name="adj2" fmla="val 10800000"/>
+            </a:avLst>
+          </a:prstGeom>
+          <a:solidFill>
+            <a:srgbClr val="1D5FCC"/>
+          </a:solidFill>
+          <a:ln w="6350">
+            <a:solidFill>
+              <a:srgbClr val="1D5FCC"/>
+            </a:solidFill>
+            <a:prstDash val="solid"/>
+          </a:ln>
+        </p:spPr>
+      </p:sp>
+      <p:sp>
+        <p:nvSpPr>
+          <p:cNvPr id="47" name="Shape 45"/>
+          <p:cNvSpPr/>
+          <p:nvPr/>
+        </p:nvSpPr>
+        <p:spPr>
+          <a:xfrm>
+            <a:off x="11365992" y="3941064"/>
+            <a:ext cx="201168" cy="201168"/>
+          </a:xfrm>
+          <a:prstGeom prst="ellipse">
+            <a:avLst/>
+          </a:prstGeom>
+          <a:ln w="12700">
+            <a:solidFill>
+              <a:srgbClr val="1D5FCC"/>
+            </a:solidFill>
+            <a:prstDash val="solid"/>
+          </a:ln>
+        </p:spPr>
+      </p:sp>
+      <p:sp>
+        <p:nvSpPr>
+          <p:cNvPr id="48" name="Shape 46"/>
+          <p:cNvSpPr/>
+          <p:nvPr/>
+        </p:nvSpPr>
+        <p:spPr>
+          <a:xfrm>
+            <a:off x="7580376" y="4233672"/>
+            <a:ext cx="3026664" cy="128016"/>
+          </a:xfrm>
+          <a:prstGeom prst="rect">
+            <a:avLst/>
+          </a:prstGeom>
+          <a:solidFill>
+            <a:srgbClr val="E8E8E8"/>
+          </a:solidFill>
+          <a:ln/>
+        </p:spPr>
+      </p:sp>
+      <p:sp>
+        <p:nvSpPr>
+          <p:cNvPr id="49" name="Shape 47"/>
+          <p:cNvSpPr/>
+          <p:nvPr/>
+        </p:nvSpPr>
+        <p:spPr>
+          <a:xfrm>
+            <a:off x="7580376" y="4233672"/>
+            <a:ext cx="1664665" cy="128016"/>
+          </a:xfrm>
+          <a:prstGeom prst="rect">
+            <a:avLst/>
+          </a:prstGeom>
+          <a:solidFill>
+            <a:srgbClr val="2E7CF6"/>
+          </a:solidFill>
+          <a:ln/>
+        </p:spPr>
+      </p:sp>
+      <p:sp>
+        <p:nvSpPr>
+          <p:cNvPr id="50" name="Text 48"/>
+          <p:cNvSpPr/>
+          <p:nvPr/>
+        </p:nvSpPr>
+        <p:spPr>
+          <a:xfrm>
+            <a:off x="10680192" y="4169664"/>
+            <a:ext cx="731520" cy="256032"/>
+          </a:xfrm>
+          <a:prstGeom prst="rect">
+            <a:avLst/>
+          </a:prstGeom>
+          <a:noFill/>
+          <a:ln/>
+        </p:spPr>
+        <p:txBody>
+          <a:bodyPr wrap="square" lIns="0" tIns="0" rIns="0" bIns="0" rtlCol="0" anchor="ctr"/>
+          <a:lstStyle/>
+          <a:p>
+            <a:pPr indent="0" marL="0">
+              <a:buNone/>
+            </a:pPr>
+            <a:r>
+              <a:rPr lang="en-US" sz="900" b="1" dirty="0">
+                <a:solidFill>
+                  <a:srgbClr val="1A1A1A"/>
+                </a:solidFill>
+                <a:latin typeface="Arial" pitchFamily="34" charset="0"/>
+                <a:ea typeface="Arial" pitchFamily="34" charset="-122"/>
+                <a:cs typeface="Arial" pitchFamily="34" charset="-120"/>
+              </a:rPr>
+              <a:t>55%</a:t>
+            </a:r>
+            <a:endParaRPr lang="en-US" sz="900" dirty="0"/>
+          </a:p>
+        </p:txBody>
+      </p:sp>
+      <p:sp>
+        <p:nvSpPr>
+          <p:cNvPr id="51" name="Shape 49"/>
+          <p:cNvSpPr/>
+          <p:nvPr/>
+        </p:nvSpPr>
+        <p:spPr>
+          <a:xfrm>
+            <a:off x="7306056" y="4681728"/>
+            <a:ext cx="164592" cy="164592"/>
+          </a:xfrm>
+          <a:prstGeom prst="ellipse">
+            <a:avLst/>
+          </a:prstGeom>
+          <a:solidFill>
+            <a:srgbClr val="E68A00"/>
+          </a:solidFill>
+          <a:ln/>
+        </p:spPr>
+      </p:sp>
+      <p:sp>
+        <p:nvSpPr>
+          <p:cNvPr id="52" name="Text 50"/>
+          <p:cNvSpPr/>
+          <p:nvPr/>
+        </p:nvSpPr>
+        <p:spPr>
+          <a:xfrm>
+            <a:off x="7580376" y="4617720"/>
+            <a:ext cx="3346704" cy="274320"/>
+          </a:xfrm>
+          <a:prstGeom prst="rect">
+            <a:avLst/>
+          </a:prstGeom>
+          <a:noFill/>
+          <a:ln/>
+        </p:spPr>
+        <p:txBody>
+          <a:bodyPr wrap="square" lIns="0" tIns="0" rIns="0" bIns="0" rtlCol="0" anchor="ctr"/>
+          <a:lstStyle/>
+          <a:p>
+            <a:pPr indent="0" marL="0">
+              <a:buNone/>
+            </a:pPr>
+            <a:r>
+              <a:rPr lang="en-US" sz="1150" b="1" dirty="0">
+                <a:solidFill>
+                  <a:srgbClr val="1A1A1A"/>
+                </a:solidFill>
+                <a:latin typeface="Arial" pitchFamily="34" charset="0"/>
+                <a:ea typeface="Arial" pitchFamily="34" charset="-122"/>
+                <a:cs typeface="Arial" pitchFamily="34" charset="-120"/>
+              </a:rPr>
+              <a:t>Training waves</a:t>
+            </a:r>
+            <a:endParaRPr lang="en-US" sz="1150" dirty="0"/>
+          </a:p>
+        </p:txBody>
+      </p:sp>
+      <p:sp>
+        <p:nvSpPr>
+          <p:cNvPr id="53" name="Shape 51"/>
+          <p:cNvSpPr/>
+          <p:nvPr/>
+        </p:nvSpPr>
+        <p:spPr>
+          <a:xfrm>
+            <a:off x="11365992" y="4654296"/>
+            <a:ext cx="201168" cy="201168"/>
+          </a:xfrm>
+          <a:prstGeom prst="pie">
+            <a:avLst>
+              <a:gd name="adj1" fmla="val 16200000"/>
+              <a:gd name="adj2" fmla="val 5400000"/>
+            </a:avLst>
+          </a:prstGeom>
+          <a:solidFill>
+            <a:srgbClr val="1D5FCC"/>
+          </a:solidFill>
+          <a:ln w="6350">
+            <a:solidFill>
+              <a:srgbClr val="1D5FCC"/>
+            </a:solidFill>
+            <a:prstDash val="solid"/>
+          </a:ln>
+        </p:spPr>
+      </p:sp>
+      <p:sp>
+        <p:nvSpPr>
+          <p:cNvPr id="54" name="Shape 52"/>
+          <p:cNvSpPr/>
+          <p:nvPr/>
+        </p:nvSpPr>
+        <p:spPr>
+          <a:xfrm>
+            <a:off x="11365992" y="4654296"/>
+            <a:ext cx="201168" cy="201168"/>
+          </a:xfrm>
+          <a:prstGeom prst="ellipse">
+            <a:avLst/>
+          </a:prstGeom>
+          <a:ln w="12700">
+            <a:solidFill>
+              <a:srgbClr val="1D5FCC"/>
+            </a:solidFill>
+            <a:prstDash val="solid"/>
+          </a:ln>
+        </p:spPr>
+      </p:sp>
+      <p:sp>
+        <p:nvSpPr>
+          <p:cNvPr id="55" name="Shape 53"/>
+          <p:cNvSpPr/>
+          <p:nvPr/>
+        </p:nvSpPr>
+        <p:spPr>
+          <a:xfrm>
+            <a:off x="7580376" y="4946904"/>
+            <a:ext cx="3026664" cy="128016"/>
+          </a:xfrm>
+          <a:prstGeom prst="rect">
+            <a:avLst/>
+          </a:prstGeom>
+          <a:solidFill>
+            <a:srgbClr val="E8E8E8"/>
+          </a:solidFill>
+          <a:ln/>
+        </p:spPr>
+      </p:sp>
+      <p:sp>
+        <p:nvSpPr>
+          <p:cNvPr id="56" name="Shape 54"/>
+          <p:cNvSpPr/>
+          <p:nvPr/>
+        </p:nvSpPr>
+        <p:spPr>
+          <a:xfrm>
+            <a:off x="7580376" y="4946904"/>
+            <a:ext cx="1150132" cy="128016"/>
+          </a:xfrm>
+          <a:prstGeom prst="rect">
+            <a:avLst/>
+          </a:prstGeom>
+          <a:solidFill>
+            <a:srgbClr val="2E7CF6"/>
+          </a:solidFill>
+          <a:ln/>
+        </p:spPr>
+      </p:sp>
+      <p:sp>
+        <p:nvSpPr>
+          <p:cNvPr id="57" name="Text 55"/>
+          <p:cNvSpPr/>
+          <p:nvPr/>
+        </p:nvSpPr>
+        <p:spPr>
+          <a:xfrm>
+            <a:off x="10680192" y="4882896"/>
+            <a:ext cx="731520" cy="256032"/>
+          </a:xfrm>
+          <a:prstGeom prst="rect">
+            <a:avLst/>
+          </a:prstGeom>
+          <a:noFill/>
+          <a:ln/>
+        </p:spPr>
+        <p:txBody>
+          <a:bodyPr wrap="square" lIns="0" tIns="0" rIns="0" bIns="0" rtlCol="0" anchor="ctr"/>
+          <a:lstStyle/>
+          <a:p>
+            <a:pPr indent="0" marL="0">
+              <a:buNone/>
+            </a:pPr>
+            <a:r>
+              <a:rPr lang="en-US" sz="900" b="1" dirty="0">
+                <a:solidFill>
+                  <a:srgbClr val="1A1A1A"/>
+                </a:solidFill>
+                <a:latin typeface="Arial" pitchFamily="34" charset="0"/>
+                <a:ea typeface="Arial" pitchFamily="34" charset="-122"/>
+                <a:cs typeface="Arial" pitchFamily="34" charset="-120"/>
+              </a:rPr>
+              <a:t>38%</a:t>
+            </a:r>
+            <a:endParaRPr lang="en-US" sz="900" dirty="0"/>
+          </a:p>
+        </p:txBody>
+      </p:sp>
+      <p:sp>
+        <p:nvSpPr>
+          <p:cNvPr id="58" name="Shape 56"/>
+          <p:cNvSpPr/>
+          <p:nvPr/>
+        </p:nvSpPr>
+        <p:spPr>
+          <a:xfrm>
+            <a:off x="7306056" y="5394960"/>
+            <a:ext cx="164592" cy="164592"/>
+          </a:xfrm>
+          <a:prstGeom prst="ellipse">
+            <a:avLst/>
+          </a:prstGeom>
+          <a:solidFill>
+            <a:srgbClr val="2E7D32"/>
+          </a:solidFill>
+          <a:ln/>
+        </p:spPr>
+      </p:sp>
+      <p:sp>
+        <p:nvSpPr>
+          <p:cNvPr id="59" name="Text 57"/>
+          <p:cNvSpPr/>
+          <p:nvPr/>
+        </p:nvSpPr>
+        <p:spPr>
+          <a:xfrm>
+            <a:off x="7580376" y="5330952"/>
+            <a:ext cx="3346704" cy="274320"/>
+          </a:xfrm>
+          <a:prstGeom prst="rect">
+            <a:avLst/>
+          </a:prstGeom>
+          <a:noFill/>
+          <a:ln/>
+        </p:spPr>
+        <p:txBody>
+          <a:bodyPr wrap="square" lIns="0" tIns="0" rIns="0" bIns="0" rtlCol="0" anchor="ctr"/>
+          <a:lstStyle/>
+          <a:p>
+            <a:pPr indent="0" marL="0">
+              <a:buNone/>
+            </a:pPr>
+            <a:r>
+              <a:rPr lang="en-US" sz="1150" b="1" dirty="0">
+                <a:solidFill>
+                  <a:srgbClr val="1A1A1A"/>
+                </a:solidFill>
+                <a:latin typeface="Arial" pitchFamily="34" charset="0"/>
+                <a:ea typeface="Arial" pitchFamily="34" charset="-122"/>
+                <a:cs typeface="Arial" pitchFamily="34" charset="-120"/>
+              </a:rPr>
+              <a:t>Regional roll-out</a:t>
+            </a:r>
+            <a:endParaRPr lang="en-US" sz="1150" dirty="0"/>
+          </a:p>
+        </p:txBody>
+      </p:sp>
+      <p:sp>
+        <p:nvSpPr>
+          <p:cNvPr id="60" name="Shape 58"/>
+          <p:cNvSpPr/>
+          <p:nvPr/>
+        </p:nvSpPr>
+        <p:spPr>
+          <a:xfrm>
+            <a:off x="11365992" y="5367528"/>
+            <a:ext cx="201168" cy="201168"/>
+          </a:xfrm>
+          <a:prstGeom prst="pie">
+            <a:avLst>
+              <a:gd name="adj1" fmla="val 16200000"/>
+              <a:gd name="adj2" fmla="val 21600000"/>
+            </a:avLst>
+          </a:prstGeom>
+          <a:solidFill>
+            <a:srgbClr val="1D5FCC"/>
+          </a:solidFill>
+          <a:ln w="6350">
+            <a:solidFill>
+              <a:srgbClr val="1D5FCC"/>
+            </a:solidFill>
+            <a:prstDash val="solid"/>
+          </a:ln>
+        </p:spPr>
+      </p:sp>
+      <p:sp>
+        <p:nvSpPr>
+          <p:cNvPr id="61" name="Shape 59"/>
+          <p:cNvSpPr/>
+          <p:nvPr/>
+        </p:nvSpPr>
+        <p:spPr>
+          <a:xfrm>
+            <a:off x="11365992" y="5367528"/>
+            <a:ext cx="201168" cy="201168"/>
+          </a:xfrm>
+          <a:prstGeom prst="ellipse">
+            <a:avLst/>
+          </a:prstGeom>
+          <a:ln w="12700">
+            <a:solidFill>
+              <a:srgbClr val="1D5FCC"/>
+            </a:solidFill>
+            <a:prstDash val="solid"/>
+          </a:ln>
+        </p:spPr>
+      </p:sp>
+      <p:sp>
+        <p:nvSpPr>
+          <p:cNvPr id="62" name="Shape 60"/>
+          <p:cNvSpPr/>
+          <p:nvPr/>
+        </p:nvSpPr>
+        <p:spPr>
+          <a:xfrm>
+            <a:off x="7580376" y="5660136"/>
+            <a:ext cx="3026664" cy="128016"/>
+          </a:xfrm>
+          <a:prstGeom prst="rect">
+            <a:avLst/>
+          </a:prstGeom>
+          <a:solidFill>
+            <a:srgbClr val="E8E8E8"/>
+          </a:solidFill>
+          <a:ln/>
+        </p:spPr>
+      </p:sp>
+      <p:sp>
+        <p:nvSpPr>
+          <p:cNvPr id="63" name="Shape 61"/>
+          <p:cNvSpPr/>
+          <p:nvPr/>
+        </p:nvSpPr>
+        <p:spPr>
+          <a:xfrm>
+            <a:off x="7580376" y="5660136"/>
+            <a:ext cx="302666" cy="128016"/>
+          </a:xfrm>
+          <a:prstGeom prst="rect">
+            <a:avLst/>
+          </a:prstGeom>
+          <a:solidFill>
+            <a:srgbClr val="2E7CF6"/>
+          </a:solidFill>
+          <a:ln/>
+        </p:spPr>
+      </p:sp>
+      <p:sp>
+        <p:nvSpPr>
+          <p:cNvPr id="64" name="Text 62"/>
+          <p:cNvSpPr/>
+          <p:nvPr/>
+        </p:nvSpPr>
+        <p:spPr>
+          <a:xfrm>
+            <a:off x="10680192" y="5596128"/>
+            <a:ext cx="731520" cy="256032"/>
+          </a:xfrm>
+          <a:prstGeom prst="rect">
+            <a:avLst/>
+          </a:prstGeom>
+          <a:noFill/>
+          <a:ln/>
+        </p:spPr>
+        <p:txBody>
+          <a:bodyPr wrap="square" lIns="0" tIns="0" rIns="0" bIns="0" rtlCol="0" anchor="ctr"/>
+          <a:lstStyle/>
+          <a:p>
+            <a:pPr indent="0" marL="0">
+              <a:buNone/>
+            </a:pPr>
+            <a:r>
+              <a:rPr lang="en-US" sz="900" b="1" dirty="0">
+                <a:solidFill>
+                  <a:srgbClr val="1A1A1A"/>
+                </a:solidFill>
+                <a:latin typeface="Arial" pitchFamily="34" charset="0"/>
+                <a:ea typeface="Arial" pitchFamily="34" charset="-122"/>
+                <a:cs typeface="Arial" pitchFamily="34" charset="-120"/>
+              </a:rPr>
+              <a:t>10%</a:t>
+            </a:r>
+            <a:endParaRPr lang="en-US" sz="900" dirty="0"/>
+          </a:p>
+        </p:txBody>
+      </p:sp>
+      <p:sp>
+        <p:nvSpPr>
+          <p:cNvPr id="65" name="Text 63"/>
+          <p:cNvSpPr/>
+          <p:nvPr/>
+        </p:nvSpPr>
+        <p:spPr>
+          <a:xfrm>
+            <a:off x="502920" y="6419088"/>
+            <a:ext cx="10515600" cy="274320"/>
+          </a:xfrm>
+          <a:prstGeom prst="rect">
+            <a:avLst/>
+          </a:prstGeom>
+          <a:noFill/>
+          <a:ln/>
+        </p:spPr>
+        <p:txBody>
+          <a:bodyPr wrap="square" lIns="0" tIns="0" rIns="0" bIns="0" rtlCol="0" anchor="ctr"/>
+          <a:lstStyle/>
+          <a:p>
+            <a:pPr indent="0" marL="0">
+              <a:buNone/>
+            </a:pPr>
+            <a:r>
+              <a:rPr lang="en-US" sz="800" dirty="0">
+                <a:solidFill>
+                  <a:srgbClr val="8C8C8C"/>
+                </a:solidFill>
+                <a:latin typeface="Arial" pitchFamily="34" charset="0"/>
+                <a:ea typeface="Arial" pitchFamily="34" charset="-122"/>
+                <a:cs typeface="Arial" pitchFamily="34" charset="-120"/>
+              </a:rPr>
+              <a:t>Source: program reporting W28; Meridio PMO</a:t>
+            </a:r>
+            <a:endParaRPr lang="en-US" sz="800" dirty="0"/>
+          </a:p>
+        </p:txBody>
+      </p:sp>
+      <p:sp>
+        <p:nvSpPr>
+          <p:cNvPr id="66" name="Text 64"/>
+          <p:cNvSpPr/>
+          <p:nvPr/>
+        </p:nvSpPr>
+        <p:spPr>
+          <a:xfrm>
+            <a:off x="11292840" y="6419088"/>
+            <a:ext cx="365760" cy="274320"/>
+          </a:xfrm>
+          <a:prstGeom prst="rect">
+            <a:avLst/>
+          </a:prstGeom>
+          <a:noFill/>
+          <a:ln/>
+        </p:spPr>
+        <p:txBody>
+          <a:bodyPr wrap="square" lIns="0" tIns="0" rIns="0" bIns="0" rtlCol="0" anchor="ctr"/>
+          <a:lstStyle/>
+          <a:p>
+            <a:pPr algn="r" indent="0" marL="0">
+              <a:buNone/>
+            </a:pPr>
+            <a:r>
+              <a:rPr lang="en-US" sz="850" b="1" dirty="0">
+                <a:solidFill>
+                  <a:srgbClr val="1D5FCC"/>
+                </a:solidFill>
+                <a:latin typeface="Arial" pitchFamily="34" charset="0"/>
+                <a:ea typeface="Arial" pitchFamily="34" charset="-122"/>
+                <a:cs typeface="Arial" pitchFamily="34" charset="-120"/>
+              </a:rPr>
+              <a:t>28</a:t>
+            </a:r>
+            <a:endParaRPr lang="en-US" sz="850" dirty="0"/>
+          </a:p>
+        </p:txBody>
+      </p:sp>
+    </p:spTree>
+  </p:cSld>
+  <p:clrMapOvr>
+    <a:masterClrMapping/>
+  </p:clrMapOvr>
+</p:sld>
+</file>
+
+<file path=ppt/slides/slide33.xml><?xml version="1.0" encoding="utf-8"?>
+<p:sld xmlns:a="http://schemas.openxmlformats.org/drawingml/2006/main" xmlns:r="http://schemas.openxmlformats.org/officeDocument/2006/relationships" xmlns:p="http://schemas.openxmlformats.org/presentationml/2006/main">
+  <p:cSld name="Slide 33">
+    <p:bg>
+      <p:bgPr>
+        <a:solidFill>
+          <a:srgbClr val="FFFFFF"/>
+        </a:solidFill>
+      </p:bgPr>
+    </p:bg>
+    <p:spTree>
+      <p:nvGrpSpPr>
+        <p:cNvPr id="1" name=""/>
+        <p:cNvGrpSpPr/>
+        <p:nvPr/>
+      </p:nvGrpSpPr>
+      <p:grpSpPr>
+        <a:xfrm>
+          <a:off x="0" y="0"/>
+          <a:ext cx="0" cy="0"/>
+          <a:chOff x="0" y="0"/>
+          <a:chExt cx="0" cy="0"/>
+        </a:xfrm>
+      </p:grpSpPr>
+      <p:sp>
+        <p:nvSpPr>
+          <p:cNvPr id="2" name="Text 0"/>
+          <p:cNvSpPr/>
+          <p:nvPr/>
+        </p:nvSpPr>
+        <p:spPr>
+          <a:xfrm>
+            <a:off x="502920" y="310896"/>
+            <a:ext cx="11155680" cy="256032"/>
+          </a:xfrm>
+          <a:prstGeom prst="rect">
+            <a:avLst/>
+          </a:prstGeom>
+          <a:noFill/>
+          <a:ln/>
+        </p:spPr>
+        <p:txBody>
+          <a:bodyPr wrap="square" lIns="0" tIns="0" rIns="0" bIns="0" rtlCol="0" anchor="ctr"/>
+          <a:lstStyle/>
+          <a:p>
+            <a:pPr indent="0" marL="0">
+              <a:buNone/>
+            </a:pPr>
+            <a:r>
+              <a:rPr lang="en-US" sz="1050" b="1" spc="200" kern="0" dirty="0">
+                <a:solidFill>
+                  <a:srgbClr val="1D5FCC"/>
+                </a:solidFill>
+                <a:latin typeface="Arial" pitchFamily="34" charset="0"/>
+                <a:ea typeface="Arial" pitchFamily="34" charset="-122"/>
+                <a:cs typeface="Arial" pitchFamily="34" charset="-120"/>
+              </a:rPr>
+              <a:t>EXHIBITS — QUOTE &amp; FUNNEL</a:t>
+            </a:r>
+            <a:endParaRPr lang="en-US" sz="1050" dirty="0"/>
+          </a:p>
+        </p:txBody>
+      </p:sp>
+      <p:sp>
+        <p:nvSpPr>
+          <p:cNvPr id="3" name="Text 1"/>
+          <p:cNvSpPr/>
+          <p:nvPr/>
+        </p:nvSpPr>
+        <p:spPr>
+          <a:xfrm>
+            <a:off x="502920" y="585216"/>
+            <a:ext cx="11155680" cy="822960"/>
+          </a:xfrm>
+          <a:prstGeom prst="rect">
+            <a:avLst/>
+          </a:prstGeom>
+          <a:noFill/>
+          <a:ln/>
+        </p:spPr>
+        <p:txBody>
+          <a:bodyPr wrap="square" lIns="0" tIns="0" rIns="0" bIns="0" rtlCol="0" anchor="t"/>
+          <a:lstStyle/>
+          <a:p>
+            <a:pPr indent="0" marL="0">
+              <a:lnSpc>
+                <a:spcPct val="102000"/>
+              </a:lnSpc>
+              <a:buNone/>
+            </a:pPr>
+            <a:r>
+              <a:rPr lang="en-US" sz="2100" b="1" dirty="0">
+                <a:solidFill>
+                  <a:srgbClr val="1A1A1A"/>
+                </a:solidFill>
+                <a:latin typeface="Arial" pitchFamily="34" charset="0"/>
+                <a:ea typeface="Arial" pitchFamily="34" charset="-122"/>
+                <a:cs typeface="Arial" pitchFamily="34" charset="-120"/>
+              </a:rPr>
+              <a:t>Customers say it themselves: uptime sells the contract, and the funnel proves they sign</a:t>
+            </a:r>
+            <a:endParaRPr lang="en-US" sz="2100" dirty="0"/>
+          </a:p>
+        </p:txBody>
+      </p:sp>
+      <p:sp>
+        <p:nvSpPr>
+          <p:cNvPr id="4" name="Shape 2"/>
+          <p:cNvSpPr/>
+          <p:nvPr/>
+        </p:nvSpPr>
+        <p:spPr>
+          <a:xfrm>
+            <a:off x="502920" y="1435608"/>
+            <a:ext cx="11155680" cy="25603"/>
+          </a:xfrm>
+          <a:prstGeom prst="rect">
+            <a:avLst/>
+          </a:prstGeom>
+          <a:solidFill>
+            <a:srgbClr val="2E7CF6"/>
+          </a:solidFill>
+          <a:ln/>
+        </p:spPr>
+      </p:sp>
+      <p:sp>
+        <p:nvSpPr>
+          <p:cNvPr id="5" name="Text 3"/>
+          <p:cNvSpPr/>
+          <p:nvPr/>
+        </p:nvSpPr>
+        <p:spPr>
+          <a:xfrm>
+            <a:off x="502920" y="1499616"/>
+            <a:ext cx="11155680" cy="384048"/>
+          </a:xfrm>
+          <a:prstGeom prst="rect">
+            <a:avLst/>
+          </a:prstGeom>
+          <a:noFill/>
+          <a:ln/>
+        </p:spPr>
+        <p:txBody>
+          <a:bodyPr wrap="square" lIns="0" tIns="0" rIns="0" bIns="0" rtlCol="0" anchor="t"/>
+          <a:lstStyle/>
+          <a:p>
+            <a:pPr indent="0" marL="0">
+              <a:buNone/>
+            </a:pPr>
+            <a:r>
+              <a:rPr lang="en-US" sz="1350" i="1" dirty="0">
+                <a:solidFill>
+                  <a:srgbClr val="595959"/>
+                </a:solidFill>
+                <a:latin typeface="Arial" pitchFamily="34" charset="0"/>
+                <a:ea typeface="Arial" pitchFamily="34" charset="-122"/>
+                <a:cs typeface="Arial" pitchFamily="34" charset="-120"/>
+              </a:rPr>
+              <a:t>Pull quote (verbatim evidence) and conversion funnel (stage-by-stage narrowing).</a:t>
+            </a:r>
+            <a:endParaRPr lang="en-US" sz="1350" dirty="0"/>
+          </a:p>
+        </p:txBody>
+      </p:sp>
+      <p:sp>
+        <p:nvSpPr>
+          <p:cNvPr id="6" name="Shape 4"/>
+          <p:cNvSpPr/>
+          <p:nvPr/>
+        </p:nvSpPr>
+        <p:spPr>
+          <a:xfrm>
+            <a:off x="502920" y="2194560"/>
+            <a:ext cx="5770880" cy="2011680"/>
+          </a:xfrm>
+          <a:prstGeom prst="roundRect">
+            <a:avLst>
+              <a:gd name="adj" fmla="val 2727"/>
+            </a:avLst>
+          </a:prstGeom>
+          <a:solidFill>
+            <a:srgbClr val="FFFFFF"/>
+          </a:solidFill>
+          <a:ln w="15875">
+            <a:solidFill>
+              <a:srgbClr val="2E7CF6"/>
+            </a:solidFill>
+            <a:prstDash val="solid"/>
+          </a:ln>
+          <a:effectLst>
+            <a:outerShdw sx="100000" sy="100000" kx="0" ky="0" algn="bl" rotWithShape="0" blurRad="88900" dist="25400" dir="2700000">
+              <a:srgbClr val="1A1A1A">
+                <a:alpha val="12000"/>
+              </a:srgbClr>
+            </a:outerShdw>
+          </a:effectLst>
+        </p:spPr>
+      </p:sp>
+      <p:sp>
+        <p:nvSpPr>
+          <p:cNvPr id="7" name="Shape 5"/>
+          <p:cNvSpPr/>
+          <p:nvPr/>
+        </p:nvSpPr>
+        <p:spPr>
+          <a:xfrm>
+            <a:off x="502920" y="2194560"/>
+            <a:ext cx="73152" cy="2011680"/>
+          </a:xfrm>
+          <a:prstGeom prst="rect">
+            <a:avLst/>
+          </a:prstGeom>
+          <a:solidFill>
+            <a:srgbClr val="2E7CF6"/>
+          </a:solidFill>
+          <a:ln/>
+        </p:spPr>
+      </p:sp>
+      <p:sp>
+        <p:nvSpPr>
+          <p:cNvPr id="8" name="Text 6"/>
+          <p:cNvSpPr/>
+          <p:nvPr/>
+        </p:nvSpPr>
+        <p:spPr>
+          <a:xfrm>
+            <a:off x="758952" y="2304288"/>
+            <a:ext cx="5313680" cy="1792224"/>
+          </a:xfrm>
+          <a:prstGeom prst="rect">
+            <a:avLst/>
+          </a:prstGeom>
+          <a:noFill/>
+          <a:ln/>
+        </p:spPr>
+        <p:txBody>
+          <a:bodyPr wrap="square" lIns="0" tIns="0" rIns="0" bIns="0" rtlCol="0" anchor="ctr"/>
+          <a:lstStyle/>
+          <a:p>
+            <a:pPr indent="0" marL="0">
+              <a:lnSpc>
+                <a:spcPct val="120000"/>
+              </a:lnSpc>
+              <a:buNone/>
+            </a:pPr>
+            <a:r>
+              <a:rPr lang="en-US" sz="1700" b="1" dirty="0">
+                <a:solidFill>
+                  <a:srgbClr val="1D5FCC"/>
+                </a:solidFill>
+                <a:latin typeface="Arial" pitchFamily="34" charset="0"/>
+                <a:ea typeface="Arial" pitchFamily="34" charset="-122"/>
+                <a:cs typeface="Arial" pitchFamily="34" charset="-120"/>
+              </a:rPr>
+              <a:t>“An hour of unplanned downtime costs me more than a year of your contract. If your sensors see the failure coming, I am not negotiating the price.”</a:t>
+            </a:r>
+            <a:endParaRPr lang="en-US" sz="1700" dirty="0"/>
+          </a:p>
+        </p:txBody>
+      </p:sp>
+      <p:sp>
+        <p:nvSpPr>
+          <p:cNvPr id="9" name="Text 7"/>
+          <p:cNvSpPr/>
+          <p:nvPr/>
+        </p:nvSpPr>
+        <p:spPr>
+          <a:xfrm>
+            <a:off x="548640" y="4343400"/>
+            <a:ext cx="5679440" cy="320040"/>
+          </a:xfrm>
+          <a:prstGeom prst="rect">
+            <a:avLst/>
+          </a:prstGeom>
+          <a:noFill/>
+          <a:ln/>
+        </p:spPr>
+        <p:txBody>
+          <a:bodyPr wrap="square" lIns="0" tIns="0" rIns="0" bIns="0" rtlCol="0" anchor="ctr"/>
+          <a:lstStyle/>
+          <a:p>
+            <a:pPr indent="0" marL="0">
+              <a:buNone/>
+            </a:pPr>
+            <a:r>
+              <a:rPr lang="en-US" sz="1100" i="1" dirty="0">
+                <a:solidFill>
+                  <a:srgbClr val="595959"/>
+                </a:solidFill>
+                <a:latin typeface="Arial" pitchFamily="34" charset="0"/>
+                <a:ea typeface="Arial" pitchFamily="34" charset="-122"/>
+                <a:cs typeface="Arial" pitchFamily="34" charset="-120"/>
+              </a:rPr>
+              <a:t>Operations director, agrifood plant (interview #17 of 42) - the pattern behind 81% of interviews.</a:t>
+            </a:r>
+            <a:endParaRPr lang="en-US" sz="1100" dirty="0"/>
+          </a:p>
+        </p:txBody>
+      </p:sp>
+      <p:sp>
+        <p:nvSpPr>
+          <p:cNvPr id="10" name="Text 8"/>
+          <p:cNvSpPr/>
+          <p:nvPr/>
+        </p:nvSpPr>
+        <p:spPr>
+          <a:xfrm>
+            <a:off x="548640" y="4892040"/>
+            <a:ext cx="5679440" cy="731520"/>
+          </a:xfrm>
+          <a:prstGeom prst="rect">
+            <a:avLst/>
+          </a:prstGeom>
+          <a:noFill/>
+          <a:ln/>
+        </p:spPr>
+        <p:txBody>
+          <a:bodyPr wrap="square" lIns="0" tIns="0" rIns="0" bIns="0" rtlCol="0" anchor="t"/>
+          <a:lstStyle/>
+          <a:p>
+            <a:pPr indent="0" marL="0">
+              <a:lnSpc>
+                <a:spcPct val="120000"/>
+              </a:lnSpc>
+              <a:buNone/>
+            </a:pPr>
+            <a:r>
+              <a:rPr lang="en-US" sz="1200" b="1" dirty="0">
+                <a:solidFill>
+                  <a:srgbClr val="1D5FCC"/>
+                </a:solidFill>
+                <a:latin typeface="Arial" pitchFamily="34" charset="0"/>
+                <a:ea typeface="Arial" pitchFamily="34" charset="-122"/>
+                <a:cs typeface="Arial" pitchFamily="34" charset="-120"/>
+              </a:rPr>
+              <a:t>What it changes: </a:t>
+            </a:r>
+            <a:pPr indent="0" marL="0">
+              <a:lnSpc>
+                <a:spcPct val="120000"/>
+              </a:lnSpc>
+              <a:buNone/>
+            </a:pPr>
+            <a:r>
+              <a:rPr lang="en-US" sz="1200" dirty="0">
+                <a:solidFill>
+                  <a:srgbClr val="1A1A1A"/>
+                </a:solidFill>
+                <a:latin typeface="Arial" pitchFamily="34" charset="0"/>
+                <a:ea typeface="Arial" pitchFamily="34" charset="-122"/>
+                <a:cs typeface="Arial" pitchFamily="34" charset="-120"/>
+              </a:rPr>
+              <a:t>the pitch leads with measured uptime, not with a maintenance price list; the premium tier is priced against the cost of downtime.</a:t>
+            </a:r>
+            <a:endParaRPr lang="en-US" sz="1200" dirty="0"/>
+          </a:p>
+        </p:txBody>
+      </p:sp>
+      <p:sp>
+        <p:nvSpPr>
+          <p:cNvPr id="11" name="Text 9"/>
+          <p:cNvSpPr/>
+          <p:nvPr/>
+        </p:nvSpPr>
+        <p:spPr>
+          <a:xfrm>
+            <a:off x="6822440" y="2039112"/>
+            <a:ext cx="4836160" cy="237744"/>
+          </a:xfrm>
+          <a:prstGeom prst="rect">
+            <a:avLst/>
+          </a:prstGeom>
+          <a:noFill/>
+          <a:ln/>
+        </p:spPr>
+        <p:txBody>
+          <a:bodyPr wrap="square" lIns="0" tIns="0" rIns="0" bIns="0" rtlCol="0" anchor="ctr"/>
+          <a:lstStyle/>
+          <a:p>
+            <a:pPr indent="0" marL="0">
+              <a:buNone/>
+            </a:pPr>
+            <a:r>
+              <a:rPr lang="en-US" sz="1000" b="1" dirty="0">
+                <a:solidFill>
+                  <a:srgbClr val="595959"/>
+                </a:solidFill>
+                <a:latin typeface="Arial" pitchFamily="34" charset="0"/>
+                <a:ea typeface="Arial" pitchFamily="34" charset="-122"/>
+                <a:cs typeface="Arial" pitchFamily="34" charset="-120"/>
+              </a:rPr>
+              <a:t>Pilot conversion funnel, North region</a:t>
+            </a:r>
+            <a:endParaRPr lang="en-US" sz="1000" dirty="0"/>
+          </a:p>
+        </p:txBody>
+      </p:sp>
+      <p:sp>
+        <p:nvSpPr>
+          <p:cNvPr id="12" name="Shape 10"/>
+          <p:cNvSpPr/>
+          <p:nvPr/>
+        </p:nvSpPr>
+        <p:spPr>
+          <a:xfrm>
+            <a:off x="7005320" y="2514600"/>
+            <a:ext cx="4287520" cy="589788"/>
+          </a:xfrm>
+          <a:prstGeom prst="rect">
+            <a:avLst/>
+          </a:prstGeom>
+          <a:solidFill>
+            <a:srgbClr val="2E7CF6"/>
+          </a:solidFill>
+          <a:ln/>
+        </p:spPr>
+      </p:sp>
+      <p:sp>
+        <p:nvSpPr>
+          <p:cNvPr id="13" name="Text 11"/>
+          <p:cNvSpPr/>
+          <p:nvPr/>
+        </p:nvSpPr>
+        <p:spPr>
+          <a:xfrm>
+            <a:off x="7005320" y="2514600"/>
+            <a:ext cx="4287520" cy="589788"/>
+          </a:xfrm>
+          <a:prstGeom prst="rect">
+            <a:avLst/>
+          </a:prstGeom>
+          <a:noFill/>
+          <a:ln/>
+        </p:spPr>
+        <p:txBody>
+          <a:bodyPr wrap="square" lIns="0" tIns="0" rIns="0" bIns="0" rtlCol="0" anchor="ctr"/>
+          <a:lstStyle/>
+          <a:p>
+            <a:pPr algn="ctr" indent="0" marL="0">
+              <a:buNone/>
+            </a:pPr>
+            <a:r>
+              <a:rPr lang="en-US" sz="1100" b="1" dirty="0">
+                <a:solidFill>
+                  <a:srgbClr val="FFFFFF"/>
+                </a:solidFill>
+                <a:latin typeface="Arial" pitchFamily="34" charset="0"/>
+                <a:ea typeface="Arial" pitchFamily="34" charset="-122"/>
+                <a:cs typeface="Arial" pitchFamily="34" charset="-120"/>
+              </a:rPr>
+              <a:t>Sites approached   1580</a:t>
+            </a:r>
+            <a:endParaRPr lang="en-US" sz="1100" dirty="0"/>
+          </a:p>
+        </p:txBody>
+      </p:sp>
+      <p:sp>
+        <p:nvSpPr>
+          <p:cNvPr id="14" name="Shape 12"/>
+          <p:cNvSpPr/>
+          <p:nvPr/>
+        </p:nvSpPr>
+        <p:spPr>
+          <a:xfrm>
+            <a:off x="7380478" y="3177540"/>
+            <a:ext cx="3537204" cy="589788"/>
+          </a:xfrm>
+          <a:prstGeom prst="rect">
+            <a:avLst/>
+          </a:prstGeom>
+          <a:solidFill>
+            <a:srgbClr val="2E7CF6"/>
+          </a:solidFill>
+          <a:ln/>
+        </p:spPr>
+      </p:sp>
+      <p:sp>
+        <p:nvSpPr>
+          <p:cNvPr id="15" name="Text 13"/>
+          <p:cNvSpPr/>
+          <p:nvPr/>
+        </p:nvSpPr>
+        <p:spPr>
+          <a:xfrm>
+            <a:off x="7380478" y="3177540"/>
+            <a:ext cx="3537204" cy="589788"/>
+          </a:xfrm>
+          <a:prstGeom prst="rect">
+            <a:avLst/>
+          </a:prstGeom>
+          <a:noFill/>
+          <a:ln/>
+        </p:spPr>
+        <p:txBody>
+          <a:bodyPr wrap="square" lIns="0" tIns="0" rIns="0" bIns="0" rtlCol="0" anchor="ctr"/>
+          <a:lstStyle/>
+          <a:p>
+            <a:pPr algn="ctr" indent="0" marL="0">
+              <a:buNone/>
+            </a:pPr>
+            <a:r>
+              <a:rPr lang="en-US" sz="1100" b="1" dirty="0">
+                <a:solidFill>
+                  <a:srgbClr val="FFFFFF"/>
+                </a:solidFill>
+                <a:latin typeface="Arial" pitchFamily="34" charset="0"/>
+                <a:ea typeface="Arial" pitchFamily="34" charset="-122"/>
+                <a:cs typeface="Arial" pitchFamily="34" charset="-120"/>
+              </a:rPr>
+              <a:t>Offers presented   940</a:t>
+            </a:r>
+            <a:endParaRPr lang="en-US" sz="1100" dirty="0"/>
+          </a:p>
+        </p:txBody>
+      </p:sp>
+      <p:sp>
+        <p:nvSpPr>
+          <p:cNvPr id="16" name="Shape 14"/>
+          <p:cNvSpPr/>
+          <p:nvPr/>
+        </p:nvSpPr>
+        <p:spPr>
+          <a:xfrm>
+            <a:off x="7755636" y="3840480"/>
+            <a:ext cx="2786888" cy="589788"/>
+          </a:xfrm>
+          <a:prstGeom prst="rect">
+            <a:avLst/>
+          </a:prstGeom>
+          <a:solidFill>
+            <a:srgbClr val="2E7CF6"/>
+          </a:solidFill>
+          <a:ln/>
+        </p:spPr>
+      </p:sp>
+      <p:sp>
+        <p:nvSpPr>
+          <p:cNvPr id="17" name="Text 15"/>
+          <p:cNvSpPr/>
+          <p:nvPr/>
+        </p:nvSpPr>
+        <p:spPr>
+          <a:xfrm>
+            <a:off x="7755636" y="3840480"/>
+            <a:ext cx="2786888" cy="589788"/>
+          </a:xfrm>
+          <a:prstGeom prst="rect">
+            <a:avLst/>
+          </a:prstGeom>
+          <a:noFill/>
+          <a:ln/>
+        </p:spPr>
+        <p:txBody>
+          <a:bodyPr wrap="square" lIns="0" tIns="0" rIns="0" bIns="0" rtlCol="0" anchor="ctr"/>
+          <a:lstStyle/>
+          <a:p>
+            <a:pPr algn="ctr" indent="0" marL="0">
+              <a:buNone/>
+            </a:pPr>
+            <a:r>
+              <a:rPr lang="en-US" sz="1100" b="1" dirty="0">
+                <a:solidFill>
+                  <a:srgbClr val="FFFFFF"/>
+                </a:solidFill>
+                <a:latin typeface="Arial" pitchFamily="34" charset="0"/>
+                <a:ea typeface="Arial" pitchFamily="34" charset="-122"/>
+                <a:cs typeface="Arial" pitchFamily="34" charset="-120"/>
+              </a:rPr>
+              <a:t>Pilots accepted   412</a:t>
+            </a:r>
+            <a:endParaRPr lang="en-US" sz="1100" dirty="0"/>
+          </a:p>
+        </p:txBody>
+      </p:sp>
+      <p:sp>
+        <p:nvSpPr>
+          <p:cNvPr id="18" name="Shape 16"/>
+          <p:cNvSpPr/>
+          <p:nvPr/>
+        </p:nvSpPr>
+        <p:spPr>
+          <a:xfrm>
+            <a:off x="8130794" y="4503420"/>
+            <a:ext cx="2036572" cy="589788"/>
+          </a:xfrm>
+          <a:prstGeom prst="rect">
+            <a:avLst/>
+          </a:prstGeom>
+          <a:solidFill>
+            <a:srgbClr val="2E7CF6"/>
+          </a:solidFill>
+          <a:ln/>
+        </p:spPr>
+      </p:sp>
+      <p:sp>
+        <p:nvSpPr>
+          <p:cNvPr id="19" name="Text 17"/>
+          <p:cNvSpPr/>
+          <p:nvPr/>
+        </p:nvSpPr>
+        <p:spPr>
+          <a:xfrm>
+            <a:off x="8130794" y="4503420"/>
+            <a:ext cx="2036572" cy="589788"/>
+          </a:xfrm>
+          <a:prstGeom prst="rect">
+            <a:avLst/>
+          </a:prstGeom>
+          <a:noFill/>
+          <a:ln/>
+        </p:spPr>
+        <p:txBody>
+          <a:bodyPr wrap="square" lIns="0" tIns="0" rIns="0" bIns="0" rtlCol="0" anchor="ctr"/>
+          <a:lstStyle/>
+          <a:p>
+            <a:pPr algn="ctr" indent="0" marL="0">
+              <a:buNone/>
+            </a:pPr>
+            <a:r>
+              <a:rPr lang="en-US" sz="1100" b="1" dirty="0">
+                <a:solidFill>
+                  <a:srgbClr val="FFFFFF"/>
+                </a:solidFill>
+                <a:latin typeface="Arial" pitchFamily="34" charset="0"/>
+                <a:ea typeface="Arial" pitchFamily="34" charset="-122"/>
+                <a:cs typeface="Arial" pitchFamily="34" charset="-120"/>
+              </a:rPr>
+              <a:t>Contracts signed   108</a:t>
+            </a:r>
+            <a:endParaRPr lang="en-US" sz="1100" dirty="0"/>
+          </a:p>
+        </p:txBody>
+      </p:sp>
+      <p:sp>
+        <p:nvSpPr>
+          <p:cNvPr id="20" name="Text 18"/>
+          <p:cNvSpPr/>
+          <p:nvPr/>
+        </p:nvSpPr>
+        <p:spPr>
+          <a:xfrm>
+            <a:off x="502920" y="6419088"/>
+            <a:ext cx="10515600" cy="274320"/>
+          </a:xfrm>
+          <a:prstGeom prst="rect">
+            <a:avLst/>
+          </a:prstGeom>
+          <a:noFill/>
+          <a:ln/>
+        </p:spPr>
+        <p:txBody>
+          <a:bodyPr wrap="square" lIns="0" tIns="0" rIns="0" bIns="0" rtlCol="0" anchor="ctr"/>
+          <a:lstStyle/>
+          <a:p>
+            <a:pPr indent="0" marL="0">
+              <a:buNone/>
+            </a:pPr>
+            <a:r>
+              <a:rPr lang="en-US" sz="800" dirty="0">
+                <a:solidFill>
+                  <a:srgbClr val="8C8C8C"/>
+                </a:solidFill>
+                <a:latin typeface="Arial" pitchFamily="34" charset="0"/>
+                <a:ea typeface="Arial" pitchFamily="34" charset="-122"/>
+                <a:cs typeface="Arial" pitchFamily="34" charset="-120"/>
+              </a:rPr>
+              <a:t>Source: 42 customer interviews; pilot CRM extract, W28</a:t>
+            </a:r>
+            <a:endParaRPr lang="en-US" sz="800" dirty="0"/>
+          </a:p>
+        </p:txBody>
+      </p:sp>
+      <p:sp>
+        <p:nvSpPr>
+          <p:cNvPr id="21" name="Text 19"/>
+          <p:cNvSpPr/>
+          <p:nvPr/>
+        </p:nvSpPr>
+        <p:spPr>
+          <a:xfrm>
+            <a:off x="11292840" y="6419088"/>
+            <a:ext cx="365760" cy="274320"/>
+          </a:xfrm>
+          <a:prstGeom prst="rect">
+            <a:avLst/>
+          </a:prstGeom>
+          <a:noFill/>
+          <a:ln/>
+        </p:spPr>
+        <p:txBody>
+          <a:bodyPr wrap="square" lIns="0" tIns="0" rIns="0" bIns="0" rtlCol="0" anchor="ctr"/>
+          <a:lstStyle/>
+          <a:p>
+            <a:pPr algn="r" indent="0" marL="0">
+              <a:buNone/>
+            </a:pPr>
+            <a:r>
+              <a:rPr lang="en-US" sz="850" b="1" dirty="0">
+                <a:solidFill>
+                  <a:srgbClr val="1D5FCC"/>
+                </a:solidFill>
+                <a:latin typeface="Arial" pitchFamily="34" charset="0"/>
+                <a:ea typeface="Arial" pitchFamily="34" charset="-122"/>
+                <a:cs typeface="Arial" pitchFamily="34" charset="-120"/>
+              </a:rPr>
+              <a:t>29</a:t>
+            </a:r>
+            <a:endParaRPr lang="en-US" sz="850" dirty="0"/>
+          </a:p>
+        </p:txBody>
+      </p:sp>
+    </p:spTree>
+  </p:cSld>
+  <p:clrMapOvr>
+    <a:masterClrMapping/>
+  </p:clrMapOvr>
+</p:sld>
+</file>
+
+<file path=ppt/slides/slide34.xml><?xml version="1.0" encoding="utf-8"?>
+<p:sld xmlns:a="http://schemas.openxmlformats.org/drawingml/2006/main" xmlns:r="http://schemas.openxmlformats.org/officeDocument/2006/relationships" xmlns:p="http://schemas.openxmlformats.org/presentationml/2006/main">
+  <p:cSld name="Slide 34">
     <p:bg>
       <p:bgPr>
         <a:solidFill>

</xml_diff>

<commit_message>
Release v1.6.0: all data exhibits native & editable; free zone composition
</commit_message>
<xml_diff>
--- a/examples/golden-deck.pptx
+++ b/examples/golden-deck.pptx
@@ -26689,7 +26689,7 @@
                 <a:ea typeface="Arial" pitchFamily="34" charset="-122"/>
                 <a:cs typeface="Arial" pitchFamily="34" charset="-120"/>
               </a:rPr>
-              <a:t>EXHIBITS — SVG (COMPARISONS)</a:t>
+              <a:t>EXHIBITS — COMPARISONS</a:t>
             </a:r>
             <a:endParaRPr lang="en-US" sz="1050" dirty="0"/>
           </a:p>
@@ -26790,7 +26790,7 @@
                 <a:ea typeface="Arial" pitchFamily="34" charset="-122"/>
                 <a:cs typeface="Arial" pitchFamily="34" charset="-120"/>
               </a:rPr>
-              <a:t>Slope chart (two periods) and dumbbell (today vs target), rendered by the SVG engine.</a:t>
+              <a:t>Slope chart (two periods) and dumbbell (today vs target) — native shapes, every dot and label stays editable.</a:t>
             </a:r>
             <a:endParaRPr lang="en-US" sz="1350" dirty="0"/>
           </a:p>
@@ -26835,33 +26835,556 @@
           </a:p>
         </p:txBody>
       </p:sp>
-      <p:pic>
-        <p:nvPicPr>
-          <p:cNvPr id="7" name="Image 0" descr="/Users/othmane_benkirane/.claude/skills/sprintospptx-v3/examples/gd-assets/slope-c643eaf059.png">    </p:cNvPr>
-          <p:cNvPicPr>
-            <a:picLocks noChangeAspect="1"/>
-          </p:cNvPicPr>
-          <p:nvPr/>
-        </p:nvPicPr>
-        <p:blipFill>
-          <a:blip r:embed="rId1"/>
-          <a:stretch>
-            <a:fillRect/>
-          </a:stretch>
-        </p:blipFill>
-        <p:spPr>
-          <a:xfrm>
-            <a:off x="594360" y="2377440"/>
-            <a:ext cx="4480560" cy="3200400"/>
-          </a:xfrm>
-          <a:prstGeom prst="rect">
-            <a:avLst/>
-          </a:prstGeom>
-        </p:spPr>
-      </p:pic>
-      <p:sp>
-        <p:nvSpPr>
-          <p:cNvPr id="8" name="Text 5"/>
+      <p:sp>
+        <p:nvSpPr>
+          <p:cNvPr id="7" name="Text 5"/>
+          <p:cNvSpPr/>
+          <p:nvPr/>
+        </p:nvSpPr>
+        <p:spPr>
+          <a:xfrm>
+            <a:off x="1188720" y="2377440"/>
+            <a:ext cx="1463040" cy="274320"/>
+          </a:xfrm>
+          <a:prstGeom prst="rect">
+            <a:avLst/>
+          </a:prstGeom>
+          <a:noFill/>
+          <a:ln/>
+        </p:spPr>
+        <p:txBody>
+          <a:bodyPr wrap="square" lIns="0" tIns="0" rIns="0" bIns="0" rtlCol="0" anchor="ctr"/>
+          <a:lstStyle/>
+          <a:p>
+            <a:pPr algn="ctr" indent="0" marL="0">
+              <a:buNone/>
+            </a:pPr>
+            <a:r>
+              <a:rPr lang="en-US" sz="1300" b="1" dirty="0">
+                <a:solidFill>
+                  <a:srgbClr val="1A1A1A"/>
+                </a:solidFill>
+                <a:latin typeface="Arial" pitchFamily="34" charset="0"/>
+                <a:ea typeface="Arial" pitchFamily="34" charset="-122"/>
+                <a:cs typeface="Arial" pitchFamily="34" charset="-120"/>
+              </a:rPr>
+              <a:t>2025</a:t>
+            </a:r>
+            <a:endParaRPr lang="en-US" sz="1300" dirty="0"/>
+          </a:p>
+        </p:txBody>
+      </p:sp>
+      <p:sp>
+        <p:nvSpPr>
+          <p:cNvPr id="8" name="Text 6"/>
+          <p:cNvSpPr/>
+          <p:nvPr/>
+        </p:nvSpPr>
+        <p:spPr>
+          <a:xfrm>
+            <a:off x="3352800" y="2377440"/>
+            <a:ext cx="1463040" cy="274320"/>
+          </a:xfrm>
+          <a:prstGeom prst="rect">
+            <a:avLst/>
+          </a:prstGeom>
+          <a:noFill/>
+          <a:ln/>
+        </p:spPr>
+        <p:txBody>
+          <a:bodyPr wrap="square" lIns="0" tIns="0" rIns="0" bIns="0" rtlCol="0" anchor="ctr"/>
+          <a:lstStyle/>
+          <a:p>
+            <a:pPr algn="ctr" indent="0" marL="0">
+              <a:buNone/>
+            </a:pPr>
+            <a:r>
+              <a:rPr lang="en-US" sz="1300" b="1" dirty="0">
+                <a:solidFill>
+                  <a:srgbClr val="1A1A1A"/>
+                </a:solidFill>
+                <a:latin typeface="Arial" pitchFamily="34" charset="0"/>
+                <a:ea typeface="Arial" pitchFamily="34" charset="-122"/>
+                <a:cs typeface="Arial" pitchFamily="34" charset="-120"/>
+              </a:rPr>
+              <a:t>2029E</a:t>
+            </a:r>
+            <a:endParaRPr lang="en-US" sz="1300" dirty="0"/>
+          </a:p>
+        </p:txBody>
+      </p:sp>
+      <p:sp>
+        <p:nvSpPr>
+          <p:cNvPr id="9" name="Shape 7"/>
+          <p:cNvSpPr/>
+          <p:nvPr/>
+        </p:nvSpPr>
+        <p:spPr>
+          <a:xfrm>
+            <a:off x="1920240" y="2779776"/>
+            <a:ext cx="0" cy="2505456"/>
+          </a:xfrm>
+          <a:prstGeom prst="line">
+            <a:avLst/>
+          </a:prstGeom>
+          <a:noFill/>
+          <a:ln w="19050">
+            <a:solidFill>
+              <a:srgbClr val="E4E8ED"/>
+            </a:solidFill>
+            <a:prstDash val="solid"/>
+          </a:ln>
+        </p:spPr>
+      </p:sp>
+      <p:sp>
+        <p:nvSpPr>
+          <p:cNvPr id="10" name="Shape 8"/>
+          <p:cNvSpPr/>
+          <p:nvPr/>
+        </p:nvSpPr>
+        <p:spPr>
+          <a:xfrm>
+            <a:off x="4084320" y="2779776"/>
+            <a:ext cx="0" cy="2505456"/>
+          </a:xfrm>
+          <a:prstGeom prst="line">
+            <a:avLst/>
+          </a:prstGeom>
+          <a:noFill/>
+          <a:ln w="19050">
+            <a:solidFill>
+              <a:srgbClr val="E4E8ED"/>
+            </a:solidFill>
+            <a:prstDash val="solid"/>
+          </a:ln>
+        </p:spPr>
+      </p:sp>
+      <p:sp>
+        <p:nvSpPr>
+          <p:cNvPr id="11" name="Shape 9"/>
+          <p:cNvSpPr/>
+          <p:nvPr/>
+        </p:nvSpPr>
+        <p:spPr>
+          <a:xfrm flipV="1">
+            <a:off x="1920240" y="2834640"/>
+            <a:ext cx="2164080" cy="165223"/>
+          </a:xfrm>
+          <a:prstGeom prst="line">
+            <a:avLst/>
+          </a:prstGeom>
+          <a:noFill/>
+          <a:ln w="22225">
+            <a:solidFill>
+              <a:srgbClr val="C2CAD3"/>
+            </a:solidFill>
+            <a:prstDash val="solid"/>
+          </a:ln>
+        </p:spPr>
+      </p:sp>
+      <p:sp>
+        <p:nvSpPr>
+          <p:cNvPr id="12" name="Shape 10"/>
+          <p:cNvSpPr/>
+          <p:nvPr/>
+        </p:nvSpPr>
+        <p:spPr>
+          <a:xfrm>
+            <a:off x="1874520" y="2954143"/>
+            <a:ext cx="91440" cy="91440"/>
+          </a:xfrm>
+          <a:prstGeom prst="ellipse">
+            <a:avLst/>
+          </a:prstGeom>
+          <a:solidFill>
+            <a:srgbClr val="C2CAD3"/>
+          </a:solidFill>
+          <a:ln/>
+        </p:spPr>
+      </p:sp>
+      <p:sp>
+        <p:nvSpPr>
+          <p:cNvPr id="13" name="Shape 11"/>
+          <p:cNvSpPr/>
+          <p:nvPr/>
+        </p:nvSpPr>
+        <p:spPr>
+          <a:xfrm>
+            <a:off x="4038600" y="2788920"/>
+            <a:ext cx="91440" cy="91440"/>
+          </a:xfrm>
+          <a:prstGeom prst="ellipse">
+            <a:avLst/>
+          </a:prstGeom>
+          <a:solidFill>
+            <a:srgbClr val="C2CAD3"/>
+          </a:solidFill>
+          <a:ln/>
+        </p:spPr>
+      </p:sp>
+      <p:sp>
+        <p:nvSpPr>
+          <p:cNvPr id="14" name="Text 12"/>
+          <p:cNvSpPr/>
+          <p:nvPr/>
+        </p:nvSpPr>
+        <p:spPr>
+          <a:xfrm>
+            <a:off x="438912" y="2890135"/>
+            <a:ext cx="1371600" cy="237744"/>
+          </a:xfrm>
+          <a:prstGeom prst="rect">
+            <a:avLst/>
+          </a:prstGeom>
+          <a:noFill/>
+          <a:ln/>
+        </p:spPr>
+        <p:txBody>
+          <a:bodyPr wrap="square" lIns="0" tIns="0" rIns="0" bIns="0" rtlCol="0" anchor="ctr"/>
+          <a:lstStyle/>
+          <a:p>
+            <a:pPr algn="r" indent="0" marL="0">
+              <a:buNone/>
+            </a:pPr>
+            <a:r>
+              <a:rPr lang="en-US" sz="1050" dirty="0">
+                <a:solidFill>
+                  <a:srgbClr val="595959"/>
+                </a:solidFill>
+                <a:latin typeface="Arial" pitchFamily="34" charset="0"/>
+                <a:ea typeface="Arial" pitchFamily="34" charset="-122"/>
+                <a:cs typeface="Arial" pitchFamily="34" charset="-120"/>
+              </a:rPr>
+              <a:t>Services  46</a:t>
+            </a:r>
+            <a:endParaRPr lang="en-US" sz="1050" dirty="0"/>
+          </a:p>
+        </p:txBody>
+      </p:sp>
+      <p:sp>
+        <p:nvSpPr>
+          <p:cNvPr id="15" name="Text 13"/>
+          <p:cNvSpPr/>
+          <p:nvPr/>
+        </p:nvSpPr>
+        <p:spPr>
+          <a:xfrm>
+            <a:off x="4194048" y="2724912"/>
+            <a:ext cx="1371600" cy="237744"/>
+          </a:xfrm>
+          <a:prstGeom prst="rect">
+            <a:avLst/>
+          </a:prstGeom>
+          <a:noFill/>
+          <a:ln/>
+        </p:spPr>
+        <p:txBody>
+          <a:bodyPr wrap="square" lIns="0" tIns="0" rIns="0" bIns="0" rtlCol="0" anchor="ctr"/>
+          <a:lstStyle/>
+          <a:p>
+            <a:pPr algn="l" indent="0" marL="0">
+              <a:buNone/>
+            </a:pPr>
+            <a:r>
+              <a:rPr lang="en-US" sz="1050" dirty="0">
+                <a:solidFill>
+                  <a:srgbClr val="595959"/>
+                </a:solidFill>
+                <a:latin typeface="Arial" pitchFamily="34" charset="0"/>
+                <a:ea typeface="Arial" pitchFamily="34" charset="-122"/>
+                <a:cs typeface="Arial" pitchFamily="34" charset="-120"/>
+              </a:rPr>
+              <a:t>48  Services</a:t>
+            </a:r>
+            <a:endParaRPr lang="en-US" sz="1050" dirty="0"/>
+          </a:p>
+        </p:txBody>
+      </p:sp>
+      <p:sp>
+        <p:nvSpPr>
+          <p:cNvPr id="16" name="Shape 14"/>
+          <p:cNvSpPr/>
+          <p:nvPr/>
+        </p:nvSpPr>
+        <p:spPr>
+          <a:xfrm flipV="1">
+            <a:off x="1920240" y="3991198"/>
+            <a:ext cx="2164080" cy="495668"/>
+          </a:xfrm>
+          <a:prstGeom prst="line">
+            <a:avLst/>
+          </a:prstGeom>
+          <a:noFill/>
+          <a:ln w="34925">
+            <a:solidFill>
+              <a:srgbClr val="2E7CF6"/>
+            </a:solidFill>
+            <a:prstDash val="solid"/>
+          </a:ln>
+        </p:spPr>
+      </p:sp>
+      <p:sp>
+        <p:nvSpPr>
+          <p:cNvPr id="17" name="Shape 15"/>
+          <p:cNvSpPr/>
+          <p:nvPr/>
+        </p:nvSpPr>
+        <p:spPr>
+          <a:xfrm>
+            <a:off x="1874520" y="4441146"/>
+            <a:ext cx="91440" cy="91440"/>
+          </a:xfrm>
+          <a:prstGeom prst="ellipse">
+            <a:avLst/>
+          </a:prstGeom>
+          <a:solidFill>
+            <a:srgbClr val="2E7CF6"/>
+          </a:solidFill>
+          <a:ln/>
+        </p:spPr>
+      </p:sp>
+      <p:sp>
+        <p:nvSpPr>
+          <p:cNvPr id="18" name="Shape 16"/>
+          <p:cNvSpPr/>
+          <p:nvPr/>
+        </p:nvSpPr>
+        <p:spPr>
+          <a:xfrm>
+            <a:off x="4038600" y="3945478"/>
+            <a:ext cx="91440" cy="91440"/>
+          </a:xfrm>
+          <a:prstGeom prst="ellipse">
+            <a:avLst/>
+          </a:prstGeom>
+          <a:solidFill>
+            <a:srgbClr val="2E7CF6"/>
+          </a:solidFill>
+          <a:ln/>
+        </p:spPr>
+      </p:sp>
+      <p:sp>
+        <p:nvSpPr>
+          <p:cNvPr id="19" name="Text 17"/>
+          <p:cNvSpPr/>
+          <p:nvPr/>
+        </p:nvSpPr>
+        <p:spPr>
+          <a:xfrm>
+            <a:off x="438912" y="4377138"/>
+            <a:ext cx="1371600" cy="237744"/>
+          </a:xfrm>
+          <a:prstGeom prst="rect">
+            <a:avLst/>
+          </a:prstGeom>
+          <a:noFill/>
+          <a:ln/>
+        </p:spPr>
+        <p:txBody>
+          <a:bodyPr wrap="square" lIns="0" tIns="0" rIns="0" bIns="0" rtlCol="0" anchor="ctr"/>
+          <a:lstStyle/>
+          <a:p>
+            <a:pPr algn="r" indent="0" marL="0">
+              <a:buNone/>
+            </a:pPr>
+            <a:r>
+              <a:rPr lang="en-US" sz="1050" b="1" dirty="0">
+                <a:solidFill>
+                  <a:srgbClr val="1A1A1A"/>
+                </a:solidFill>
+                <a:latin typeface="Arial" pitchFamily="34" charset="0"/>
+                <a:ea typeface="Arial" pitchFamily="34" charset="-122"/>
+                <a:cs typeface="Arial" pitchFamily="34" charset="-120"/>
+              </a:rPr>
+              <a:t>Group  28</a:t>
+            </a:r>
+            <a:endParaRPr lang="en-US" sz="1050" dirty="0"/>
+          </a:p>
+        </p:txBody>
+      </p:sp>
+      <p:sp>
+        <p:nvSpPr>
+          <p:cNvPr id="20" name="Text 18"/>
+          <p:cNvSpPr/>
+          <p:nvPr/>
+        </p:nvSpPr>
+        <p:spPr>
+          <a:xfrm>
+            <a:off x="4194048" y="3881470"/>
+            <a:ext cx="1371600" cy="237744"/>
+          </a:xfrm>
+          <a:prstGeom prst="rect">
+            <a:avLst/>
+          </a:prstGeom>
+          <a:noFill/>
+          <a:ln/>
+        </p:spPr>
+        <p:txBody>
+          <a:bodyPr wrap="square" lIns="0" tIns="0" rIns="0" bIns="0" rtlCol="0" anchor="ctr"/>
+          <a:lstStyle/>
+          <a:p>
+            <a:pPr algn="l" indent="0" marL="0">
+              <a:buNone/>
+            </a:pPr>
+            <a:r>
+              <a:rPr lang="en-US" sz="1050" b="1" dirty="0">
+                <a:solidFill>
+                  <a:srgbClr val="1A1A1A"/>
+                </a:solidFill>
+                <a:latin typeface="Arial" pitchFamily="34" charset="0"/>
+                <a:ea typeface="Arial" pitchFamily="34" charset="-122"/>
+                <a:cs typeface="Arial" pitchFamily="34" charset="-120"/>
+              </a:rPr>
+              <a:t>34  Group</a:t>
+            </a:r>
+            <a:endParaRPr lang="en-US" sz="1050" dirty="0"/>
+          </a:p>
+        </p:txBody>
+      </p:sp>
+      <p:sp>
+        <p:nvSpPr>
+          <p:cNvPr id="21" name="Shape 19"/>
+          <p:cNvSpPr/>
+          <p:nvPr/>
+        </p:nvSpPr>
+        <p:spPr>
+          <a:xfrm>
+            <a:off x="1920240" y="5147757"/>
+            <a:ext cx="2164080" cy="82611"/>
+          </a:xfrm>
+          <a:prstGeom prst="line">
+            <a:avLst/>
+          </a:prstGeom>
+          <a:noFill/>
+          <a:ln w="22225">
+            <a:solidFill>
+              <a:srgbClr val="C2CAD3"/>
+            </a:solidFill>
+            <a:prstDash val="solid"/>
+          </a:ln>
+        </p:spPr>
+      </p:sp>
+      <p:sp>
+        <p:nvSpPr>
+          <p:cNvPr id="22" name="Shape 20"/>
+          <p:cNvSpPr/>
+          <p:nvPr/>
+        </p:nvSpPr>
+        <p:spPr>
+          <a:xfrm>
+            <a:off x="1874520" y="5102037"/>
+            <a:ext cx="91440" cy="91440"/>
+          </a:xfrm>
+          <a:prstGeom prst="ellipse">
+            <a:avLst/>
+          </a:prstGeom>
+          <a:solidFill>
+            <a:srgbClr val="C2CAD3"/>
+          </a:solidFill>
+          <a:ln/>
+        </p:spPr>
+      </p:sp>
+      <p:sp>
+        <p:nvSpPr>
+          <p:cNvPr id="23" name="Shape 21"/>
+          <p:cNvSpPr/>
+          <p:nvPr/>
+        </p:nvSpPr>
+        <p:spPr>
+          <a:xfrm>
+            <a:off x="4038600" y="5184648"/>
+            <a:ext cx="91440" cy="91440"/>
+          </a:xfrm>
+          <a:prstGeom prst="ellipse">
+            <a:avLst/>
+          </a:prstGeom>
+          <a:solidFill>
+            <a:srgbClr val="C2CAD3"/>
+          </a:solidFill>
+          <a:ln/>
+        </p:spPr>
+      </p:sp>
+      <p:sp>
+        <p:nvSpPr>
+          <p:cNvPr id="24" name="Text 22"/>
+          <p:cNvSpPr/>
+          <p:nvPr/>
+        </p:nvSpPr>
+        <p:spPr>
+          <a:xfrm>
+            <a:off x="438912" y="5038029"/>
+            <a:ext cx="1371600" cy="237744"/>
+          </a:xfrm>
+          <a:prstGeom prst="rect">
+            <a:avLst/>
+          </a:prstGeom>
+          <a:noFill/>
+          <a:ln/>
+        </p:spPr>
+        <p:txBody>
+          <a:bodyPr wrap="square" lIns="0" tIns="0" rIns="0" bIns="0" rtlCol="0" anchor="ctr"/>
+          <a:lstStyle/>
+          <a:p>
+            <a:pPr algn="r" indent="0" marL="0">
+              <a:buNone/>
+            </a:pPr>
+            <a:r>
+              <a:rPr lang="en-US" sz="1050" dirty="0">
+                <a:solidFill>
+                  <a:srgbClr val="595959"/>
+                </a:solidFill>
+                <a:latin typeface="Arial" pitchFamily="34" charset="0"/>
+                <a:ea typeface="Arial" pitchFamily="34" charset="-122"/>
+                <a:cs typeface="Arial" pitchFamily="34" charset="-120"/>
+              </a:rPr>
+              <a:t>Equipment  20</a:t>
+            </a:r>
+            <a:endParaRPr lang="en-US" sz="1050" dirty="0"/>
+          </a:p>
+        </p:txBody>
+      </p:sp>
+      <p:sp>
+        <p:nvSpPr>
+          <p:cNvPr id="25" name="Text 23"/>
+          <p:cNvSpPr/>
+          <p:nvPr/>
+        </p:nvSpPr>
+        <p:spPr>
+          <a:xfrm>
+            <a:off x="4194048" y="5120640"/>
+            <a:ext cx="1371600" cy="237744"/>
+          </a:xfrm>
+          <a:prstGeom prst="rect">
+            <a:avLst/>
+          </a:prstGeom>
+          <a:noFill/>
+          <a:ln/>
+        </p:spPr>
+        <p:txBody>
+          <a:bodyPr wrap="square" lIns="0" tIns="0" rIns="0" bIns="0" rtlCol="0" anchor="ctr"/>
+          <a:lstStyle/>
+          <a:p>
+            <a:pPr algn="l" indent="0" marL="0">
+              <a:buNone/>
+            </a:pPr>
+            <a:r>
+              <a:rPr lang="en-US" sz="1050" dirty="0">
+                <a:solidFill>
+                  <a:srgbClr val="595959"/>
+                </a:solidFill>
+                <a:latin typeface="Arial" pitchFamily="34" charset="0"/>
+                <a:ea typeface="Arial" pitchFamily="34" charset="-122"/>
+                <a:cs typeface="Arial" pitchFamily="34" charset="-120"/>
+              </a:rPr>
+              <a:t>19  Equipment</a:t>
+            </a:r>
+            <a:endParaRPr lang="en-US" sz="1050" dirty="0"/>
+          </a:p>
+        </p:txBody>
+      </p:sp>
+      <p:sp>
+        <p:nvSpPr>
+          <p:cNvPr id="26" name="Text 24"/>
           <p:cNvSpPr/>
           <p:nvPr/>
         </p:nvSpPr>
@@ -26898,33 +27421,513 @@
           </a:p>
         </p:txBody>
       </p:sp>
-      <p:pic>
-        <p:nvPicPr>
-          <p:cNvPr id="9" name="Image 1" descr="/Users/othmane_benkirane/.claude/skills/sprintospptx-v3/examples/gd-assets/dumbbell-cbcde06d46.png">    </p:cNvPr>
-          <p:cNvPicPr>
-            <a:picLocks noChangeAspect="1"/>
-          </p:cNvPicPr>
-          <p:nvPr/>
-        </p:nvPicPr>
-        <p:blipFill>
-          <a:blip r:embed="rId2"/>
-          <a:stretch>
-            <a:fillRect/>
-          </a:stretch>
-        </p:blipFill>
-        <p:spPr>
-          <a:xfrm>
-            <a:off x="6096000" y="2514600"/>
-            <a:ext cx="5029200" cy="2834640"/>
-          </a:xfrm>
-          <a:prstGeom prst="rect">
-            <a:avLst/>
-          </a:prstGeom>
-        </p:spPr>
-      </p:pic>
-      <p:sp>
-        <p:nvSpPr>
-          <p:cNvPr id="10" name="Text 6"/>
+      <p:sp>
+        <p:nvSpPr>
+          <p:cNvPr id="27" name="Text 25"/>
+          <p:cNvSpPr/>
+          <p:nvPr/>
+        </p:nvSpPr>
+        <p:spPr>
+          <a:xfrm>
+            <a:off x="7696200" y="2423160"/>
+            <a:ext cx="3870960" cy="256032"/>
+          </a:xfrm>
+          <a:prstGeom prst="rect">
+            <a:avLst/>
+          </a:prstGeom>
+          <a:noFill/>
+          <a:ln/>
+        </p:spPr>
+        <p:txBody>
+          <a:bodyPr wrap="square" lIns="0" tIns="0" rIns="0" bIns="0" rtlCol="0" anchor="ctr"/>
+          <a:lstStyle/>
+          <a:p>
+            <a:pPr indent="0" marL="0">
+              <a:buNone/>
+            </a:pPr>
+            <a:r>
+              <a:rPr lang="en-US" sz="1050" dirty="0">
+                <a:solidFill>
+                  <a:srgbClr val="C2CAD3"/>
+                </a:solidFill>
+                <a:latin typeface="Arial" pitchFamily="34" charset="0"/>
+                <a:ea typeface="Arial" pitchFamily="34" charset="-122"/>
+                <a:cs typeface="Arial" pitchFamily="34" charset="-120"/>
+              </a:rPr>
+              <a:t>● </a:t>
+            </a:r>
+            <a:pPr indent="0" marL="0">
+              <a:buNone/>
+            </a:pPr>
+            <a:r>
+              <a:rPr lang="en-US" sz="1050" b="1" dirty="0">
+                <a:solidFill>
+                  <a:srgbClr val="595959"/>
+                </a:solidFill>
+                <a:latin typeface="Arial" pitchFamily="34" charset="0"/>
+                <a:ea typeface="Arial" pitchFamily="34" charset="-122"/>
+                <a:cs typeface="Arial" pitchFamily="34" charset="-120"/>
+              </a:rPr>
+              <a:t>Today    </a:t>
+            </a:r>
+            <a:pPr indent="0" marL="0">
+              <a:buNone/>
+            </a:pPr>
+            <a:r>
+              <a:rPr lang="en-US" sz="1050" dirty="0">
+                <a:solidFill>
+                  <a:srgbClr val="2E7CF6"/>
+                </a:solidFill>
+                <a:latin typeface="Arial" pitchFamily="34" charset="0"/>
+                <a:ea typeface="Arial" pitchFamily="34" charset="-122"/>
+                <a:cs typeface="Arial" pitchFamily="34" charset="-120"/>
+              </a:rPr>
+              <a:t>● </a:t>
+            </a:r>
+            <a:pPr indent="0" marL="0">
+              <a:buNone/>
+            </a:pPr>
+            <a:r>
+              <a:rPr lang="en-US" sz="1050" b="1" dirty="0">
+                <a:solidFill>
+                  <a:srgbClr val="1D5FCC"/>
+                </a:solidFill>
+                <a:latin typeface="Arial" pitchFamily="34" charset="0"/>
+                <a:ea typeface="Arial" pitchFamily="34" charset="-122"/>
+                <a:cs typeface="Arial" pitchFamily="34" charset="-120"/>
+              </a:rPr>
+              <a:t>2029 target</a:t>
+            </a:r>
+            <a:endParaRPr lang="en-US" sz="1050" dirty="0"/>
+          </a:p>
+        </p:txBody>
+      </p:sp>
+      <p:sp>
+        <p:nvSpPr>
+          <p:cNvPr id="28" name="Text 26"/>
+          <p:cNvSpPr/>
+          <p:nvPr/>
+        </p:nvSpPr>
+        <p:spPr>
+          <a:xfrm>
+            <a:off x="5958840" y="3130296"/>
+            <a:ext cx="1627632" cy="256032"/>
+          </a:xfrm>
+          <a:prstGeom prst="rect">
+            <a:avLst/>
+          </a:prstGeom>
+          <a:noFill/>
+          <a:ln/>
+        </p:spPr>
+        <p:txBody>
+          <a:bodyPr wrap="square" lIns="0" tIns="0" rIns="0" bIns="0" rtlCol="0" anchor="ctr"/>
+          <a:lstStyle/>
+          <a:p>
+            <a:pPr algn="r" indent="0" marL="0">
+              <a:buNone/>
+            </a:pPr>
+            <a:r>
+              <a:rPr lang="en-US" sz="1050" b="1" dirty="0">
+                <a:solidFill>
+                  <a:srgbClr val="1A1A1A"/>
+                </a:solidFill>
+                <a:latin typeface="Arial" pitchFamily="34" charset="0"/>
+                <a:ea typeface="Arial" pitchFamily="34" charset="-122"/>
+                <a:cs typeface="Arial" pitchFamily="34" charset="-120"/>
+              </a:rPr>
+              <a:t>Parts capture %</a:t>
+            </a:r>
+            <a:endParaRPr lang="en-US" sz="1050" dirty="0"/>
+          </a:p>
+        </p:txBody>
+      </p:sp>
+      <p:sp>
+        <p:nvSpPr>
+          <p:cNvPr id="29" name="Shape 27"/>
+          <p:cNvSpPr/>
+          <p:nvPr/>
+        </p:nvSpPr>
+        <p:spPr>
+          <a:xfrm>
+            <a:off x="8856303" y="3249168"/>
+            <a:ext cx="1085257" cy="0"/>
+          </a:xfrm>
+          <a:prstGeom prst="line">
+            <a:avLst/>
+          </a:prstGeom>
+          <a:noFill/>
+          <a:ln w="44450">
+            <a:solidFill>
+              <a:srgbClr val="DCE1E7"/>
+            </a:solidFill>
+            <a:prstDash val="solid"/>
+          </a:ln>
+        </p:spPr>
+      </p:sp>
+      <p:sp>
+        <p:nvSpPr>
+          <p:cNvPr id="30" name="Shape 28"/>
+          <p:cNvSpPr/>
+          <p:nvPr/>
+        </p:nvSpPr>
+        <p:spPr>
+          <a:xfrm>
+            <a:off x="8783151" y="3176016"/>
+            <a:ext cx="146304" cy="146304"/>
+          </a:xfrm>
+          <a:prstGeom prst="ellipse">
+            <a:avLst/>
+          </a:prstGeom>
+          <a:solidFill>
+            <a:srgbClr val="C2CAD3"/>
+          </a:solidFill>
+          <a:ln/>
+        </p:spPr>
+      </p:sp>
+      <p:sp>
+        <p:nvSpPr>
+          <p:cNvPr id="31" name="Shape 29"/>
+          <p:cNvSpPr/>
+          <p:nvPr/>
+        </p:nvSpPr>
+        <p:spPr>
+          <a:xfrm>
+            <a:off x="9868408" y="3176016"/>
+            <a:ext cx="146304" cy="146304"/>
+          </a:xfrm>
+          <a:prstGeom prst="ellipse">
+            <a:avLst/>
+          </a:prstGeom>
+          <a:solidFill>
+            <a:srgbClr val="2E7CF6"/>
+          </a:solidFill>
+          <a:ln/>
+        </p:spPr>
+      </p:sp>
+      <p:sp>
+        <p:nvSpPr>
+          <p:cNvPr id="32" name="Text 30"/>
+          <p:cNvSpPr/>
+          <p:nvPr/>
+        </p:nvSpPr>
+        <p:spPr>
+          <a:xfrm>
+            <a:off x="10051288" y="3130296"/>
+            <a:ext cx="640080" cy="256032"/>
+          </a:xfrm>
+          <a:prstGeom prst="rect">
+            <a:avLst/>
+          </a:prstGeom>
+          <a:noFill/>
+          <a:ln/>
+        </p:spPr>
+        <p:txBody>
+          <a:bodyPr wrap="square" lIns="0" tIns="0" rIns="0" bIns="0" rtlCol="0" anchor="ctr"/>
+          <a:lstStyle/>
+          <a:p>
+            <a:pPr indent="0" marL="0">
+              <a:buNone/>
+            </a:pPr>
+            <a:r>
+              <a:rPr lang="en-US" sz="1050" b="1" dirty="0">
+                <a:solidFill>
+                  <a:srgbClr val="1D5FCC"/>
+                </a:solidFill>
+                <a:latin typeface="Arial" pitchFamily="34" charset="0"/>
+                <a:ea typeface="Arial" pitchFamily="34" charset="-122"/>
+                <a:cs typeface="Arial" pitchFamily="34" charset="-120"/>
+              </a:rPr>
+              <a:t>60</a:t>
+            </a:r>
+            <a:endParaRPr lang="en-US" sz="1050" dirty="0"/>
+          </a:p>
+        </p:txBody>
+      </p:sp>
+      <p:sp>
+        <p:nvSpPr>
+          <p:cNvPr id="33" name="Text 31"/>
+          <p:cNvSpPr/>
+          <p:nvPr/>
+        </p:nvSpPr>
+        <p:spPr>
+          <a:xfrm>
+            <a:off x="5958840" y="3867912"/>
+            <a:ext cx="1627632" cy="256032"/>
+          </a:xfrm>
+          <a:prstGeom prst="rect">
+            <a:avLst/>
+          </a:prstGeom>
+          <a:noFill/>
+          <a:ln/>
+        </p:spPr>
+        <p:txBody>
+          <a:bodyPr wrap="square" lIns="0" tIns="0" rIns="0" bIns="0" rtlCol="0" anchor="ctr"/>
+          <a:lstStyle/>
+          <a:p>
+            <a:pPr algn="r" indent="0" marL="0">
+              <a:buNone/>
+            </a:pPr>
+            <a:r>
+              <a:rPr lang="en-US" sz="1050" b="1" dirty="0">
+                <a:solidFill>
+                  <a:srgbClr val="1A1A1A"/>
+                </a:solidFill>
+                <a:latin typeface="Arial" pitchFamily="34" charset="0"/>
+                <a:ea typeface="Arial" pitchFamily="34" charset="-122"/>
+                <a:cs typeface="Arial" pitchFamily="34" charset="-120"/>
+              </a:rPr>
+              <a:t>Contract attach %</a:t>
+            </a:r>
+            <a:endParaRPr lang="en-US" sz="1050" dirty="0"/>
+          </a:p>
+        </p:txBody>
+      </p:sp>
+      <p:sp>
+        <p:nvSpPr>
+          <p:cNvPr id="34" name="Shape 32"/>
+          <p:cNvSpPr/>
+          <p:nvPr/>
+        </p:nvSpPr>
+        <p:spPr>
+          <a:xfrm>
+            <a:off x="8145272" y="3986784"/>
+            <a:ext cx="523917" cy="0"/>
+          </a:xfrm>
+          <a:prstGeom prst="line">
+            <a:avLst/>
+          </a:prstGeom>
+          <a:noFill/>
+          <a:ln w="44450">
+            <a:solidFill>
+              <a:srgbClr val="DCE1E7"/>
+            </a:solidFill>
+            <a:prstDash val="solid"/>
+          </a:ln>
+        </p:spPr>
+      </p:sp>
+      <p:sp>
+        <p:nvSpPr>
+          <p:cNvPr id="35" name="Shape 33"/>
+          <p:cNvSpPr/>
+          <p:nvPr/>
+        </p:nvSpPr>
+        <p:spPr>
+          <a:xfrm>
+            <a:off x="8072120" y="3913632"/>
+            <a:ext cx="146304" cy="146304"/>
+          </a:xfrm>
+          <a:prstGeom prst="ellipse">
+            <a:avLst/>
+          </a:prstGeom>
+          <a:solidFill>
+            <a:srgbClr val="C2CAD3"/>
+          </a:solidFill>
+          <a:ln/>
+        </p:spPr>
+      </p:sp>
+      <p:sp>
+        <p:nvSpPr>
+          <p:cNvPr id="36" name="Shape 34"/>
+          <p:cNvSpPr/>
+          <p:nvPr/>
+        </p:nvSpPr>
+        <p:spPr>
+          <a:xfrm>
+            <a:off x="8596037" y="3913632"/>
+            <a:ext cx="146304" cy="146304"/>
+          </a:xfrm>
+          <a:prstGeom prst="ellipse">
+            <a:avLst/>
+          </a:prstGeom>
+          <a:solidFill>
+            <a:srgbClr val="2E7CF6"/>
+          </a:solidFill>
+          <a:ln/>
+        </p:spPr>
+      </p:sp>
+      <p:sp>
+        <p:nvSpPr>
+          <p:cNvPr id="37" name="Text 35"/>
+          <p:cNvSpPr/>
+          <p:nvPr/>
+        </p:nvSpPr>
+        <p:spPr>
+          <a:xfrm>
+            <a:off x="8778917" y="3867912"/>
+            <a:ext cx="640080" cy="256032"/>
+          </a:xfrm>
+          <a:prstGeom prst="rect">
+            <a:avLst/>
+          </a:prstGeom>
+          <a:noFill/>
+          <a:ln/>
+        </p:spPr>
+        <p:txBody>
+          <a:bodyPr wrap="square" lIns="0" tIns="0" rIns="0" bIns="0" rtlCol="0" anchor="ctr"/>
+          <a:lstStyle/>
+          <a:p>
+            <a:pPr indent="0" marL="0">
+              <a:buNone/>
+            </a:pPr>
+            <a:r>
+              <a:rPr lang="en-US" sz="1050" b="1" dirty="0">
+                <a:solidFill>
+                  <a:srgbClr val="1D5FCC"/>
+                </a:solidFill>
+                <a:latin typeface="Arial" pitchFamily="34" charset="0"/>
+                <a:ea typeface="Arial" pitchFamily="34" charset="-122"/>
+                <a:cs typeface="Arial" pitchFamily="34" charset="-120"/>
+              </a:rPr>
+              <a:t>26</a:t>
+            </a:r>
+            <a:endParaRPr lang="en-US" sz="1050" dirty="0"/>
+          </a:p>
+        </p:txBody>
+      </p:sp>
+      <p:sp>
+        <p:nvSpPr>
+          <p:cNvPr id="38" name="Text 36"/>
+          <p:cNvSpPr/>
+          <p:nvPr/>
+        </p:nvSpPr>
+        <p:spPr>
+          <a:xfrm>
+            <a:off x="5958840" y="4605528"/>
+            <a:ext cx="1627632" cy="256032"/>
+          </a:xfrm>
+          <a:prstGeom prst="rect">
+            <a:avLst/>
+          </a:prstGeom>
+          <a:noFill/>
+          <a:ln/>
+        </p:spPr>
+        <p:txBody>
+          <a:bodyPr wrap="square" lIns="0" tIns="0" rIns="0" bIns="0" rtlCol="0" anchor="ctr"/>
+          <a:lstStyle/>
+          <a:p>
+            <a:pPr algn="r" indent="0" marL="0">
+              <a:buNone/>
+            </a:pPr>
+            <a:r>
+              <a:rPr lang="en-US" sz="1050" b="1" dirty="0">
+                <a:solidFill>
+                  <a:srgbClr val="1A1A1A"/>
+                </a:solidFill>
+                <a:latin typeface="Arial" pitchFamily="34" charset="0"/>
+                <a:ea typeface="Arial" pitchFamily="34" charset="-122"/>
+                <a:cs typeface="Arial" pitchFamily="34" charset="-120"/>
+              </a:rPr>
+              <a:t>Tech utilization %</a:t>
+            </a:r>
+            <a:endParaRPr lang="en-US" sz="1050" dirty="0"/>
+          </a:p>
+        </p:txBody>
+      </p:sp>
+      <p:sp>
+        <p:nvSpPr>
+          <p:cNvPr id="39" name="Shape 37"/>
+          <p:cNvSpPr/>
+          <p:nvPr/>
+        </p:nvSpPr>
+        <p:spPr>
+          <a:xfrm>
+            <a:off x="9978983" y="4724400"/>
+            <a:ext cx="636185" cy="0"/>
+          </a:xfrm>
+          <a:prstGeom prst="line">
+            <a:avLst/>
+          </a:prstGeom>
+          <a:noFill/>
+          <a:ln w="44450">
+            <a:solidFill>
+              <a:srgbClr val="DCE1E7"/>
+            </a:solidFill>
+            <a:prstDash val="solid"/>
+          </a:ln>
+        </p:spPr>
+      </p:sp>
+      <p:sp>
+        <p:nvSpPr>
+          <p:cNvPr id="40" name="Shape 38"/>
+          <p:cNvSpPr/>
+          <p:nvPr/>
+        </p:nvSpPr>
+        <p:spPr>
+          <a:xfrm>
+            <a:off x="9905831" y="4651248"/>
+            <a:ext cx="146304" cy="146304"/>
+          </a:xfrm>
+          <a:prstGeom prst="ellipse">
+            <a:avLst/>
+          </a:prstGeom>
+          <a:solidFill>
+            <a:srgbClr val="C2CAD3"/>
+          </a:solidFill>
+          <a:ln/>
+        </p:spPr>
+      </p:sp>
+      <p:sp>
+        <p:nvSpPr>
+          <p:cNvPr id="41" name="Shape 39"/>
+          <p:cNvSpPr/>
+          <p:nvPr/>
+        </p:nvSpPr>
+        <p:spPr>
+          <a:xfrm>
+            <a:off x="10542016" y="4651248"/>
+            <a:ext cx="146304" cy="146304"/>
+          </a:xfrm>
+          <a:prstGeom prst="ellipse">
+            <a:avLst/>
+          </a:prstGeom>
+          <a:solidFill>
+            <a:srgbClr val="2E7CF6"/>
+          </a:solidFill>
+          <a:ln/>
+        </p:spPr>
+      </p:sp>
+      <p:sp>
+        <p:nvSpPr>
+          <p:cNvPr id="42" name="Text 40"/>
+          <p:cNvSpPr/>
+          <p:nvPr/>
+        </p:nvSpPr>
+        <p:spPr>
+          <a:xfrm>
+            <a:off x="10724896" y="4605528"/>
+            <a:ext cx="640080" cy="256032"/>
+          </a:xfrm>
+          <a:prstGeom prst="rect">
+            <a:avLst/>
+          </a:prstGeom>
+          <a:noFill/>
+          <a:ln/>
+        </p:spPr>
+        <p:txBody>
+          <a:bodyPr wrap="square" lIns="0" tIns="0" rIns="0" bIns="0" rtlCol="0" anchor="ctr"/>
+          <a:lstStyle/>
+          <a:p>
+            <a:pPr indent="0" marL="0">
+              <a:buNone/>
+            </a:pPr>
+            <a:r>
+              <a:rPr lang="en-US" sz="1050" b="1" dirty="0">
+                <a:solidFill>
+                  <a:srgbClr val="1D5FCC"/>
+                </a:solidFill>
+                <a:latin typeface="Arial" pitchFamily="34" charset="0"/>
+                <a:ea typeface="Arial" pitchFamily="34" charset="-122"/>
+                <a:cs typeface="Arial" pitchFamily="34" charset="-120"/>
+              </a:rPr>
+              <a:t>78</a:t>
+            </a:r>
+            <a:endParaRPr lang="en-US" sz="1050" dirty="0"/>
+          </a:p>
+        </p:txBody>
+      </p:sp>
+      <p:sp>
+        <p:nvSpPr>
+          <p:cNvPr id="43" name="Text 41"/>
           <p:cNvSpPr/>
           <p:nvPr/>
         </p:nvSpPr>
@@ -26963,7 +27966,7 @@
       </p:sp>
       <p:sp>
         <p:nvSpPr>
-          <p:cNvPr id="11" name="Text 7"/>
+          <p:cNvPr id="44" name="Text 42"/>
           <p:cNvSpPr/>
           <p:nvPr/>
         </p:nvSpPr>
@@ -27065,7 +28068,7 @@
                 <a:ea typeface="Arial" pitchFamily="34" charset="-122"/>
                 <a:cs typeface="Arial" pitchFamily="34" charset="-120"/>
               </a:rPr>
-              <a:t>EXHIBITS — SVG (STRUCTURE)</a:t>
+              <a:t>EXHIBITS — STRUCTURE</a:t>
             </a:r>
             <a:endParaRPr lang="en-US" sz="1050" dirty="0"/>
           </a:p>
@@ -27166,7 +28169,7 @@
                 <a:ea typeface="Arial" pitchFamily="34" charset="-122"/>
                 <a:cs typeface="Arial" pitchFamily="34" charset="-120"/>
               </a:rPr>
-              <a:t>Marimekko (two-dimensional mix), waffle (memorable proportion) and Venn (where the premium wins).</a:t>
+              <a:t>Marimekko (two-dimensional mix), waffle (memorable proportion) and Venn — native shapes, fully editable.</a:t>
             </a:r>
             <a:endParaRPr lang="en-US" sz="1350" dirty="0"/>
           </a:p>
@@ -27181,7 +28184,7 @@
         <p:spPr>
           <a:xfrm>
             <a:off x="502920" y="1993392"/>
-            <a:ext cx="3587675" cy="237744"/>
+            <a:ext cx="3431689" cy="237744"/>
           </a:xfrm>
           <a:prstGeom prst="rect">
             <a:avLst/>
@@ -27211,40 +28214,41 @@
           </a:p>
         </p:txBody>
       </p:sp>
-      <p:pic>
-        <p:nvPicPr>
-          <p:cNvPr id="7" name="Image 0" descr="/Users/othmane_benkirane/.claude/skills/sprintospptx-v3/examples/gd-assets/mekko-ee7d0ed49d.png">    </p:cNvPr>
-          <p:cNvPicPr>
-            <a:picLocks noChangeAspect="1"/>
-          </p:cNvPicPr>
-          <p:nvPr/>
-        </p:nvPicPr>
-        <p:blipFill>
-          <a:blip r:embed="rId1"/>
-          <a:stretch>
-            <a:fillRect/>
-          </a:stretch>
-        </p:blipFill>
+      <p:sp>
+        <p:nvSpPr>
+          <p:cNvPr id="7" name="Shape 5"/>
+          <p:cNvSpPr/>
+          <p:nvPr/>
+        </p:nvSpPr>
         <p:spPr>
           <a:xfrm>
             <a:off x="502920" y="2423160"/>
-            <a:ext cx="3450515" cy="2463668"/>
-          </a:xfrm>
-          <a:prstGeom prst="rect">
-            <a:avLst/>
-          </a:prstGeom>
-        </p:spPr>
-      </p:pic>
-      <p:sp>
-        <p:nvSpPr>
-          <p:cNvPr id="8" name="Text 5"/>
-          <p:cNvSpPr/>
-          <p:nvPr/>
-        </p:nvSpPr>
-        <p:spPr>
-          <a:xfrm>
-            <a:off x="4364915" y="1993392"/>
-            <a:ext cx="3899647" cy="237744"/>
+            <a:ext cx="2034459" cy="1410005"/>
+          </a:xfrm>
+          <a:prstGeom prst="rect">
+            <a:avLst/>
+          </a:prstGeom>
+          <a:solidFill>
+            <a:srgbClr val="2E7CF6"/>
+          </a:solidFill>
+          <a:ln w="12700">
+            <a:solidFill>
+              <a:srgbClr val="FFFFFF"/>
+            </a:solidFill>
+            <a:prstDash val="solid"/>
+          </a:ln>
+        </p:spPr>
+      </p:sp>
+      <p:sp>
+        <p:nvSpPr>
+          <p:cNvPr id="8" name="Text 6"/>
+          <p:cNvSpPr/>
+          <p:nvPr/>
+        </p:nvSpPr>
+        <p:spPr>
+          <a:xfrm>
+            <a:off x="502920" y="3009290"/>
+            <a:ext cx="2034459" cy="237744"/>
           </a:xfrm>
           <a:prstGeom prst="rect">
             <a:avLst/>
@@ -27256,6 +28260,379 @@
           <a:bodyPr wrap="square" lIns="0" tIns="0" rIns="0" bIns="0" rtlCol="0" anchor="ctr"/>
           <a:lstStyle/>
           <a:p>
+            <a:pPr algn="ctr" indent="0" marL="0">
+              <a:buNone/>
+            </a:pPr>
+            <a:r>
+              <a:rPr lang="en-US" sz="1000" b="1" dirty="0">
+                <a:solidFill>
+                  <a:srgbClr val="FFFFFF"/>
+                </a:solidFill>
+                <a:latin typeface="Arial" pitchFamily="34" charset="0"/>
+                <a:ea typeface="Arial" pitchFamily="34" charset="-122"/>
+                <a:cs typeface="Arial" pitchFamily="34" charset="-120"/>
+              </a:rPr>
+              <a:t>60%</a:t>
+            </a:r>
+            <a:endParaRPr lang="en-US" sz="1000" dirty="0"/>
+          </a:p>
+        </p:txBody>
+      </p:sp>
+      <p:sp>
+        <p:nvSpPr>
+          <p:cNvPr id="9" name="Shape 7"/>
+          <p:cNvSpPr/>
+          <p:nvPr/>
+        </p:nvSpPr>
+        <p:spPr>
+          <a:xfrm>
+            <a:off x="502920" y="3833165"/>
+            <a:ext cx="2034459" cy="940003"/>
+          </a:xfrm>
+          <a:prstGeom prst="rect">
+            <a:avLst/>
+          </a:prstGeom>
+          <a:solidFill>
+            <a:srgbClr val="AFC9F0"/>
+          </a:solidFill>
+          <a:ln w="12700">
+            <a:solidFill>
+              <a:srgbClr val="FFFFFF"/>
+            </a:solidFill>
+            <a:prstDash val="solid"/>
+          </a:ln>
+        </p:spPr>
+      </p:sp>
+      <p:sp>
+        <p:nvSpPr>
+          <p:cNvPr id="10" name="Text 8"/>
+          <p:cNvSpPr/>
+          <p:nvPr/>
+        </p:nvSpPr>
+        <p:spPr>
+          <a:xfrm>
+            <a:off x="502920" y="4184294"/>
+            <a:ext cx="2034459" cy="237744"/>
+          </a:xfrm>
+          <a:prstGeom prst="rect">
+            <a:avLst/>
+          </a:prstGeom>
+          <a:noFill/>
+          <a:ln/>
+        </p:spPr>
+        <p:txBody>
+          <a:bodyPr wrap="square" lIns="0" tIns="0" rIns="0" bIns="0" rtlCol="0" anchor="ctr"/>
+          <a:lstStyle/>
+          <a:p>
+            <a:pPr algn="ctr" indent="0" marL="0">
+              <a:buNone/>
+            </a:pPr>
+            <a:r>
+              <a:rPr lang="en-US" sz="1000" b="1" dirty="0">
+                <a:solidFill>
+                  <a:srgbClr val="FFFFFF"/>
+                </a:solidFill>
+                <a:latin typeface="Arial" pitchFamily="34" charset="0"/>
+                <a:ea typeface="Arial" pitchFamily="34" charset="-122"/>
+                <a:cs typeface="Arial" pitchFamily="34" charset="-120"/>
+              </a:rPr>
+              <a:t>40%</a:t>
+            </a:r>
+            <a:endParaRPr lang="en-US" sz="1000" dirty="0"/>
+          </a:p>
+        </p:txBody>
+      </p:sp>
+      <p:sp>
+        <p:nvSpPr>
+          <p:cNvPr id="11" name="Text 9"/>
+          <p:cNvSpPr/>
+          <p:nvPr/>
+        </p:nvSpPr>
+        <p:spPr>
+          <a:xfrm>
+            <a:off x="365760" y="4846320"/>
+            <a:ext cx="2308779" cy="274320"/>
+          </a:xfrm>
+          <a:prstGeom prst="rect">
+            <a:avLst/>
+          </a:prstGeom>
+          <a:noFill/>
+          <a:ln/>
+        </p:spPr>
+        <p:txBody>
+          <a:bodyPr wrap="square" lIns="0" tIns="0" rIns="0" bIns="0" rtlCol="0" anchor="ctr"/>
+          <a:lstStyle/>
+          <a:p>
+            <a:pPr algn="ctr" indent="0" marL="0">
+              <a:buNone/>
+            </a:pPr>
+            <a:r>
+              <a:rPr lang="en-US" sz="1050" b="1" dirty="0">
+                <a:solidFill>
+                  <a:srgbClr val="1A1A1A"/>
+                </a:solidFill>
+                <a:latin typeface="Arial" pitchFamily="34" charset="0"/>
+                <a:ea typeface="Arial" pitchFamily="34" charset="-122"/>
+                <a:cs typeface="Arial" pitchFamily="34" charset="-120"/>
+              </a:rPr>
+              <a:t>Equipment (65%)</a:t>
+            </a:r>
+            <a:endParaRPr lang="en-US" sz="1050" dirty="0"/>
+          </a:p>
+        </p:txBody>
+      </p:sp>
+      <p:sp>
+        <p:nvSpPr>
+          <p:cNvPr id="12" name="Shape 10"/>
+          <p:cNvSpPr/>
+          <p:nvPr/>
+        </p:nvSpPr>
+        <p:spPr>
+          <a:xfrm>
+            <a:off x="2610531" y="2423160"/>
+            <a:ext cx="1095478" cy="1057504"/>
+          </a:xfrm>
+          <a:prstGeom prst="rect">
+            <a:avLst/>
+          </a:prstGeom>
+          <a:solidFill>
+            <a:srgbClr val="2E7CF6"/>
+          </a:solidFill>
+          <a:ln w="12700">
+            <a:solidFill>
+              <a:srgbClr val="FFFFFF"/>
+            </a:solidFill>
+            <a:prstDash val="solid"/>
+          </a:ln>
+        </p:spPr>
+      </p:sp>
+      <p:sp>
+        <p:nvSpPr>
+          <p:cNvPr id="13" name="Text 11"/>
+          <p:cNvSpPr/>
+          <p:nvPr/>
+        </p:nvSpPr>
+        <p:spPr>
+          <a:xfrm>
+            <a:off x="2610531" y="2833040"/>
+            <a:ext cx="1095478" cy="237744"/>
+          </a:xfrm>
+          <a:prstGeom prst="rect">
+            <a:avLst/>
+          </a:prstGeom>
+          <a:noFill/>
+          <a:ln/>
+        </p:spPr>
+        <p:txBody>
+          <a:bodyPr wrap="square" lIns="0" tIns="0" rIns="0" bIns="0" rtlCol="0" anchor="ctr"/>
+          <a:lstStyle/>
+          <a:p>
+            <a:pPr algn="ctr" indent="0" marL="0">
+              <a:buNone/>
+            </a:pPr>
+            <a:r>
+              <a:rPr lang="en-US" sz="1000" b="1" dirty="0">
+                <a:solidFill>
+                  <a:srgbClr val="FFFFFF"/>
+                </a:solidFill>
+                <a:latin typeface="Arial" pitchFamily="34" charset="0"/>
+                <a:ea typeface="Arial" pitchFamily="34" charset="-122"/>
+                <a:cs typeface="Arial" pitchFamily="34" charset="-120"/>
+              </a:rPr>
+              <a:t>45%</a:t>
+            </a:r>
+            <a:endParaRPr lang="en-US" sz="1000" dirty="0"/>
+          </a:p>
+        </p:txBody>
+      </p:sp>
+      <p:sp>
+        <p:nvSpPr>
+          <p:cNvPr id="14" name="Shape 12"/>
+          <p:cNvSpPr/>
+          <p:nvPr/>
+        </p:nvSpPr>
+        <p:spPr>
+          <a:xfrm>
+            <a:off x="2610531" y="3480664"/>
+            <a:ext cx="1095478" cy="822503"/>
+          </a:xfrm>
+          <a:prstGeom prst="rect">
+            <a:avLst/>
+          </a:prstGeom>
+          <a:solidFill>
+            <a:srgbClr val="5AA0FF"/>
+          </a:solidFill>
+          <a:ln w="12700">
+            <a:solidFill>
+              <a:srgbClr val="FFFFFF"/>
+            </a:solidFill>
+            <a:prstDash val="solid"/>
+          </a:ln>
+        </p:spPr>
+      </p:sp>
+      <p:sp>
+        <p:nvSpPr>
+          <p:cNvPr id="15" name="Text 13"/>
+          <p:cNvSpPr/>
+          <p:nvPr/>
+        </p:nvSpPr>
+        <p:spPr>
+          <a:xfrm>
+            <a:off x="2610531" y="3773043"/>
+            <a:ext cx="1095478" cy="237744"/>
+          </a:xfrm>
+          <a:prstGeom prst="rect">
+            <a:avLst/>
+          </a:prstGeom>
+          <a:noFill/>
+          <a:ln/>
+        </p:spPr>
+        <p:txBody>
+          <a:bodyPr wrap="square" lIns="0" tIns="0" rIns="0" bIns="0" rtlCol="0" anchor="ctr"/>
+          <a:lstStyle/>
+          <a:p>
+            <a:pPr algn="ctr" indent="0" marL="0">
+              <a:buNone/>
+            </a:pPr>
+            <a:r>
+              <a:rPr lang="en-US" sz="1000" b="1" dirty="0">
+                <a:solidFill>
+                  <a:srgbClr val="FFFFFF"/>
+                </a:solidFill>
+                <a:latin typeface="Arial" pitchFamily="34" charset="0"/>
+                <a:ea typeface="Arial" pitchFamily="34" charset="-122"/>
+                <a:cs typeface="Arial" pitchFamily="34" charset="-120"/>
+              </a:rPr>
+              <a:t>35%</a:t>
+            </a:r>
+            <a:endParaRPr lang="en-US" sz="1000" dirty="0"/>
+          </a:p>
+        </p:txBody>
+      </p:sp>
+      <p:sp>
+        <p:nvSpPr>
+          <p:cNvPr id="16" name="Shape 14"/>
+          <p:cNvSpPr/>
+          <p:nvPr/>
+        </p:nvSpPr>
+        <p:spPr>
+          <a:xfrm>
+            <a:off x="2610531" y="4303166"/>
+            <a:ext cx="1095478" cy="470002"/>
+          </a:xfrm>
+          <a:prstGeom prst="rect">
+            <a:avLst/>
+          </a:prstGeom>
+          <a:solidFill>
+            <a:srgbClr val="AFC9F0"/>
+          </a:solidFill>
+          <a:ln w="12700">
+            <a:solidFill>
+              <a:srgbClr val="FFFFFF"/>
+            </a:solidFill>
+            <a:prstDash val="solid"/>
+          </a:ln>
+        </p:spPr>
+      </p:sp>
+      <p:sp>
+        <p:nvSpPr>
+          <p:cNvPr id="17" name="Text 15"/>
+          <p:cNvSpPr/>
+          <p:nvPr/>
+        </p:nvSpPr>
+        <p:spPr>
+          <a:xfrm>
+            <a:off x="2610531" y="4419295"/>
+            <a:ext cx="1095478" cy="237744"/>
+          </a:xfrm>
+          <a:prstGeom prst="rect">
+            <a:avLst/>
+          </a:prstGeom>
+          <a:noFill/>
+          <a:ln/>
+        </p:spPr>
+        <p:txBody>
+          <a:bodyPr wrap="square" lIns="0" tIns="0" rIns="0" bIns="0" rtlCol="0" anchor="ctr"/>
+          <a:lstStyle/>
+          <a:p>
+            <a:pPr algn="ctr" indent="0" marL="0">
+              <a:buNone/>
+            </a:pPr>
+            <a:r>
+              <a:rPr lang="en-US" sz="1000" b="1" dirty="0">
+                <a:solidFill>
+                  <a:srgbClr val="FFFFFF"/>
+                </a:solidFill>
+                <a:latin typeface="Arial" pitchFamily="34" charset="0"/>
+                <a:ea typeface="Arial" pitchFamily="34" charset="-122"/>
+                <a:cs typeface="Arial" pitchFamily="34" charset="-120"/>
+              </a:rPr>
+              <a:t>20%</a:t>
+            </a:r>
+            <a:endParaRPr lang="en-US" sz="1000" dirty="0"/>
+          </a:p>
+        </p:txBody>
+      </p:sp>
+      <p:sp>
+        <p:nvSpPr>
+          <p:cNvPr id="18" name="Text 16"/>
+          <p:cNvSpPr/>
+          <p:nvPr/>
+        </p:nvSpPr>
+        <p:spPr>
+          <a:xfrm>
+            <a:off x="2473371" y="4846320"/>
+            <a:ext cx="1369798" cy="274320"/>
+          </a:xfrm>
+          <a:prstGeom prst="rect">
+            <a:avLst/>
+          </a:prstGeom>
+          <a:noFill/>
+          <a:ln/>
+        </p:spPr>
+        <p:txBody>
+          <a:bodyPr wrap="square" lIns="0" tIns="0" rIns="0" bIns="0" rtlCol="0" anchor="ctr"/>
+          <a:lstStyle/>
+          <a:p>
+            <a:pPr algn="ctr" indent="0" marL="0">
+              <a:buNone/>
+            </a:pPr>
+            <a:r>
+              <a:rPr lang="en-US" sz="1050" b="1" dirty="0">
+                <a:solidFill>
+                  <a:srgbClr val="1A1A1A"/>
+                </a:solidFill>
+                <a:latin typeface="Arial" pitchFamily="34" charset="0"/>
+                <a:ea typeface="Arial" pitchFamily="34" charset="-122"/>
+                <a:cs typeface="Arial" pitchFamily="34" charset="-120"/>
+              </a:rPr>
+              <a:t>Services (35%)</a:t>
+            </a:r>
+            <a:endParaRPr lang="en-US" sz="1050" dirty="0"/>
+          </a:p>
+        </p:txBody>
+      </p:sp>
+      <p:sp>
+        <p:nvSpPr>
+          <p:cNvPr id="19" name="Text 17"/>
+          <p:cNvSpPr/>
+          <p:nvPr/>
+        </p:nvSpPr>
+        <p:spPr>
+          <a:xfrm>
+            <a:off x="4208929" y="1993392"/>
+            <a:ext cx="4055633" cy="237744"/>
+          </a:xfrm>
+          <a:prstGeom prst="rect">
+            <a:avLst/>
+          </a:prstGeom>
+          <a:noFill/>
+          <a:ln/>
+        </p:spPr>
+        <p:txBody>
+          <a:bodyPr wrap="square" lIns="0" tIns="0" rIns="0" bIns="0" rtlCol="0" anchor="ctr"/>
+          <a:lstStyle/>
+          <a:p>
             <a:pPr indent="0" marL="0">
               <a:buNone/>
             </a:pPr>
@@ -27274,33 +28651,2290 @@
           </a:p>
         </p:txBody>
       </p:sp>
-      <p:pic>
-        <p:nvPicPr>
-          <p:cNvPr id="9" name="Image 1" descr="/Users/othmane_benkirane/.claude/skills/sprintospptx-v3/examples/gd-assets/waffle-877df5af8a.png">    </p:cNvPr>
-          <p:cNvPicPr>
-            <a:picLocks noChangeAspect="1"/>
-          </p:cNvPicPr>
-          <p:nvPr/>
-        </p:nvPicPr>
-        <p:blipFill>
-          <a:blip r:embed="rId2"/>
-          <a:stretch>
-            <a:fillRect/>
-          </a:stretch>
-        </p:blipFill>
-        <p:spPr>
-          <a:xfrm>
-            <a:off x="4364915" y="2697480"/>
-            <a:ext cx="3808207" cy="2227801"/>
-          </a:xfrm>
-          <a:prstGeom prst="rect">
-            <a:avLst/>
-          </a:prstGeom>
-        </p:spPr>
-      </p:pic>
-      <p:sp>
-        <p:nvSpPr>
-          <p:cNvPr id="10" name="Text 6"/>
+      <p:sp>
+        <p:nvSpPr>
+          <p:cNvPr id="20" name="Shape 18"/>
+          <p:cNvSpPr/>
+          <p:nvPr/>
+        </p:nvSpPr>
+        <p:spPr>
+          <a:xfrm>
+            <a:off x="4208929" y="2514600"/>
+            <a:ext cx="178785" cy="178785"/>
+          </a:xfrm>
+          <a:prstGeom prst="roundRect">
+            <a:avLst>
+              <a:gd name="adj" fmla="val 18000"/>
+            </a:avLst>
+          </a:prstGeom>
+          <a:solidFill>
+            <a:srgbClr val="E9EDF2"/>
+          </a:solidFill>
+          <a:ln/>
+        </p:spPr>
+      </p:sp>
+      <p:sp>
+        <p:nvSpPr>
+          <p:cNvPr id="21" name="Shape 19"/>
+          <p:cNvSpPr/>
+          <p:nvPr/>
+        </p:nvSpPr>
+        <p:spPr>
+          <a:xfrm>
+            <a:off x="4426960" y="2514600"/>
+            <a:ext cx="178785" cy="178785"/>
+          </a:xfrm>
+          <a:prstGeom prst="roundRect">
+            <a:avLst>
+              <a:gd name="adj" fmla="val 18000"/>
+            </a:avLst>
+          </a:prstGeom>
+          <a:solidFill>
+            <a:srgbClr val="E9EDF2"/>
+          </a:solidFill>
+          <a:ln/>
+        </p:spPr>
+      </p:sp>
+      <p:sp>
+        <p:nvSpPr>
+          <p:cNvPr id="22" name="Shape 20"/>
+          <p:cNvSpPr/>
+          <p:nvPr/>
+        </p:nvSpPr>
+        <p:spPr>
+          <a:xfrm>
+            <a:off x="4644991" y="2514600"/>
+            <a:ext cx="178785" cy="178785"/>
+          </a:xfrm>
+          <a:prstGeom prst="roundRect">
+            <a:avLst>
+              <a:gd name="adj" fmla="val 18000"/>
+            </a:avLst>
+          </a:prstGeom>
+          <a:solidFill>
+            <a:srgbClr val="E9EDF2"/>
+          </a:solidFill>
+          <a:ln/>
+        </p:spPr>
+      </p:sp>
+      <p:sp>
+        <p:nvSpPr>
+          <p:cNvPr id="23" name="Shape 21"/>
+          <p:cNvSpPr/>
+          <p:nvPr/>
+        </p:nvSpPr>
+        <p:spPr>
+          <a:xfrm>
+            <a:off x="4863021" y="2514600"/>
+            <a:ext cx="178785" cy="178785"/>
+          </a:xfrm>
+          <a:prstGeom prst="roundRect">
+            <a:avLst>
+              <a:gd name="adj" fmla="val 18000"/>
+            </a:avLst>
+          </a:prstGeom>
+          <a:solidFill>
+            <a:srgbClr val="E9EDF2"/>
+          </a:solidFill>
+          <a:ln/>
+        </p:spPr>
+      </p:sp>
+      <p:sp>
+        <p:nvSpPr>
+          <p:cNvPr id="24" name="Shape 22"/>
+          <p:cNvSpPr/>
+          <p:nvPr/>
+        </p:nvSpPr>
+        <p:spPr>
+          <a:xfrm>
+            <a:off x="5081052" y="2514600"/>
+            <a:ext cx="178785" cy="178785"/>
+          </a:xfrm>
+          <a:prstGeom prst="roundRect">
+            <a:avLst>
+              <a:gd name="adj" fmla="val 18000"/>
+            </a:avLst>
+          </a:prstGeom>
+          <a:solidFill>
+            <a:srgbClr val="E9EDF2"/>
+          </a:solidFill>
+          <a:ln/>
+        </p:spPr>
+      </p:sp>
+      <p:sp>
+        <p:nvSpPr>
+          <p:cNvPr id="25" name="Shape 23"/>
+          <p:cNvSpPr/>
+          <p:nvPr/>
+        </p:nvSpPr>
+        <p:spPr>
+          <a:xfrm>
+            <a:off x="5299082" y="2514600"/>
+            <a:ext cx="178785" cy="178785"/>
+          </a:xfrm>
+          <a:prstGeom prst="roundRect">
+            <a:avLst>
+              <a:gd name="adj" fmla="val 18000"/>
+            </a:avLst>
+          </a:prstGeom>
+          <a:solidFill>
+            <a:srgbClr val="E9EDF2"/>
+          </a:solidFill>
+          <a:ln/>
+        </p:spPr>
+      </p:sp>
+      <p:sp>
+        <p:nvSpPr>
+          <p:cNvPr id="26" name="Shape 24"/>
+          <p:cNvSpPr/>
+          <p:nvPr/>
+        </p:nvSpPr>
+        <p:spPr>
+          <a:xfrm>
+            <a:off x="5517113" y="2514600"/>
+            <a:ext cx="178785" cy="178785"/>
+          </a:xfrm>
+          <a:prstGeom prst="roundRect">
+            <a:avLst>
+              <a:gd name="adj" fmla="val 18000"/>
+            </a:avLst>
+          </a:prstGeom>
+          <a:solidFill>
+            <a:srgbClr val="E9EDF2"/>
+          </a:solidFill>
+          <a:ln/>
+        </p:spPr>
+      </p:sp>
+      <p:sp>
+        <p:nvSpPr>
+          <p:cNvPr id="27" name="Shape 25"/>
+          <p:cNvSpPr/>
+          <p:nvPr/>
+        </p:nvSpPr>
+        <p:spPr>
+          <a:xfrm>
+            <a:off x="5735144" y="2514600"/>
+            <a:ext cx="178785" cy="178785"/>
+          </a:xfrm>
+          <a:prstGeom prst="roundRect">
+            <a:avLst>
+              <a:gd name="adj" fmla="val 18000"/>
+            </a:avLst>
+          </a:prstGeom>
+          <a:solidFill>
+            <a:srgbClr val="E9EDF2"/>
+          </a:solidFill>
+          <a:ln/>
+        </p:spPr>
+      </p:sp>
+      <p:sp>
+        <p:nvSpPr>
+          <p:cNvPr id="28" name="Shape 26"/>
+          <p:cNvSpPr/>
+          <p:nvPr/>
+        </p:nvSpPr>
+        <p:spPr>
+          <a:xfrm>
+            <a:off x="5953174" y="2514600"/>
+            <a:ext cx="178785" cy="178785"/>
+          </a:xfrm>
+          <a:prstGeom prst="roundRect">
+            <a:avLst>
+              <a:gd name="adj" fmla="val 18000"/>
+            </a:avLst>
+          </a:prstGeom>
+          <a:solidFill>
+            <a:srgbClr val="E9EDF2"/>
+          </a:solidFill>
+          <a:ln/>
+        </p:spPr>
+      </p:sp>
+      <p:sp>
+        <p:nvSpPr>
+          <p:cNvPr id="29" name="Shape 27"/>
+          <p:cNvSpPr/>
+          <p:nvPr/>
+        </p:nvSpPr>
+        <p:spPr>
+          <a:xfrm>
+            <a:off x="6171205" y="2514600"/>
+            <a:ext cx="178785" cy="178785"/>
+          </a:xfrm>
+          <a:prstGeom prst="roundRect">
+            <a:avLst>
+              <a:gd name="adj" fmla="val 18000"/>
+            </a:avLst>
+          </a:prstGeom>
+          <a:solidFill>
+            <a:srgbClr val="E9EDF2"/>
+          </a:solidFill>
+          <a:ln/>
+        </p:spPr>
+      </p:sp>
+      <p:sp>
+        <p:nvSpPr>
+          <p:cNvPr id="30" name="Shape 28"/>
+          <p:cNvSpPr/>
+          <p:nvPr/>
+        </p:nvSpPr>
+        <p:spPr>
+          <a:xfrm>
+            <a:off x="4208929" y="2732631"/>
+            <a:ext cx="178785" cy="178785"/>
+          </a:xfrm>
+          <a:prstGeom prst="roundRect">
+            <a:avLst>
+              <a:gd name="adj" fmla="val 18000"/>
+            </a:avLst>
+          </a:prstGeom>
+          <a:solidFill>
+            <a:srgbClr val="E9EDF2"/>
+          </a:solidFill>
+          <a:ln/>
+        </p:spPr>
+      </p:sp>
+      <p:sp>
+        <p:nvSpPr>
+          <p:cNvPr id="31" name="Shape 29"/>
+          <p:cNvSpPr/>
+          <p:nvPr/>
+        </p:nvSpPr>
+        <p:spPr>
+          <a:xfrm>
+            <a:off x="4426960" y="2732631"/>
+            <a:ext cx="178785" cy="178785"/>
+          </a:xfrm>
+          <a:prstGeom prst="roundRect">
+            <a:avLst>
+              <a:gd name="adj" fmla="val 18000"/>
+            </a:avLst>
+          </a:prstGeom>
+          <a:solidFill>
+            <a:srgbClr val="E9EDF2"/>
+          </a:solidFill>
+          <a:ln/>
+        </p:spPr>
+      </p:sp>
+      <p:sp>
+        <p:nvSpPr>
+          <p:cNvPr id="32" name="Shape 30"/>
+          <p:cNvSpPr/>
+          <p:nvPr/>
+        </p:nvSpPr>
+        <p:spPr>
+          <a:xfrm>
+            <a:off x="4644991" y="2732631"/>
+            <a:ext cx="178785" cy="178785"/>
+          </a:xfrm>
+          <a:prstGeom prst="roundRect">
+            <a:avLst>
+              <a:gd name="adj" fmla="val 18000"/>
+            </a:avLst>
+          </a:prstGeom>
+          <a:solidFill>
+            <a:srgbClr val="E9EDF2"/>
+          </a:solidFill>
+          <a:ln/>
+        </p:spPr>
+      </p:sp>
+      <p:sp>
+        <p:nvSpPr>
+          <p:cNvPr id="33" name="Shape 31"/>
+          <p:cNvSpPr/>
+          <p:nvPr/>
+        </p:nvSpPr>
+        <p:spPr>
+          <a:xfrm>
+            <a:off x="4863021" y="2732631"/>
+            <a:ext cx="178785" cy="178785"/>
+          </a:xfrm>
+          <a:prstGeom prst="roundRect">
+            <a:avLst>
+              <a:gd name="adj" fmla="val 18000"/>
+            </a:avLst>
+          </a:prstGeom>
+          <a:solidFill>
+            <a:srgbClr val="E9EDF2"/>
+          </a:solidFill>
+          <a:ln/>
+        </p:spPr>
+      </p:sp>
+      <p:sp>
+        <p:nvSpPr>
+          <p:cNvPr id="34" name="Shape 32"/>
+          <p:cNvSpPr/>
+          <p:nvPr/>
+        </p:nvSpPr>
+        <p:spPr>
+          <a:xfrm>
+            <a:off x="5081052" y="2732631"/>
+            <a:ext cx="178785" cy="178785"/>
+          </a:xfrm>
+          <a:prstGeom prst="roundRect">
+            <a:avLst>
+              <a:gd name="adj" fmla="val 18000"/>
+            </a:avLst>
+          </a:prstGeom>
+          <a:solidFill>
+            <a:srgbClr val="E9EDF2"/>
+          </a:solidFill>
+          <a:ln/>
+        </p:spPr>
+      </p:sp>
+      <p:sp>
+        <p:nvSpPr>
+          <p:cNvPr id="35" name="Shape 33"/>
+          <p:cNvSpPr/>
+          <p:nvPr/>
+        </p:nvSpPr>
+        <p:spPr>
+          <a:xfrm>
+            <a:off x="5299082" y="2732631"/>
+            <a:ext cx="178785" cy="178785"/>
+          </a:xfrm>
+          <a:prstGeom prst="roundRect">
+            <a:avLst>
+              <a:gd name="adj" fmla="val 18000"/>
+            </a:avLst>
+          </a:prstGeom>
+          <a:solidFill>
+            <a:srgbClr val="E9EDF2"/>
+          </a:solidFill>
+          <a:ln/>
+        </p:spPr>
+      </p:sp>
+      <p:sp>
+        <p:nvSpPr>
+          <p:cNvPr id="36" name="Shape 34"/>
+          <p:cNvSpPr/>
+          <p:nvPr/>
+        </p:nvSpPr>
+        <p:spPr>
+          <a:xfrm>
+            <a:off x="5517113" y="2732631"/>
+            <a:ext cx="178785" cy="178785"/>
+          </a:xfrm>
+          <a:prstGeom prst="roundRect">
+            <a:avLst>
+              <a:gd name="adj" fmla="val 18000"/>
+            </a:avLst>
+          </a:prstGeom>
+          <a:solidFill>
+            <a:srgbClr val="E9EDF2"/>
+          </a:solidFill>
+          <a:ln/>
+        </p:spPr>
+      </p:sp>
+      <p:sp>
+        <p:nvSpPr>
+          <p:cNvPr id="37" name="Shape 35"/>
+          <p:cNvSpPr/>
+          <p:nvPr/>
+        </p:nvSpPr>
+        <p:spPr>
+          <a:xfrm>
+            <a:off x="5735144" y="2732631"/>
+            <a:ext cx="178785" cy="178785"/>
+          </a:xfrm>
+          <a:prstGeom prst="roundRect">
+            <a:avLst>
+              <a:gd name="adj" fmla="val 18000"/>
+            </a:avLst>
+          </a:prstGeom>
+          <a:solidFill>
+            <a:srgbClr val="E9EDF2"/>
+          </a:solidFill>
+          <a:ln/>
+        </p:spPr>
+      </p:sp>
+      <p:sp>
+        <p:nvSpPr>
+          <p:cNvPr id="38" name="Shape 36"/>
+          <p:cNvSpPr/>
+          <p:nvPr/>
+        </p:nvSpPr>
+        <p:spPr>
+          <a:xfrm>
+            <a:off x="5953174" y="2732631"/>
+            <a:ext cx="178785" cy="178785"/>
+          </a:xfrm>
+          <a:prstGeom prst="roundRect">
+            <a:avLst>
+              <a:gd name="adj" fmla="val 18000"/>
+            </a:avLst>
+          </a:prstGeom>
+          <a:solidFill>
+            <a:srgbClr val="E9EDF2"/>
+          </a:solidFill>
+          <a:ln/>
+        </p:spPr>
+      </p:sp>
+      <p:sp>
+        <p:nvSpPr>
+          <p:cNvPr id="39" name="Shape 37"/>
+          <p:cNvSpPr/>
+          <p:nvPr/>
+        </p:nvSpPr>
+        <p:spPr>
+          <a:xfrm>
+            <a:off x="6171205" y="2732631"/>
+            <a:ext cx="178785" cy="178785"/>
+          </a:xfrm>
+          <a:prstGeom prst="roundRect">
+            <a:avLst>
+              <a:gd name="adj" fmla="val 18000"/>
+            </a:avLst>
+          </a:prstGeom>
+          <a:solidFill>
+            <a:srgbClr val="E9EDF2"/>
+          </a:solidFill>
+          <a:ln/>
+        </p:spPr>
+      </p:sp>
+      <p:sp>
+        <p:nvSpPr>
+          <p:cNvPr id="40" name="Shape 38"/>
+          <p:cNvSpPr/>
+          <p:nvPr/>
+        </p:nvSpPr>
+        <p:spPr>
+          <a:xfrm>
+            <a:off x="4208929" y="2950661"/>
+            <a:ext cx="178785" cy="178785"/>
+          </a:xfrm>
+          <a:prstGeom prst="roundRect">
+            <a:avLst>
+              <a:gd name="adj" fmla="val 18000"/>
+            </a:avLst>
+          </a:prstGeom>
+          <a:solidFill>
+            <a:srgbClr val="E9EDF2"/>
+          </a:solidFill>
+          <a:ln/>
+        </p:spPr>
+      </p:sp>
+      <p:sp>
+        <p:nvSpPr>
+          <p:cNvPr id="41" name="Shape 39"/>
+          <p:cNvSpPr/>
+          <p:nvPr/>
+        </p:nvSpPr>
+        <p:spPr>
+          <a:xfrm>
+            <a:off x="4426960" y="2950661"/>
+            <a:ext cx="178785" cy="178785"/>
+          </a:xfrm>
+          <a:prstGeom prst="roundRect">
+            <a:avLst>
+              <a:gd name="adj" fmla="val 18000"/>
+            </a:avLst>
+          </a:prstGeom>
+          <a:solidFill>
+            <a:srgbClr val="E9EDF2"/>
+          </a:solidFill>
+          <a:ln/>
+        </p:spPr>
+      </p:sp>
+      <p:sp>
+        <p:nvSpPr>
+          <p:cNvPr id="42" name="Shape 40"/>
+          <p:cNvSpPr/>
+          <p:nvPr/>
+        </p:nvSpPr>
+        <p:spPr>
+          <a:xfrm>
+            <a:off x="4644991" y="2950661"/>
+            <a:ext cx="178785" cy="178785"/>
+          </a:xfrm>
+          <a:prstGeom prst="roundRect">
+            <a:avLst>
+              <a:gd name="adj" fmla="val 18000"/>
+            </a:avLst>
+          </a:prstGeom>
+          <a:solidFill>
+            <a:srgbClr val="E9EDF2"/>
+          </a:solidFill>
+          <a:ln/>
+        </p:spPr>
+      </p:sp>
+      <p:sp>
+        <p:nvSpPr>
+          <p:cNvPr id="43" name="Shape 41"/>
+          <p:cNvSpPr/>
+          <p:nvPr/>
+        </p:nvSpPr>
+        <p:spPr>
+          <a:xfrm>
+            <a:off x="4863021" y="2950661"/>
+            <a:ext cx="178785" cy="178785"/>
+          </a:xfrm>
+          <a:prstGeom prst="roundRect">
+            <a:avLst>
+              <a:gd name="adj" fmla="val 18000"/>
+            </a:avLst>
+          </a:prstGeom>
+          <a:solidFill>
+            <a:srgbClr val="E9EDF2"/>
+          </a:solidFill>
+          <a:ln/>
+        </p:spPr>
+      </p:sp>
+      <p:sp>
+        <p:nvSpPr>
+          <p:cNvPr id="44" name="Shape 42"/>
+          <p:cNvSpPr/>
+          <p:nvPr/>
+        </p:nvSpPr>
+        <p:spPr>
+          <a:xfrm>
+            <a:off x="5081052" y="2950661"/>
+            <a:ext cx="178785" cy="178785"/>
+          </a:xfrm>
+          <a:prstGeom prst="roundRect">
+            <a:avLst>
+              <a:gd name="adj" fmla="val 18000"/>
+            </a:avLst>
+          </a:prstGeom>
+          <a:solidFill>
+            <a:srgbClr val="E9EDF2"/>
+          </a:solidFill>
+          <a:ln/>
+        </p:spPr>
+      </p:sp>
+      <p:sp>
+        <p:nvSpPr>
+          <p:cNvPr id="45" name="Shape 43"/>
+          <p:cNvSpPr/>
+          <p:nvPr/>
+        </p:nvSpPr>
+        <p:spPr>
+          <a:xfrm>
+            <a:off x="5299082" y="2950661"/>
+            <a:ext cx="178785" cy="178785"/>
+          </a:xfrm>
+          <a:prstGeom prst="roundRect">
+            <a:avLst>
+              <a:gd name="adj" fmla="val 18000"/>
+            </a:avLst>
+          </a:prstGeom>
+          <a:solidFill>
+            <a:srgbClr val="E9EDF2"/>
+          </a:solidFill>
+          <a:ln/>
+        </p:spPr>
+      </p:sp>
+      <p:sp>
+        <p:nvSpPr>
+          <p:cNvPr id="46" name="Shape 44"/>
+          <p:cNvSpPr/>
+          <p:nvPr/>
+        </p:nvSpPr>
+        <p:spPr>
+          <a:xfrm>
+            <a:off x="5517113" y="2950661"/>
+            <a:ext cx="178785" cy="178785"/>
+          </a:xfrm>
+          <a:prstGeom prst="roundRect">
+            <a:avLst>
+              <a:gd name="adj" fmla="val 18000"/>
+            </a:avLst>
+          </a:prstGeom>
+          <a:solidFill>
+            <a:srgbClr val="E9EDF2"/>
+          </a:solidFill>
+          <a:ln/>
+        </p:spPr>
+      </p:sp>
+      <p:sp>
+        <p:nvSpPr>
+          <p:cNvPr id="47" name="Shape 45"/>
+          <p:cNvSpPr/>
+          <p:nvPr/>
+        </p:nvSpPr>
+        <p:spPr>
+          <a:xfrm>
+            <a:off x="5735144" y="2950661"/>
+            <a:ext cx="178785" cy="178785"/>
+          </a:xfrm>
+          <a:prstGeom prst="roundRect">
+            <a:avLst>
+              <a:gd name="adj" fmla="val 18000"/>
+            </a:avLst>
+          </a:prstGeom>
+          <a:solidFill>
+            <a:srgbClr val="E9EDF2"/>
+          </a:solidFill>
+          <a:ln/>
+        </p:spPr>
+      </p:sp>
+      <p:sp>
+        <p:nvSpPr>
+          <p:cNvPr id="48" name="Shape 46"/>
+          <p:cNvSpPr/>
+          <p:nvPr/>
+        </p:nvSpPr>
+        <p:spPr>
+          <a:xfrm>
+            <a:off x="5953174" y="2950661"/>
+            <a:ext cx="178785" cy="178785"/>
+          </a:xfrm>
+          <a:prstGeom prst="roundRect">
+            <a:avLst>
+              <a:gd name="adj" fmla="val 18000"/>
+            </a:avLst>
+          </a:prstGeom>
+          <a:solidFill>
+            <a:srgbClr val="E9EDF2"/>
+          </a:solidFill>
+          <a:ln/>
+        </p:spPr>
+      </p:sp>
+      <p:sp>
+        <p:nvSpPr>
+          <p:cNvPr id="49" name="Shape 47"/>
+          <p:cNvSpPr/>
+          <p:nvPr/>
+        </p:nvSpPr>
+        <p:spPr>
+          <a:xfrm>
+            <a:off x="6171205" y="2950661"/>
+            <a:ext cx="178785" cy="178785"/>
+          </a:xfrm>
+          <a:prstGeom prst="roundRect">
+            <a:avLst>
+              <a:gd name="adj" fmla="val 18000"/>
+            </a:avLst>
+          </a:prstGeom>
+          <a:solidFill>
+            <a:srgbClr val="E9EDF2"/>
+          </a:solidFill>
+          <a:ln/>
+        </p:spPr>
+      </p:sp>
+      <p:sp>
+        <p:nvSpPr>
+          <p:cNvPr id="50" name="Shape 48"/>
+          <p:cNvSpPr/>
+          <p:nvPr/>
+        </p:nvSpPr>
+        <p:spPr>
+          <a:xfrm>
+            <a:off x="4208929" y="3168692"/>
+            <a:ext cx="178785" cy="178785"/>
+          </a:xfrm>
+          <a:prstGeom prst="roundRect">
+            <a:avLst>
+              <a:gd name="adj" fmla="val 18000"/>
+            </a:avLst>
+          </a:prstGeom>
+          <a:solidFill>
+            <a:srgbClr val="E9EDF2"/>
+          </a:solidFill>
+          <a:ln/>
+        </p:spPr>
+      </p:sp>
+      <p:sp>
+        <p:nvSpPr>
+          <p:cNvPr id="51" name="Shape 49"/>
+          <p:cNvSpPr/>
+          <p:nvPr/>
+        </p:nvSpPr>
+        <p:spPr>
+          <a:xfrm>
+            <a:off x="4426960" y="3168692"/>
+            <a:ext cx="178785" cy="178785"/>
+          </a:xfrm>
+          <a:prstGeom prst="roundRect">
+            <a:avLst>
+              <a:gd name="adj" fmla="val 18000"/>
+            </a:avLst>
+          </a:prstGeom>
+          <a:solidFill>
+            <a:srgbClr val="E9EDF2"/>
+          </a:solidFill>
+          <a:ln/>
+        </p:spPr>
+      </p:sp>
+      <p:sp>
+        <p:nvSpPr>
+          <p:cNvPr id="52" name="Shape 50"/>
+          <p:cNvSpPr/>
+          <p:nvPr/>
+        </p:nvSpPr>
+        <p:spPr>
+          <a:xfrm>
+            <a:off x="4644991" y="3168692"/>
+            <a:ext cx="178785" cy="178785"/>
+          </a:xfrm>
+          <a:prstGeom prst="roundRect">
+            <a:avLst>
+              <a:gd name="adj" fmla="val 18000"/>
+            </a:avLst>
+          </a:prstGeom>
+          <a:solidFill>
+            <a:srgbClr val="E9EDF2"/>
+          </a:solidFill>
+          <a:ln/>
+        </p:spPr>
+      </p:sp>
+      <p:sp>
+        <p:nvSpPr>
+          <p:cNvPr id="53" name="Shape 51"/>
+          <p:cNvSpPr/>
+          <p:nvPr/>
+        </p:nvSpPr>
+        <p:spPr>
+          <a:xfrm>
+            <a:off x="4863021" y="3168692"/>
+            <a:ext cx="178785" cy="178785"/>
+          </a:xfrm>
+          <a:prstGeom prst="roundRect">
+            <a:avLst>
+              <a:gd name="adj" fmla="val 18000"/>
+            </a:avLst>
+          </a:prstGeom>
+          <a:solidFill>
+            <a:srgbClr val="E9EDF2"/>
+          </a:solidFill>
+          <a:ln/>
+        </p:spPr>
+      </p:sp>
+      <p:sp>
+        <p:nvSpPr>
+          <p:cNvPr id="54" name="Shape 52"/>
+          <p:cNvSpPr/>
+          <p:nvPr/>
+        </p:nvSpPr>
+        <p:spPr>
+          <a:xfrm>
+            <a:off x="5081052" y="3168692"/>
+            <a:ext cx="178785" cy="178785"/>
+          </a:xfrm>
+          <a:prstGeom prst="roundRect">
+            <a:avLst>
+              <a:gd name="adj" fmla="val 18000"/>
+            </a:avLst>
+          </a:prstGeom>
+          <a:solidFill>
+            <a:srgbClr val="E9EDF2"/>
+          </a:solidFill>
+          <a:ln/>
+        </p:spPr>
+      </p:sp>
+      <p:sp>
+        <p:nvSpPr>
+          <p:cNvPr id="55" name="Shape 53"/>
+          <p:cNvSpPr/>
+          <p:nvPr/>
+        </p:nvSpPr>
+        <p:spPr>
+          <a:xfrm>
+            <a:off x="5299082" y="3168692"/>
+            <a:ext cx="178785" cy="178785"/>
+          </a:xfrm>
+          <a:prstGeom prst="roundRect">
+            <a:avLst>
+              <a:gd name="adj" fmla="val 18000"/>
+            </a:avLst>
+          </a:prstGeom>
+          <a:solidFill>
+            <a:srgbClr val="E9EDF2"/>
+          </a:solidFill>
+          <a:ln/>
+        </p:spPr>
+      </p:sp>
+      <p:sp>
+        <p:nvSpPr>
+          <p:cNvPr id="56" name="Shape 54"/>
+          <p:cNvSpPr/>
+          <p:nvPr/>
+        </p:nvSpPr>
+        <p:spPr>
+          <a:xfrm>
+            <a:off x="5517113" y="3168692"/>
+            <a:ext cx="178785" cy="178785"/>
+          </a:xfrm>
+          <a:prstGeom prst="roundRect">
+            <a:avLst>
+              <a:gd name="adj" fmla="val 18000"/>
+            </a:avLst>
+          </a:prstGeom>
+          <a:solidFill>
+            <a:srgbClr val="E9EDF2"/>
+          </a:solidFill>
+          <a:ln/>
+        </p:spPr>
+      </p:sp>
+      <p:sp>
+        <p:nvSpPr>
+          <p:cNvPr id="57" name="Shape 55"/>
+          <p:cNvSpPr/>
+          <p:nvPr/>
+        </p:nvSpPr>
+        <p:spPr>
+          <a:xfrm>
+            <a:off x="5735144" y="3168692"/>
+            <a:ext cx="178785" cy="178785"/>
+          </a:xfrm>
+          <a:prstGeom prst="roundRect">
+            <a:avLst>
+              <a:gd name="adj" fmla="val 18000"/>
+            </a:avLst>
+          </a:prstGeom>
+          <a:solidFill>
+            <a:srgbClr val="E9EDF2"/>
+          </a:solidFill>
+          <a:ln/>
+        </p:spPr>
+      </p:sp>
+      <p:sp>
+        <p:nvSpPr>
+          <p:cNvPr id="58" name="Shape 56"/>
+          <p:cNvSpPr/>
+          <p:nvPr/>
+        </p:nvSpPr>
+        <p:spPr>
+          <a:xfrm>
+            <a:off x="5953174" y="3168692"/>
+            <a:ext cx="178785" cy="178785"/>
+          </a:xfrm>
+          <a:prstGeom prst="roundRect">
+            <a:avLst>
+              <a:gd name="adj" fmla="val 18000"/>
+            </a:avLst>
+          </a:prstGeom>
+          <a:solidFill>
+            <a:srgbClr val="E9EDF2"/>
+          </a:solidFill>
+          <a:ln/>
+        </p:spPr>
+      </p:sp>
+      <p:sp>
+        <p:nvSpPr>
+          <p:cNvPr id="59" name="Shape 57"/>
+          <p:cNvSpPr/>
+          <p:nvPr/>
+        </p:nvSpPr>
+        <p:spPr>
+          <a:xfrm>
+            <a:off x="6171205" y="3168692"/>
+            <a:ext cx="178785" cy="178785"/>
+          </a:xfrm>
+          <a:prstGeom prst="roundRect">
+            <a:avLst>
+              <a:gd name="adj" fmla="val 18000"/>
+            </a:avLst>
+          </a:prstGeom>
+          <a:solidFill>
+            <a:srgbClr val="E9EDF2"/>
+          </a:solidFill>
+          <a:ln/>
+        </p:spPr>
+      </p:sp>
+      <p:sp>
+        <p:nvSpPr>
+          <p:cNvPr id="60" name="Shape 58"/>
+          <p:cNvSpPr/>
+          <p:nvPr/>
+        </p:nvSpPr>
+        <p:spPr>
+          <a:xfrm>
+            <a:off x="4208929" y="3386722"/>
+            <a:ext cx="178785" cy="178785"/>
+          </a:xfrm>
+          <a:prstGeom prst="roundRect">
+            <a:avLst>
+              <a:gd name="adj" fmla="val 18000"/>
+            </a:avLst>
+          </a:prstGeom>
+          <a:solidFill>
+            <a:srgbClr val="E9EDF2"/>
+          </a:solidFill>
+          <a:ln/>
+        </p:spPr>
+      </p:sp>
+      <p:sp>
+        <p:nvSpPr>
+          <p:cNvPr id="61" name="Shape 59"/>
+          <p:cNvSpPr/>
+          <p:nvPr/>
+        </p:nvSpPr>
+        <p:spPr>
+          <a:xfrm>
+            <a:off x="4426960" y="3386722"/>
+            <a:ext cx="178785" cy="178785"/>
+          </a:xfrm>
+          <a:prstGeom prst="roundRect">
+            <a:avLst>
+              <a:gd name="adj" fmla="val 18000"/>
+            </a:avLst>
+          </a:prstGeom>
+          <a:solidFill>
+            <a:srgbClr val="E9EDF2"/>
+          </a:solidFill>
+          <a:ln/>
+        </p:spPr>
+      </p:sp>
+      <p:sp>
+        <p:nvSpPr>
+          <p:cNvPr id="62" name="Shape 60"/>
+          <p:cNvSpPr/>
+          <p:nvPr/>
+        </p:nvSpPr>
+        <p:spPr>
+          <a:xfrm>
+            <a:off x="4644991" y="3386722"/>
+            <a:ext cx="178785" cy="178785"/>
+          </a:xfrm>
+          <a:prstGeom prst="roundRect">
+            <a:avLst>
+              <a:gd name="adj" fmla="val 18000"/>
+            </a:avLst>
+          </a:prstGeom>
+          <a:solidFill>
+            <a:srgbClr val="E9EDF2"/>
+          </a:solidFill>
+          <a:ln/>
+        </p:spPr>
+      </p:sp>
+      <p:sp>
+        <p:nvSpPr>
+          <p:cNvPr id="63" name="Shape 61"/>
+          <p:cNvSpPr/>
+          <p:nvPr/>
+        </p:nvSpPr>
+        <p:spPr>
+          <a:xfrm>
+            <a:off x="4863021" y="3386722"/>
+            <a:ext cx="178785" cy="178785"/>
+          </a:xfrm>
+          <a:prstGeom prst="roundRect">
+            <a:avLst>
+              <a:gd name="adj" fmla="val 18000"/>
+            </a:avLst>
+          </a:prstGeom>
+          <a:solidFill>
+            <a:srgbClr val="E9EDF2"/>
+          </a:solidFill>
+          <a:ln/>
+        </p:spPr>
+      </p:sp>
+      <p:sp>
+        <p:nvSpPr>
+          <p:cNvPr id="64" name="Shape 62"/>
+          <p:cNvSpPr/>
+          <p:nvPr/>
+        </p:nvSpPr>
+        <p:spPr>
+          <a:xfrm>
+            <a:off x="5081052" y="3386722"/>
+            <a:ext cx="178785" cy="178785"/>
+          </a:xfrm>
+          <a:prstGeom prst="roundRect">
+            <a:avLst>
+              <a:gd name="adj" fmla="val 18000"/>
+            </a:avLst>
+          </a:prstGeom>
+          <a:solidFill>
+            <a:srgbClr val="E9EDF2"/>
+          </a:solidFill>
+          <a:ln/>
+        </p:spPr>
+      </p:sp>
+      <p:sp>
+        <p:nvSpPr>
+          <p:cNvPr id="65" name="Shape 63"/>
+          <p:cNvSpPr/>
+          <p:nvPr/>
+        </p:nvSpPr>
+        <p:spPr>
+          <a:xfrm>
+            <a:off x="5299082" y="3386722"/>
+            <a:ext cx="178785" cy="178785"/>
+          </a:xfrm>
+          <a:prstGeom prst="roundRect">
+            <a:avLst>
+              <a:gd name="adj" fmla="val 18000"/>
+            </a:avLst>
+          </a:prstGeom>
+          <a:solidFill>
+            <a:srgbClr val="E9EDF2"/>
+          </a:solidFill>
+          <a:ln/>
+        </p:spPr>
+      </p:sp>
+      <p:sp>
+        <p:nvSpPr>
+          <p:cNvPr id="66" name="Shape 64"/>
+          <p:cNvSpPr/>
+          <p:nvPr/>
+        </p:nvSpPr>
+        <p:spPr>
+          <a:xfrm>
+            <a:off x="5517113" y="3386722"/>
+            <a:ext cx="178785" cy="178785"/>
+          </a:xfrm>
+          <a:prstGeom prst="roundRect">
+            <a:avLst>
+              <a:gd name="adj" fmla="val 18000"/>
+            </a:avLst>
+          </a:prstGeom>
+          <a:solidFill>
+            <a:srgbClr val="E9EDF2"/>
+          </a:solidFill>
+          <a:ln/>
+        </p:spPr>
+      </p:sp>
+      <p:sp>
+        <p:nvSpPr>
+          <p:cNvPr id="67" name="Shape 65"/>
+          <p:cNvSpPr/>
+          <p:nvPr/>
+        </p:nvSpPr>
+        <p:spPr>
+          <a:xfrm>
+            <a:off x="5735144" y="3386722"/>
+            <a:ext cx="178785" cy="178785"/>
+          </a:xfrm>
+          <a:prstGeom prst="roundRect">
+            <a:avLst>
+              <a:gd name="adj" fmla="val 18000"/>
+            </a:avLst>
+          </a:prstGeom>
+          <a:solidFill>
+            <a:srgbClr val="E9EDF2"/>
+          </a:solidFill>
+          <a:ln/>
+        </p:spPr>
+      </p:sp>
+      <p:sp>
+        <p:nvSpPr>
+          <p:cNvPr id="68" name="Shape 66"/>
+          <p:cNvSpPr/>
+          <p:nvPr/>
+        </p:nvSpPr>
+        <p:spPr>
+          <a:xfrm>
+            <a:off x="5953174" y="3386722"/>
+            <a:ext cx="178785" cy="178785"/>
+          </a:xfrm>
+          <a:prstGeom prst="roundRect">
+            <a:avLst>
+              <a:gd name="adj" fmla="val 18000"/>
+            </a:avLst>
+          </a:prstGeom>
+          <a:solidFill>
+            <a:srgbClr val="E9EDF2"/>
+          </a:solidFill>
+          <a:ln/>
+        </p:spPr>
+      </p:sp>
+      <p:sp>
+        <p:nvSpPr>
+          <p:cNvPr id="69" name="Shape 67"/>
+          <p:cNvSpPr/>
+          <p:nvPr/>
+        </p:nvSpPr>
+        <p:spPr>
+          <a:xfrm>
+            <a:off x="6171205" y="3386722"/>
+            <a:ext cx="178785" cy="178785"/>
+          </a:xfrm>
+          <a:prstGeom prst="roundRect">
+            <a:avLst>
+              <a:gd name="adj" fmla="val 18000"/>
+            </a:avLst>
+          </a:prstGeom>
+          <a:solidFill>
+            <a:srgbClr val="E9EDF2"/>
+          </a:solidFill>
+          <a:ln/>
+        </p:spPr>
+      </p:sp>
+      <p:sp>
+        <p:nvSpPr>
+          <p:cNvPr id="70" name="Shape 68"/>
+          <p:cNvSpPr/>
+          <p:nvPr/>
+        </p:nvSpPr>
+        <p:spPr>
+          <a:xfrm>
+            <a:off x="4208929" y="3604753"/>
+            <a:ext cx="178785" cy="178785"/>
+          </a:xfrm>
+          <a:prstGeom prst="roundRect">
+            <a:avLst>
+              <a:gd name="adj" fmla="val 18000"/>
+            </a:avLst>
+          </a:prstGeom>
+          <a:solidFill>
+            <a:srgbClr val="E9EDF2"/>
+          </a:solidFill>
+          <a:ln/>
+        </p:spPr>
+      </p:sp>
+      <p:sp>
+        <p:nvSpPr>
+          <p:cNvPr id="71" name="Shape 69"/>
+          <p:cNvSpPr/>
+          <p:nvPr/>
+        </p:nvSpPr>
+        <p:spPr>
+          <a:xfrm>
+            <a:off x="4426960" y="3604753"/>
+            <a:ext cx="178785" cy="178785"/>
+          </a:xfrm>
+          <a:prstGeom prst="roundRect">
+            <a:avLst>
+              <a:gd name="adj" fmla="val 18000"/>
+            </a:avLst>
+          </a:prstGeom>
+          <a:solidFill>
+            <a:srgbClr val="E9EDF2"/>
+          </a:solidFill>
+          <a:ln/>
+        </p:spPr>
+      </p:sp>
+      <p:sp>
+        <p:nvSpPr>
+          <p:cNvPr id="72" name="Shape 70"/>
+          <p:cNvSpPr/>
+          <p:nvPr/>
+        </p:nvSpPr>
+        <p:spPr>
+          <a:xfrm>
+            <a:off x="4644991" y="3604753"/>
+            <a:ext cx="178785" cy="178785"/>
+          </a:xfrm>
+          <a:prstGeom prst="roundRect">
+            <a:avLst>
+              <a:gd name="adj" fmla="val 18000"/>
+            </a:avLst>
+          </a:prstGeom>
+          <a:solidFill>
+            <a:srgbClr val="E9EDF2"/>
+          </a:solidFill>
+          <a:ln/>
+        </p:spPr>
+      </p:sp>
+      <p:sp>
+        <p:nvSpPr>
+          <p:cNvPr id="73" name="Shape 71"/>
+          <p:cNvSpPr/>
+          <p:nvPr/>
+        </p:nvSpPr>
+        <p:spPr>
+          <a:xfrm>
+            <a:off x="4863021" y="3604753"/>
+            <a:ext cx="178785" cy="178785"/>
+          </a:xfrm>
+          <a:prstGeom prst="roundRect">
+            <a:avLst>
+              <a:gd name="adj" fmla="val 18000"/>
+            </a:avLst>
+          </a:prstGeom>
+          <a:solidFill>
+            <a:srgbClr val="E9EDF2"/>
+          </a:solidFill>
+          <a:ln/>
+        </p:spPr>
+      </p:sp>
+      <p:sp>
+        <p:nvSpPr>
+          <p:cNvPr id="74" name="Shape 72"/>
+          <p:cNvSpPr/>
+          <p:nvPr/>
+        </p:nvSpPr>
+        <p:spPr>
+          <a:xfrm>
+            <a:off x="5081052" y="3604753"/>
+            <a:ext cx="178785" cy="178785"/>
+          </a:xfrm>
+          <a:prstGeom prst="roundRect">
+            <a:avLst>
+              <a:gd name="adj" fmla="val 18000"/>
+            </a:avLst>
+          </a:prstGeom>
+          <a:solidFill>
+            <a:srgbClr val="E9EDF2"/>
+          </a:solidFill>
+          <a:ln/>
+        </p:spPr>
+      </p:sp>
+      <p:sp>
+        <p:nvSpPr>
+          <p:cNvPr id="75" name="Shape 73"/>
+          <p:cNvSpPr/>
+          <p:nvPr/>
+        </p:nvSpPr>
+        <p:spPr>
+          <a:xfrm>
+            <a:off x="5299082" y="3604753"/>
+            <a:ext cx="178785" cy="178785"/>
+          </a:xfrm>
+          <a:prstGeom prst="roundRect">
+            <a:avLst>
+              <a:gd name="adj" fmla="val 18000"/>
+            </a:avLst>
+          </a:prstGeom>
+          <a:solidFill>
+            <a:srgbClr val="E9EDF2"/>
+          </a:solidFill>
+          <a:ln/>
+        </p:spPr>
+      </p:sp>
+      <p:sp>
+        <p:nvSpPr>
+          <p:cNvPr id="76" name="Shape 74"/>
+          <p:cNvSpPr/>
+          <p:nvPr/>
+        </p:nvSpPr>
+        <p:spPr>
+          <a:xfrm>
+            <a:off x="5517113" y="3604753"/>
+            <a:ext cx="178785" cy="178785"/>
+          </a:xfrm>
+          <a:prstGeom prst="roundRect">
+            <a:avLst>
+              <a:gd name="adj" fmla="val 18000"/>
+            </a:avLst>
+          </a:prstGeom>
+          <a:solidFill>
+            <a:srgbClr val="E9EDF2"/>
+          </a:solidFill>
+          <a:ln/>
+        </p:spPr>
+      </p:sp>
+      <p:sp>
+        <p:nvSpPr>
+          <p:cNvPr id="77" name="Shape 75"/>
+          <p:cNvSpPr/>
+          <p:nvPr/>
+        </p:nvSpPr>
+        <p:spPr>
+          <a:xfrm>
+            <a:off x="5735144" y="3604753"/>
+            <a:ext cx="178785" cy="178785"/>
+          </a:xfrm>
+          <a:prstGeom prst="roundRect">
+            <a:avLst>
+              <a:gd name="adj" fmla="val 18000"/>
+            </a:avLst>
+          </a:prstGeom>
+          <a:solidFill>
+            <a:srgbClr val="E9EDF2"/>
+          </a:solidFill>
+          <a:ln/>
+        </p:spPr>
+      </p:sp>
+      <p:sp>
+        <p:nvSpPr>
+          <p:cNvPr id="78" name="Shape 76"/>
+          <p:cNvSpPr/>
+          <p:nvPr/>
+        </p:nvSpPr>
+        <p:spPr>
+          <a:xfrm>
+            <a:off x="5953174" y="3604753"/>
+            <a:ext cx="178785" cy="178785"/>
+          </a:xfrm>
+          <a:prstGeom prst="roundRect">
+            <a:avLst>
+              <a:gd name="adj" fmla="val 18000"/>
+            </a:avLst>
+          </a:prstGeom>
+          <a:solidFill>
+            <a:srgbClr val="E9EDF2"/>
+          </a:solidFill>
+          <a:ln/>
+        </p:spPr>
+      </p:sp>
+      <p:sp>
+        <p:nvSpPr>
+          <p:cNvPr id="79" name="Shape 77"/>
+          <p:cNvSpPr/>
+          <p:nvPr/>
+        </p:nvSpPr>
+        <p:spPr>
+          <a:xfrm>
+            <a:off x="6171205" y="3604753"/>
+            <a:ext cx="178785" cy="178785"/>
+          </a:xfrm>
+          <a:prstGeom prst="roundRect">
+            <a:avLst>
+              <a:gd name="adj" fmla="val 18000"/>
+            </a:avLst>
+          </a:prstGeom>
+          <a:solidFill>
+            <a:srgbClr val="E9EDF2"/>
+          </a:solidFill>
+          <a:ln/>
+        </p:spPr>
+      </p:sp>
+      <p:sp>
+        <p:nvSpPr>
+          <p:cNvPr id="80" name="Shape 78"/>
+          <p:cNvSpPr/>
+          <p:nvPr/>
+        </p:nvSpPr>
+        <p:spPr>
+          <a:xfrm>
+            <a:off x="4208929" y="3822784"/>
+            <a:ext cx="178785" cy="178785"/>
+          </a:xfrm>
+          <a:prstGeom prst="roundRect">
+            <a:avLst>
+              <a:gd name="adj" fmla="val 18000"/>
+            </a:avLst>
+          </a:prstGeom>
+          <a:solidFill>
+            <a:srgbClr val="2E7CF6"/>
+          </a:solidFill>
+          <a:ln/>
+        </p:spPr>
+      </p:sp>
+      <p:sp>
+        <p:nvSpPr>
+          <p:cNvPr id="81" name="Shape 79"/>
+          <p:cNvSpPr/>
+          <p:nvPr/>
+        </p:nvSpPr>
+        <p:spPr>
+          <a:xfrm>
+            <a:off x="4426960" y="3822784"/>
+            <a:ext cx="178785" cy="178785"/>
+          </a:xfrm>
+          <a:prstGeom prst="roundRect">
+            <a:avLst>
+              <a:gd name="adj" fmla="val 18000"/>
+            </a:avLst>
+          </a:prstGeom>
+          <a:solidFill>
+            <a:srgbClr val="E9EDF2"/>
+          </a:solidFill>
+          <a:ln/>
+        </p:spPr>
+      </p:sp>
+      <p:sp>
+        <p:nvSpPr>
+          <p:cNvPr id="82" name="Shape 80"/>
+          <p:cNvSpPr/>
+          <p:nvPr/>
+        </p:nvSpPr>
+        <p:spPr>
+          <a:xfrm>
+            <a:off x="4644991" y="3822784"/>
+            <a:ext cx="178785" cy="178785"/>
+          </a:xfrm>
+          <a:prstGeom prst="roundRect">
+            <a:avLst>
+              <a:gd name="adj" fmla="val 18000"/>
+            </a:avLst>
+          </a:prstGeom>
+          <a:solidFill>
+            <a:srgbClr val="E9EDF2"/>
+          </a:solidFill>
+          <a:ln/>
+        </p:spPr>
+      </p:sp>
+      <p:sp>
+        <p:nvSpPr>
+          <p:cNvPr id="83" name="Shape 81"/>
+          <p:cNvSpPr/>
+          <p:nvPr/>
+        </p:nvSpPr>
+        <p:spPr>
+          <a:xfrm>
+            <a:off x="4863021" y="3822784"/>
+            <a:ext cx="178785" cy="178785"/>
+          </a:xfrm>
+          <a:prstGeom prst="roundRect">
+            <a:avLst>
+              <a:gd name="adj" fmla="val 18000"/>
+            </a:avLst>
+          </a:prstGeom>
+          <a:solidFill>
+            <a:srgbClr val="E9EDF2"/>
+          </a:solidFill>
+          <a:ln/>
+        </p:spPr>
+      </p:sp>
+      <p:sp>
+        <p:nvSpPr>
+          <p:cNvPr id="84" name="Shape 82"/>
+          <p:cNvSpPr/>
+          <p:nvPr/>
+        </p:nvSpPr>
+        <p:spPr>
+          <a:xfrm>
+            <a:off x="5081052" y="3822784"/>
+            <a:ext cx="178785" cy="178785"/>
+          </a:xfrm>
+          <a:prstGeom prst="roundRect">
+            <a:avLst>
+              <a:gd name="adj" fmla="val 18000"/>
+            </a:avLst>
+          </a:prstGeom>
+          <a:solidFill>
+            <a:srgbClr val="E9EDF2"/>
+          </a:solidFill>
+          <a:ln/>
+        </p:spPr>
+      </p:sp>
+      <p:sp>
+        <p:nvSpPr>
+          <p:cNvPr id="85" name="Shape 83"/>
+          <p:cNvSpPr/>
+          <p:nvPr/>
+        </p:nvSpPr>
+        <p:spPr>
+          <a:xfrm>
+            <a:off x="5299082" y="3822784"/>
+            <a:ext cx="178785" cy="178785"/>
+          </a:xfrm>
+          <a:prstGeom prst="roundRect">
+            <a:avLst>
+              <a:gd name="adj" fmla="val 18000"/>
+            </a:avLst>
+          </a:prstGeom>
+          <a:solidFill>
+            <a:srgbClr val="E9EDF2"/>
+          </a:solidFill>
+          <a:ln/>
+        </p:spPr>
+      </p:sp>
+      <p:sp>
+        <p:nvSpPr>
+          <p:cNvPr id="86" name="Shape 84"/>
+          <p:cNvSpPr/>
+          <p:nvPr/>
+        </p:nvSpPr>
+        <p:spPr>
+          <a:xfrm>
+            <a:off x="5517113" y="3822784"/>
+            <a:ext cx="178785" cy="178785"/>
+          </a:xfrm>
+          <a:prstGeom prst="roundRect">
+            <a:avLst>
+              <a:gd name="adj" fmla="val 18000"/>
+            </a:avLst>
+          </a:prstGeom>
+          <a:solidFill>
+            <a:srgbClr val="E9EDF2"/>
+          </a:solidFill>
+          <a:ln/>
+        </p:spPr>
+      </p:sp>
+      <p:sp>
+        <p:nvSpPr>
+          <p:cNvPr id="87" name="Shape 85"/>
+          <p:cNvSpPr/>
+          <p:nvPr/>
+        </p:nvSpPr>
+        <p:spPr>
+          <a:xfrm>
+            <a:off x="5735144" y="3822784"/>
+            <a:ext cx="178785" cy="178785"/>
+          </a:xfrm>
+          <a:prstGeom prst="roundRect">
+            <a:avLst>
+              <a:gd name="adj" fmla="val 18000"/>
+            </a:avLst>
+          </a:prstGeom>
+          <a:solidFill>
+            <a:srgbClr val="E9EDF2"/>
+          </a:solidFill>
+          <a:ln/>
+        </p:spPr>
+      </p:sp>
+      <p:sp>
+        <p:nvSpPr>
+          <p:cNvPr id="88" name="Shape 86"/>
+          <p:cNvSpPr/>
+          <p:nvPr/>
+        </p:nvSpPr>
+        <p:spPr>
+          <a:xfrm>
+            <a:off x="5953174" y="3822784"/>
+            <a:ext cx="178785" cy="178785"/>
+          </a:xfrm>
+          <a:prstGeom prst="roundRect">
+            <a:avLst>
+              <a:gd name="adj" fmla="val 18000"/>
+            </a:avLst>
+          </a:prstGeom>
+          <a:solidFill>
+            <a:srgbClr val="E9EDF2"/>
+          </a:solidFill>
+          <a:ln/>
+        </p:spPr>
+      </p:sp>
+      <p:sp>
+        <p:nvSpPr>
+          <p:cNvPr id="89" name="Shape 87"/>
+          <p:cNvSpPr/>
+          <p:nvPr/>
+        </p:nvSpPr>
+        <p:spPr>
+          <a:xfrm>
+            <a:off x="6171205" y="3822784"/>
+            <a:ext cx="178785" cy="178785"/>
+          </a:xfrm>
+          <a:prstGeom prst="roundRect">
+            <a:avLst>
+              <a:gd name="adj" fmla="val 18000"/>
+            </a:avLst>
+          </a:prstGeom>
+          <a:solidFill>
+            <a:srgbClr val="E9EDF2"/>
+          </a:solidFill>
+          <a:ln/>
+        </p:spPr>
+      </p:sp>
+      <p:sp>
+        <p:nvSpPr>
+          <p:cNvPr id="90" name="Shape 88"/>
+          <p:cNvSpPr/>
+          <p:nvPr/>
+        </p:nvSpPr>
+        <p:spPr>
+          <a:xfrm>
+            <a:off x="4208929" y="4040814"/>
+            <a:ext cx="178785" cy="178785"/>
+          </a:xfrm>
+          <a:prstGeom prst="roundRect">
+            <a:avLst>
+              <a:gd name="adj" fmla="val 18000"/>
+            </a:avLst>
+          </a:prstGeom>
+          <a:solidFill>
+            <a:srgbClr val="2E7CF6"/>
+          </a:solidFill>
+          <a:ln/>
+        </p:spPr>
+      </p:sp>
+      <p:sp>
+        <p:nvSpPr>
+          <p:cNvPr id="91" name="Shape 89"/>
+          <p:cNvSpPr/>
+          <p:nvPr/>
+        </p:nvSpPr>
+        <p:spPr>
+          <a:xfrm>
+            <a:off x="4426960" y="4040814"/>
+            <a:ext cx="178785" cy="178785"/>
+          </a:xfrm>
+          <a:prstGeom prst="roundRect">
+            <a:avLst>
+              <a:gd name="adj" fmla="val 18000"/>
+            </a:avLst>
+          </a:prstGeom>
+          <a:solidFill>
+            <a:srgbClr val="2E7CF6"/>
+          </a:solidFill>
+          <a:ln/>
+        </p:spPr>
+      </p:sp>
+      <p:sp>
+        <p:nvSpPr>
+          <p:cNvPr id="92" name="Shape 90"/>
+          <p:cNvSpPr/>
+          <p:nvPr/>
+        </p:nvSpPr>
+        <p:spPr>
+          <a:xfrm>
+            <a:off x="4644991" y="4040814"/>
+            <a:ext cx="178785" cy="178785"/>
+          </a:xfrm>
+          <a:prstGeom prst="roundRect">
+            <a:avLst>
+              <a:gd name="adj" fmla="val 18000"/>
+            </a:avLst>
+          </a:prstGeom>
+          <a:solidFill>
+            <a:srgbClr val="2E7CF6"/>
+          </a:solidFill>
+          <a:ln/>
+        </p:spPr>
+      </p:sp>
+      <p:sp>
+        <p:nvSpPr>
+          <p:cNvPr id="93" name="Shape 91"/>
+          <p:cNvSpPr/>
+          <p:nvPr/>
+        </p:nvSpPr>
+        <p:spPr>
+          <a:xfrm>
+            <a:off x="4863021" y="4040814"/>
+            <a:ext cx="178785" cy="178785"/>
+          </a:xfrm>
+          <a:prstGeom prst="roundRect">
+            <a:avLst>
+              <a:gd name="adj" fmla="val 18000"/>
+            </a:avLst>
+          </a:prstGeom>
+          <a:solidFill>
+            <a:srgbClr val="2E7CF6"/>
+          </a:solidFill>
+          <a:ln/>
+        </p:spPr>
+      </p:sp>
+      <p:sp>
+        <p:nvSpPr>
+          <p:cNvPr id="94" name="Shape 92"/>
+          <p:cNvSpPr/>
+          <p:nvPr/>
+        </p:nvSpPr>
+        <p:spPr>
+          <a:xfrm>
+            <a:off x="5081052" y="4040814"/>
+            <a:ext cx="178785" cy="178785"/>
+          </a:xfrm>
+          <a:prstGeom prst="roundRect">
+            <a:avLst>
+              <a:gd name="adj" fmla="val 18000"/>
+            </a:avLst>
+          </a:prstGeom>
+          <a:solidFill>
+            <a:srgbClr val="2E7CF6"/>
+          </a:solidFill>
+          <a:ln/>
+        </p:spPr>
+      </p:sp>
+      <p:sp>
+        <p:nvSpPr>
+          <p:cNvPr id="95" name="Shape 93"/>
+          <p:cNvSpPr/>
+          <p:nvPr/>
+        </p:nvSpPr>
+        <p:spPr>
+          <a:xfrm>
+            <a:off x="5299082" y="4040814"/>
+            <a:ext cx="178785" cy="178785"/>
+          </a:xfrm>
+          <a:prstGeom prst="roundRect">
+            <a:avLst>
+              <a:gd name="adj" fmla="val 18000"/>
+            </a:avLst>
+          </a:prstGeom>
+          <a:solidFill>
+            <a:srgbClr val="2E7CF6"/>
+          </a:solidFill>
+          <a:ln/>
+        </p:spPr>
+      </p:sp>
+      <p:sp>
+        <p:nvSpPr>
+          <p:cNvPr id="96" name="Shape 94"/>
+          <p:cNvSpPr/>
+          <p:nvPr/>
+        </p:nvSpPr>
+        <p:spPr>
+          <a:xfrm>
+            <a:off x="5517113" y="4040814"/>
+            <a:ext cx="178785" cy="178785"/>
+          </a:xfrm>
+          <a:prstGeom prst="roundRect">
+            <a:avLst>
+              <a:gd name="adj" fmla="val 18000"/>
+            </a:avLst>
+          </a:prstGeom>
+          <a:solidFill>
+            <a:srgbClr val="2E7CF6"/>
+          </a:solidFill>
+          <a:ln/>
+        </p:spPr>
+      </p:sp>
+      <p:sp>
+        <p:nvSpPr>
+          <p:cNvPr id="97" name="Shape 95"/>
+          <p:cNvSpPr/>
+          <p:nvPr/>
+        </p:nvSpPr>
+        <p:spPr>
+          <a:xfrm>
+            <a:off x="5735144" y="4040814"/>
+            <a:ext cx="178785" cy="178785"/>
+          </a:xfrm>
+          <a:prstGeom prst="roundRect">
+            <a:avLst>
+              <a:gd name="adj" fmla="val 18000"/>
+            </a:avLst>
+          </a:prstGeom>
+          <a:solidFill>
+            <a:srgbClr val="2E7CF6"/>
+          </a:solidFill>
+          <a:ln/>
+        </p:spPr>
+      </p:sp>
+      <p:sp>
+        <p:nvSpPr>
+          <p:cNvPr id="98" name="Shape 96"/>
+          <p:cNvSpPr/>
+          <p:nvPr/>
+        </p:nvSpPr>
+        <p:spPr>
+          <a:xfrm>
+            <a:off x="5953174" y="4040814"/>
+            <a:ext cx="178785" cy="178785"/>
+          </a:xfrm>
+          <a:prstGeom prst="roundRect">
+            <a:avLst>
+              <a:gd name="adj" fmla="val 18000"/>
+            </a:avLst>
+          </a:prstGeom>
+          <a:solidFill>
+            <a:srgbClr val="2E7CF6"/>
+          </a:solidFill>
+          <a:ln/>
+        </p:spPr>
+      </p:sp>
+      <p:sp>
+        <p:nvSpPr>
+          <p:cNvPr id="99" name="Shape 97"/>
+          <p:cNvSpPr/>
+          <p:nvPr/>
+        </p:nvSpPr>
+        <p:spPr>
+          <a:xfrm>
+            <a:off x="6171205" y="4040814"/>
+            <a:ext cx="178785" cy="178785"/>
+          </a:xfrm>
+          <a:prstGeom prst="roundRect">
+            <a:avLst>
+              <a:gd name="adj" fmla="val 18000"/>
+            </a:avLst>
+          </a:prstGeom>
+          <a:solidFill>
+            <a:srgbClr val="2E7CF6"/>
+          </a:solidFill>
+          <a:ln/>
+        </p:spPr>
+      </p:sp>
+      <p:sp>
+        <p:nvSpPr>
+          <p:cNvPr id="100" name="Shape 98"/>
+          <p:cNvSpPr/>
+          <p:nvPr/>
+        </p:nvSpPr>
+        <p:spPr>
+          <a:xfrm>
+            <a:off x="4208929" y="4258845"/>
+            <a:ext cx="178785" cy="178785"/>
+          </a:xfrm>
+          <a:prstGeom prst="roundRect">
+            <a:avLst>
+              <a:gd name="adj" fmla="val 18000"/>
+            </a:avLst>
+          </a:prstGeom>
+          <a:solidFill>
+            <a:srgbClr val="2E7CF6"/>
+          </a:solidFill>
+          <a:ln/>
+        </p:spPr>
+      </p:sp>
+      <p:sp>
+        <p:nvSpPr>
+          <p:cNvPr id="101" name="Shape 99"/>
+          <p:cNvSpPr/>
+          <p:nvPr/>
+        </p:nvSpPr>
+        <p:spPr>
+          <a:xfrm>
+            <a:off x="4426960" y="4258845"/>
+            <a:ext cx="178785" cy="178785"/>
+          </a:xfrm>
+          <a:prstGeom prst="roundRect">
+            <a:avLst>
+              <a:gd name="adj" fmla="val 18000"/>
+            </a:avLst>
+          </a:prstGeom>
+          <a:solidFill>
+            <a:srgbClr val="2E7CF6"/>
+          </a:solidFill>
+          <a:ln/>
+        </p:spPr>
+      </p:sp>
+      <p:sp>
+        <p:nvSpPr>
+          <p:cNvPr id="102" name="Shape 100"/>
+          <p:cNvSpPr/>
+          <p:nvPr/>
+        </p:nvSpPr>
+        <p:spPr>
+          <a:xfrm>
+            <a:off x="4644991" y="4258845"/>
+            <a:ext cx="178785" cy="178785"/>
+          </a:xfrm>
+          <a:prstGeom prst="roundRect">
+            <a:avLst>
+              <a:gd name="adj" fmla="val 18000"/>
+            </a:avLst>
+          </a:prstGeom>
+          <a:solidFill>
+            <a:srgbClr val="2E7CF6"/>
+          </a:solidFill>
+          <a:ln/>
+        </p:spPr>
+      </p:sp>
+      <p:sp>
+        <p:nvSpPr>
+          <p:cNvPr id="103" name="Shape 101"/>
+          <p:cNvSpPr/>
+          <p:nvPr/>
+        </p:nvSpPr>
+        <p:spPr>
+          <a:xfrm>
+            <a:off x="4863021" y="4258845"/>
+            <a:ext cx="178785" cy="178785"/>
+          </a:xfrm>
+          <a:prstGeom prst="roundRect">
+            <a:avLst>
+              <a:gd name="adj" fmla="val 18000"/>
+            </a:avLst>
+          </a:prstGeom>
+          <a:solidFill>
+            <a:srgbClr val="2E7CF6"/>
+          </a:solidFill>
+          <a:ln/>
+        </p:spPr>
+      </p:sp>
+      <p:sp>
+        <p:nvSpPr>
+          <p:cNvPr id="104" name="Shape 102"/>
+          <p:cNvSpPr/>
+          <p:nvPr/>
+        </p:nvSpPr>
+        <p:spPr>
+          <a:xfrm>
+            <a:off x="5081052" y="4258845"/>
+            <a:ext cx="178785" cy="178785"/>
+          </a:xfrm>
+          <a:prstGeom prst="roundRect">
+            <a:avLst>
+              <a:gd name="adj" fmla="val 18000"/>
+            </a:avLst>
+          </a:prstGeom>
+          <a:solidFill>
+            <a:srgbClr val="2E7CF6"/>
+          </a:solidFill>
+          <a:ln/>
+        </p:spPr>
+      </p:sp>
+      <p:sp>
+        <p:nvSpPr>
+          <p:cNvPr id="105" name="Shape 103"/>
+          <p:cNvSpPr/>
+          <p:nvPr/>
+        </p:nvSpPr>
+        <p:spPr>
+          <a:xfrm>
+            <a:off x="5299082" y="4258845"/>
+            <a:ext cx="178785" cy="178785"/>
+          </a:xfrm>
+          <a:prstGeom prst="roundRect">
+            <a:avLst>
+              <a:gd name="adj" fmla="val 18000"/>
+            </a:avLst>
+          </a:prstGeom>
+          <a:solidFill>
+            <a:srgbClr val="2E7CF6"/>
+          </a:solidFill>
+          <a:ln/>
+        </p:spPr>
+      </p:sp>
+      <p:sp>
+        <p:nvSpPr>
+          <p:cNvPr id="106" name="Shape 104"/>
+          <p:cNvSpPr/>
+          <p:nvPr/>
+        </p:nvSpPr>
+        <p:spPr>
+          <a:xfrm>
+            <a:off x="5517113" y="4258845"/>
+            <a:ext cx="178785" cy="178785"/>
+          </a:xfrm>
+          <a:prstGeom prst="roundRect">
+            <a:avLst>
+              <a:gd name="adj" fmla="val 18000"/>
+            </a:avLst>
+          </a:prstGeom>
+          <a:solidFill>
+            <a:srgbClr val="2E7CF6"/>
+          </a:solidFill>
+          <a:ln/>
+        </p:spPr>
+      </p:sp>
+      <p:sp>
+        <p:nvSpPr>
+          <p:cNvPr id="107" name="Shape 105"/>
+          <p:cNvSpPr/>
+          <p:nvPr/>
+        </p:nvSpPr>
+        <p:spPr>
+          <a:xfrm>
+            <a:off x="5735144" y="4258845"/>
+            <a:ext cx="178785" cy="178785"/>
+          </a:xfrm>
+          <a:prstGeom prst="roundRect">
+            <a:avLst>
+              <a:gd name="adj" fmla="val 18000"/>
+            </a:avLst>
+          </a:prstGeom>
+          <a:solidFill>
+            <a:srgbClr val="2E7CF6"/>
+          </a:solidFill>
+          <a:ln/>
+        </p:spPr>
+      </p:sp>
+      <p:sp>
+        <p:nvSpPr>
+          <p:cNvPr id="108" name="Shape 106"/>
+          <p:cNvSpPr/>
+          <p:nvPr/>
+        </p:nvSpPr>
+        <p:spPr>
+          <a:xfrm>
+            <a:off x="5953174" y="4258845"/>
+            <a:ext cx="178785" cy="178785"/>
+          </a:xfrm>
+          <a:prstGeom prst="roundRect">
+            <a:avLst>
+              <a:gd name="adj" fmla="val 18000"/>
+            </a:avLst>
+          </a:prstGeom>
+          <a:solidFill>
+            <a:srgbClr val="2E7CF6"/>
+          </a:solidFill>
+          <a:ln/>
+        </p:spPr>
+      </p:sp>
+      <p:sp>
+        <p:nvSpPr>
+          <p:cNvPr id="109" name="Shape 107"/>
+          <p:cNvSpPr/>
+          <p:nvPr/>
+        </p:nvSpPr>
+        <p:spPr>
+          <a:xfrm>
+            <a:off x="6171205" y="4258845"/>
+            <a:ext cx="178785" cy="178785"/>
+          </a:xfrm>
+          <a:prstGeom prst="roundRect">
+            <a:avLst>
+              <a:gd name="adj" fmla="val 18000"/>
+            </a:avLst>
+          </a:prstGeom>
+          <a:solidFill>
+            <a:srgbClr val="2E7CF6"/>
+          </a:solidFill>
+          <a:ln/>
+        </p:spPr>
+      </p:sp>
+      <p:sp>
+        <p:nvSpPr>
+          <p:cNvPr id="110" name="Shape 108"/>
+          <p:cNvSpPr/>
+          <p:nvPr/>
+        </p:nvSpPr>
+        <p:spPr>
+          <a:xfrm>
+            <a:off x="4208929" y="4476876"/>
+            <a:ext cx="178785" cy="178785"/>
+          </a:xfrm>
+          <a:prstGeom prst="roundRect">
+            <a:avLst>
+              <a:gd name="adj" fmla="val 18000"/>
+            </a:avLst>
+          </a:prstGeom>
+          <a:solidFill>
+            <a:srgbClr val="2E7CF6"/>
+          </a:solidFill>
+          <a:ln/>
+        </p:spPr>
+      </p:sp>
+      <p:sp>
+        <p:nvSpPr>
+          <p:cNvPr id="111" name="Shape 109"/>
+          <p:cNvSpPr/>
+          <p:nvPr/>
+        </p:nvSpPr>
+        <p:spPr>
+          <a:xfrm>
+            <a:off x="4426960" y="4476876"/>
+            <a:ext cx="178785" cy="178785"/>
+          </a:xfrm>
+          <a:prstGeom prst="roundRect">
+            <a:avLst>
+              <a:gd name="adj" fmla="val 18000"/>
+            </a:avLst>
+          </a:prstGeom>
+          <a:solidFill>
+            <a:srgbClr val="2E7CF6"/>
+          </a:solidFill>
+          <a:ln/>
+        </p:spPr>
+      </p:sp>
+      <p:sp>
+        <p:nvSpPr>
+          <p:cNvPr id="112" name="Shape 110"/>
+          <p:cNvSpPr/>
+          <p:nvPr/>
+        </p:nvSpPr>
+        <p:spPr>
+          <a:xfrm>
+            <a:off x="4644991" y="4476876"/>
+            <a:ext cx="178785" cy="178785"/>
+          </a:xfrm>
+          <a:prstGeom prst="roundRect">
+            <a:avLst>
+              <a:gd name="adj" fmla="val 18000"/>
+            </a:avLst>
+          </a:prstGeom>
+          <a:solidFill>
+            <a:srgbClr val="2E7CF6"/>
+          </a:solidFill>
+          <a:ln/>
+        </p:spPr>
+      </p:sp>
+      <p:sp>
+        <p:nvSpPr>
+          <p:cNvPr id="113" name="Shape 111"/>
+          <p:cNvSpPr/>
+          <p:nvPr/>
+        </p:nvSpPr>
+        <p:spPr>
+          <a:xfrm>
+            <a:off x="4863021" y="4476876"/>
+            <a:ext cx="178785" cy="178785"/>
+          </a:xfrm>
+          <a:prstGeom prst="roundRect">
+            <a:avLst>
+              <a:gd name="adj" fmla="val 18000"/>
+            </a:avLst>
+          </a:prstGeom>
+          <a:solidFill>
+            <a:srgbClr val="2E7CF6"/>
+          </a:solidFill>
+          <a:ln/>
+        </p:spPr>
+      </p:sp>
+      <p:sp>
+        <p:nvSpPr>
+          <p:cNvPr id="114" name="Shape 112"/>
+          <p:cNvSpPr/>
+          <p:nvPr/>
+        </p:nvSpPr>
+        <p:spPr>
+          <a:xfrm>
+            <a:off x="5081052" y="4476876"/>
+            <a:ext cx="178785" cy="178785"/>
+          </a:xfrm>
+          <a:prstGeom prst="roundRect">
+            <a:avLst>
+              <a:gd name="adj" fmla="val 18000"/>
+            </a:avLst>
+          </a:prstGeom>
+          <a:solidFill>
+            <a:srgbClr val="2E7CF6"/>
+          </a:solidFill>
+          <a:ln/>
+        </p:spPr>
+      </p:sp>
+      <p:sp>
+        <p:nvSpPr>
+          <p:cNvPr id="115" name="Shape 113"/>
+          <p:cNvSpPr/>
+          <p:nvPr/>
+        </p:nvSpPr>
+        <p:spPr>
+          <a:xfrm>
+            <a:off x="5299082" y="4476876"/>
+            <a:ext cx="178785" cy="178785"/>
+          </a:xfrm>
+          <a:prstGeom prst="roundRect">
+            <a:avLst>
+              <a:gd name="adj" fmla="val 18000"/>
+            </a:avLst>
+          </a:prstGeom>
+          <a:solidFill>
+            <a:srgbClr val="2E7CF6"/>
+          </a:solidFill>
+          <a:ln/>
+        </p:spPr>
+      </p:sp>
+      <p:sp>
+        <p:nvSpPr>
+          <p:cNvPr id="116" name="Shape 114"/>
+          <p:cNvSpPr/>
+          <p:nvPr/>
+        </p:nvSpPr>
+        <p:spPr>
+          <a:xfrm>
+            <a:off x="5517113" y="4476876"/>
+            <a:ext cx="178785" cy="178785"/>
+          </a:xfrm>
+          <a:prstGeom prst="roundRect">
+            <a:avLst>
+              <a:gd name="adj" fmla="val 18000"/>
+            </a:avLst>
+          </a:prstGeom>
+          <a:solidFill>
+            <a:srgbClr val="2E7CF6"/>
+          </a:solidFill>
+          <a:ln/>
+        </p:spPr>
+      </p:sp>
+      <p:sp>
+        <p:nvSpPr>
+          <p:cNvPr id="117" name="Shape 115"/>
+          <p:cNvSpPr/>
+          <p:nvPr/>
+        </p:nvSpPr>
+        <p:spPr>
+          <a:xfrm>
+            <a:off x="5735144" y="4476876"/>
+            <a:ext cx="178785" cy="178785"/>
+          </a:xfrm>
+          <a:prstGeom prst="roundRect">
+            <a:avLst>
+              <a:gd name="adj" fmla="val 18000"/>
+            </a:avLst>
+          </a:prstGeom>
+          <a:solidFill>
+            <a:srgbClr val="2E7CF6"/>
+          </a:solidFill>
+          <a:ln/>
+        </p:spPr>
+      </p:sp>
+      <p:sp>
+        <p:nvSpPr>
+          <p:cNvPr id="118" name="Shape 116"/>
+          <p:cNvSpPr/>
+          <p:nvPr/>
+        </p:nvSpPr>
+        <p:spPr>
+          <a:xfrm>
+            <a:off x="5953174" y="4476876"/>
+            <a:ext cx="178785" cy="178785"/>
+          </a:xfrm>
+          <a:prstGeom prst="roundRect">
+            <a:avLst>
+              <a:gd name="adj" fmla="val 18000"/>
+            </a:avLst>
+          </a:prstGeom>
+          <a:solidFill>
+            <a:srgbClr val="2E7CF6"/>
+          </a:solidFill>
+          <a:ln/>
+        </p:spPr>
+      </p:sp>
+      <p:sp>
+        <p:nvSpPr>
+          <p:cNvPr id="119" name="Shape 117"/>
+          <p:cNvSpPr/>
+          <p:nvPr/>
+        </p:nvSpPr>
+        <p:spPr>
+          <a:xfrm>
+            <a:off x="6171205" y="4476876"/>
+            <a:ext cx="178785" cy="178785"/>
+          </a:xfrm>
+          <a:prstGeom prst="roundRect">
+            <a:avLst>
+              <a:gd name="adj" fmla="val 18000"/>
+            </a:avLst>
+          </a:prstGeom>
+          <a:solidFill>
+            <a:srgbClr val="2E7CF6"/>
+          </a:solidFill>
+          <a:ln/>
+        </p:spPr>
+      </p:sp>
+      <p:sp>
+        <p:nvSpPr>
+          <p:cNvPr id="120" name="Text 118"/>
+          <p:cNvSpPr/>
+          <p:nvPr/>
+        </p:nvSpPr>
+        <p:spPr>
+          <a:xfrm>
+            <a:off x="6663556" y="2950661"/>
+            <a:ext cx="1509567" cy="731520"/>
+          </a:xfrm>
+          <a:prstGeom prst="rect">
+            <a:avLst/>
+          </a:prstGeom>
+          <a:noFill/>
+          <a:ln/>
+        </p:spPr>
+        <p:txBody>
+          <a:bodyPr wrap="square" lIns="0" tIns="0" rIns="0" bIns="0" rtlCol="0" anchor="ctr"/>
+          <a:lstStyle/>
+          <a:p>
+            <a:pPr indent="0" marL="0">
+              <a:buNone/>
+            </a:pPr>
+            <a:r>
+              <a:rPr lang="en-US" sz="4000" b="1" dirty="0">
+                <a:solidFill>
+                  <a:srgbClr val="1A1A1A"/>
+                </a:solidFill>
+                <a:latin typeface="Arial" pitchFamily="34" charset="0"/>
+                <a:ea typeface="Arial" pitchFamily="34" charset="-122"/>
+                <a:cs typeface="Arial" pitchFamily="34" charset="-120"/>
+              </a:rPr>
+              <a:t>31%</a:t>
+            </a:r>
+            <a:endParaRPr lang="en-US" sz="4000" dirty="0"/>
+          </a:p>
+        </p:txBody>
+      </p:sp>
+      <p:sp>
+        <p:nvSpPr>
+          <p:cNvPr id="121" name="Text 119"/>
+          <p:cNvSpPr/>
+          <p:nvPr/>
+        </p:nvSpPr>
+        <p:spPr>
+          <a:xfrm>
+            <a:off x="6663556" y="3727901"/>
+            <a:ext cx="1509567" cy="914400"/>
+          </a:xfrm>
+          <a:prstGeom prst="rect">
+            <a:avLst/>
+          </a:prstGeom>
+          <a:noFill/>
+          <a:ln/>
+        </p:spPr>
+        <p:txBody>
+          <a:bodyPr wrap="square" lIns="0" tIns="0" rIns="0" bIns="0" rtlCol="0" anchor="t"/>
+          <a:lstStyle/>
+          <a:p>
+            <a:pPr indent="0" marL="0">
+              <a:lnSpc>
+                <a:spcPct val="115000"/>
+              </a:lnSpc>
+              <a:buNone/>
+            </a:pPr>
+            <a:r>
+              <a:rPr lang="en-US" sz="1200" dirty="0">
+                <a:solidFill>
+                  <a:srgbClr val="595959"/>
+                </a:solidFill>
+                <a:latin typeface="Arial" pitchFamily="34" charset="0"/>
+                <a:ea typeface="Arial" pitchFamily="34" charset="-122"/>
+                <a:cs typeface="Arial" pitchFamily="34" charset="-120"/>
+              </a:rPr>
+              <a:t>of installed-base parts spend captured today</a:t>
+            </a:r>
+            <a:endParaRPr lang="en-US" sz="1200" dirty="0"/>
+          </a:p>
+        </p:txBody>
+      </p:sp>
+      <p:sp>
+        <p:nvSpPr>
+          <p:cNvPr id="122" name="Text 120"/>
           <p:cNvSpPr/>
           <p:nvPr/>
         </p:nvSpPr>
@@ -27337,33 +30971,246 @@
           </a:p>
         </p:txBody>
       </p:sp>
-      <p:pic>
-        <p:nvPicPr>
-          <p:cNvPr id="11" name="Image 2" descr="/Users/othmane_benkirane/.claude/skills/sprintospptx-v3/examples/gd-assets/venn-989f31a059.png">    </p:cNvPr>
-          <p:cNvPicPr>
-            <a:picLocks noChangeAspect="1"/>
-          </p:cNvPicPr>
-          <p:nvPr/>
-        </p:nvPicPr>
-        <p:blipFill>
-          <a:blip r:embed="rId3"/>
-          <a:stretch>
-            <a:fillRect/>
-          </a:stretch>
-        </p:blipFill>
-        <p:spPr>
-          <a:xfrm>
-            <a:off x="8630322" y="2395728"/>
-            <a:ext cx="2799678" cy="2544907"/>
-          </a:xfrm>
-          <a:prstGeom prst="rect">
-            <a:avLst/>
-          </a:prstGeom>
-        </p:spPr>
-      </p:pic>
-      <p:sp>
-        <p:nvSpPr>
-          <p:cNvPr id="12" name="Text 7"/>
+      <p:sp>
+        <p:nvSpPr>
+          <p:cNvPr id="123" name="Shape 121"/>
+          <p:cNvSpPr/>
+          <p:nvPr/>
+        </p:nvSpPr>
+        <p:spPr>
+          <a:xfrm>
+            <a:off x="9142187" y="2135771"/>
+            <a:ext cx="1913108" cy="1913108"/>
+          </a:xfrm>
+          <a:prstGeom prst="ellipse">
+            <a:avLst/>
+          </a:prstGeom>
+          <a:solidFill>
+            <a:srgbClr val="2E7CF6">
+              <a:alpha val="38000"/>
+            </a:srgbClr>
+          </a:solidFill>
+          <a:ln w="12700">
+            <a:solidFill>
+              <a:srgbClr val="2E7CF6"/>
+            </a:solidFill>
+            <a:prstDash val="solid"/>
+          </a:ln>
+        </p:spPr>
+      </p:sp>
+      <p:sp>
+        <p:nvSpPr>
+          <p:cNvPr id="124" name="Shape 122"/>
+          <p:cNvSpPr/>
+          <p:nvPr/>
+        </p:nvSpPr>
+        <p:spPr>
+          <a:xfrm>
+            <a:off x="8596569" y="3084673"/>
+            <a:ext cx="1913108" cy="1913108"/>
+          </a:xfrm>
+          <a:prstGeom prst="ellipse">
+            <a:avLst/>
+          </a:prstGeom>
+          <a:solidFill>
+            <a:srgbClr val="76B900">
+              <a:alpha val="38000"/>
+            </a:srgbClr>
+          </a:solidFill>
+          <a:ln w="12700">
+            <a:solidFill>
+              <a:srgbClr val="76B900"/>
+            </a:solidFill>
+            <a:prstDash val="solid"/>
+          </a:ln>
+        </p:spPr>
+      </p:sp>
+      <p:sp>
+        <p:nvSpPr>
+          <p:cNvPr id="125" name="Shape 123"/>
+          <p:cNvSpPr/>
+          <p:nvPr/>
+        </p:nvSpPr>
+        <p:spPr>
+          <a:xfrm>
+            <a:off x="9687806" y="3084673"/>
+            <a:ext cx="1913108" cy="1913108"/>
+          </a:xfrm>
+          <a:prstGeom prst="ellipse">
+            <a:avLst/>
+          </a:prstGeom>
+          <a:solidFill>
+            <a:srgbClr val="F2A900">
+              <a:alpha val="38000"/>
+            </a:srgbClr>
+          </a:solidFill>
+          <a:ln w="12700">
+            <a:solidFill>
+              <a:srgbClr val="F2A900"/>
+            </a:solidFill>
+            <a:prstDash val="solid"/>
+          </a:ln>
+        </p:spPr>
+      </p:sp>
+      <p:sp>
+        <p:nvSpPr>
+          <p:cNvPr id="126" name="Text 124"/>
+          <p:cNvSpPr/>
+          <p:nvPr/>
+        </p:nvSpPr>
+        <p:spPr>
+          <a:xfrm>
+            <a:off x="9367221" y="3700856"/>
+            <a:ext cx="1463040" cy="274320"/>
+          </a:xfrm>
+          <a:prstGeom prst="rect">
+            <a:avLst/>
+          </a:prstGeom>
+          <a:noFill/>
+          <a:ln/>
+        </p:spPr>
+        <p:txBody>
+          <a:bodyPr wrap="square" lIns="0" tIns="0" rIns="0" bIns="0" rtlCol="0" anchor="ctr"/>
+          <a:lstStyle/>
+          <a:p>
+            <a:pPr algn="ctr" indent="0" marL="0">
+              <a:buNone/>
+            </a:pPr>
+            <a:r>
+              <a:rPr lang="en-US" sz="1200" b="1" dirty="0">
+                <a:solidFill>
+                  <a:srgbClr val="1A1A1A"/>
+                </a:solidFill>
+                <a:latin typeface="Arial" pitchFamily="34" charset="0"/>
+                <a:ea typeface="Arial" pitchFamily="34" charset="-122"/>
+                <a:cs typeface="Arial" pitchFamily="34" charset="-120"/>
+              </a:rPr>
+              <a:t>Premium</a:t>
+            </a:r>
+            <a:endParaRPr lang="en-US" sz="1200" dirty="0"/>
+          </a:p>
+        </p:txBody>
+      </p:sp>
+      <p:sp>
+        <p:nvSpPr>
+          <p:cNvPr id="127" name="Text 125"/>
+          <p:cNvSpPr/>
+          <p:nvPr/>
+        </p:nvSpPr>
+        <p:spPr>
+          <a:xfrm>
+            <a:off x="9184341" y="1861451"/>
+            <a:ext cx="1828800" cy="256032"/>
+          </a:xfrm>
+          <a:prstGeom prst="rect">
+            <a:avLst/>
+          </a:prstGeom>
+          <a:noFill/>
+          <a:ln/>
+        </p:spPr>
+        <p:txBody>
+          <a:bodyPr wrap="square" lIns="0" tIns="0" rIns="0" bIns="0" rtlCol="0" anchor="ctr"/>
+          <a:lstStyle/>
+          <a:p>
+            <a:pPr algn="ctr" indent="0" marL="0">
+              <a:buNone/>
+            </a:pPr>
+            <a:r>
+              <a:rPr lang="en-US" sz="1100" b="1" dirty="0">
+                <a:solidFill>
+                  <a:srgbClr val="1A1A1A"/>
+                </a:solidFill>
+                <a:latin typeface="Arial" pitchFamily="34" charset="0"/>
+                <a:ea typeface="Arial" pitchFamily="34" charset="-122"/>
+                <a:cs typeface="Arial" pitchFamily="34" charset="-120"/>
+              </a:rPr>
+              <a:t>Uptime need</a:t>
+            </a:r>
+            <a:endParaRPr lang="en-US" sz="1100" dirty="0"/>
+          </a:p>
+        </p:txBody>
+      </p:sp>
+      <p:sp>
+        <p:nvSpPr>
+          <p:cNvPr id="128" name="Text 126"/>
+          <p:cNvSpPr/>
+          <p:nvPr/>
+        </p:nvSpPr>
+        <p:spPr>
+          <a:xfrm>
+            <a:off x="8139369" y="5034356"/>
+            <a:ext cx="1828800" cy="256032"/>
+          </a:xfrm>
+          <a:prstGeom prst="rect">
+            <a:avLst/>
+          </a:prstGeom>
+          <a:noFill/>
+          <a:ln/>
+        </p:spPr>
+        <p:txBody>
+          <a:bodyPr wrap="square" lIns="0" tIns="0" rIns="0" bIns="0" rtlCol="0" anchor="ctr"/>
+          <a:lstStyle/>
+          <a:p>
+            <a:pPr algn="ctr" indent="0" marL="0">
+              <a:buNone/>
+            </a:pPr>
+            <a:r>
+              <a:rPr lang="en-US" sz="1100" b="1" dirty="0">
+                <a:solidFill>
+                  <a:srgbClr val="1A1A1A"/>
+                </a:solidFill>
+                <a:latin typeface="Arial" pitchFamily="34" charset="0"/>
+                <a:ea typeface="Arial" pitchFamily="34" charset="-122"/>
+                <a:cs typeface="Arial" pitchFamily="34" charset="-120"/>
+              </a:rPr>
+              <a:t>Field coverage</a:t>
+            </a:r>
+            <a:endParaRPr lang="en-US" sz="1100" dirty="0"/>
+          </a:p>
+        </p:txBody>
+      </p:sp>
+      <p:sp>
+        <p:nvSpPr>
+          <p:cNvPr id="129" name="Text 127"/>
+          <p:cNvSpPr/>
+          <p:nvPr/>
+        </p:nvSpPr>
+        <p:spPr>
+          <a:xfrm>
+            <a:off x="10229313" y="5034356"/>
+            <a:ext cx="1828800" cy="256032"/>
+          </a:xfrm>
+          <a:prstGeom prst="rect">
+            <a:avLst/>
+          </a:prstGeom>
+          <a:noFill/>
+          <a:ln/>
+        </p:spPr>
+        <p:txBody>
+          <a:bodyPr wrap="square" lIns="0" tIns="0" rIns="0" bIns="0" rtlCol="0" anchor="ctr"/>
+          <a:lstStyle/>
+          <a:p>
+            <a:pPr algn="ctr" indent="0" marL="0">
+              <a:buNone/>
+            </a:pPr>
+            <a:r>
+              <a:rPr lang="en-US" sz="1100" b="1" dirty="0">
+                <a:solidFill>
+                  <a:srgbClr val="1A1A1A"/>
+                </a:solidFill>
+                <a:latin typeface="Arial" pitchFamily="34" charset="0"/>
+                <a:ea typeface="Arial" pitchFamily="34" charset="-122"/>
+                <a:cs typeface="Arial" pitchFamily="34" charset="-120"/>
+              </a:rPr>
+              <a:t>Usage data</a:t>
+            </a:r>
+            <a:endParaRPr lang="en-US" sz="1100" dirty="0"/>
+          </a:p>
+        </p:txBody>
+      </p:sp>
+      <p:sp>
+        <p:nvSpPr>
+          <p:cNvPr id="130" name="Text 128"/>
           <p:cNvSpPr/>
           <p:nvPr/>
         </p:nvSpPr>
@@ -27402,7 +31249,7 @@
       </p:sp>
       <p:sp>
         <p:nvSpPr>
-          <p:cNvPr id="13" name="Text 8"/>
+          <p:cNvPr id="131" name="Text 129"/>
           <p:cNvSpPr/>
           <p:nvPr/>
         </p:nvSpPr>

</xml_diff>

<commit_message>
Release v1.6.1: hardening release — 20 defects fixed after a 68-agent audit
</commit_message>
<xml_diff>
--- a/examples/golden-deck.pptx
+++ b/examples/golden-deck.pptx
@@ -1210,7 +1210,6 @@
                 </a:pPr>
               </a:p>
             </c:txPr>
-            <c:dLblPos val="outEnd"/>
             <c:showLegendKey val="0"/>
             <c:showVal val="0"/>
             <c:showCatName val="0"/>
@@ -1285,7 +1284,6 @@
               </a:pPr>
             </a:p>
           </c:txPr>
-          <c:dLblPos val="outEnd"/>
           <c:showLegendKey val="0"/>
           <c:showVal val="0"/>
           <c:showCatName val="0"/>
@@ -1346,7 +1344,6 @@
                 </a:pPr>
               </a:p>
             </c:txPr>
-            <c:dLblPos val="outEnd"/>
             <c:showLegendKey val="0"/>
             <c:showVal val="0"/>
             <c:showCatName val="0"/>
@@ -1439,7 +1436,6 @@
               </a:pPr>
             </a:p>
           </c:txPr>
-          <c:dLblPos val="outEnd"/>
           <c:showLegendKey val="0"/>
           <c:showVal val="0"/>
           <c:showCatName val="0"/>
@@ -6470,7 +6466,7 @@
                 <a:ea typeface="Arial" pitchFamily="34" charset="-122"/>
                 <a:cs typeface="Arial" pitchFamily="34" charset="-120"/>
               </a:rPr>
-              <a:t>Novaserv closing and retention plan for the 60 technicians; design of the managed offer and of the linked equipment + contract pricing; contracting of the partner platform; recruitment of the installed-base sales core team (8 people).</a:t>
+              <a:t>Novaserv closing and retention plan for the 60 technicians; design of the managed offer and of the linked equipment + contract pricing; contracting of the partner platform; recruitment of the installed-base sales core team (8 people). Exit criterion: retention plan signed by at least 15 of the 18 targeted senior technicians before any public announcement.</a:t>
             </a:r>
             <a:endParaRPr lang="en-US" sz="1200" dirty="0"/>
           </a:p>
@@ -6649,7 +6645,7 @@
                 <a:ea typeface="Arial" pitchFamily="34" charset="-122"/>
                 <a:cs typeface="Arial" pitchFamily="34" charset="-120"/>
               </a:rPr>
-              <a:t>Pilot on 400 connected sites in the North region: measurement of the attach rate (go/no-go threshold: 20%), of actual margin per contract and of satisfaction; premium pricing adjustment; first cohort of 40 technicians trained in predictive maintenance.</a:t>
+              <a:t>Pilot on 400 connected sites in the North region: measurement of the attach rate (go/no-go threshold: 20%), of actual margin per contract and of satisfaction; premium pricing adjustment; first cohort of 40 technicians trained in predictive maintenance. The go/no-go is contractual: below a 20% attach rate the roll-out stops and the investment case is reviewed.</a:t>
             </a:r>
             <a:endParaRPr lang="en-US" sz="1200" dirty="0"/>
           </a:p>
@@ -6828,7 +6824,7 @@
                 <a:ea typeface="Arial" pitchFamily="34" charset="-122"/>
                 <a:cs typeface="Arial" pitchFamily="34" charset="-120"/>
               </a:rPr>
-              <a:t>Roll-out in regional waves (North, East, Rhone, West, South), migration of the 2,100 Novaserv contracts to the target platform, training of 300 technicians, build-up of forward stock in the 12 regional hubs.</a:t>
+              <a:t>Roll-out in regional waves (North, East, Rhone, West, South), migration of the 2,100 Novaserv contracts to the target platform, training of 300 technicians, build-up of forward stock in the 12 regional hubs. Each wave starts only when the previous one holds a 95% contract-renewal rate, so quality gates the pace.</a:t>
             </a:r>
             <a:endParaRPr lang="en-US" sz="1200" dirty="0"/>
           </a:p>
@@ -7007,7 +7003,7 @@
                 <a:ea typeface="Arial" pitchFamily="34" charset="-122"/>
                 <a:cs typeface="Arial" pitchFamily="34" charset="-120"/>
               </a:rPr>
-              <a:t>Predictive maintenance generalized across the connected base (target: 11,000 sites), upgrade of standard contracts to premium, supplier renegotiation on consolidated parts volumes, preparation of the Benelux extension.</a:t>
+              <a:t>Predictive maintenance generalized across the connected base (target: 11,000 sites), upgrade of standard contracts to premium, supplier renegotiation on consolidated parts volumes, preparation of the Benelux extension. Target exit state: 35% services mix, 11,000 connected sites, and a parts capture rate above 55%.</a:t>
             </a:r>
             <a:endParaRPr lang="en-US" sz="1200" dirty="0"/>
           </a:p>
@@ -24408,7 +24404,36 @@
                 <a:ea typeface="Arial" pitchFamily="34" charset="-122"/>
                 <a:cs typeface="Arial" pitchFamily="34" charset="-120"/>
               </a:rPr>
-              <a:t>Everything in this program either raises the attach rate or raises the value of an attached contract.</a:t>
+              <a:t>Everything in this program either raises the attach rate or raises the value of an attached contract. That is why the steering pack tracks five tiles and nothing else: pilot conversion, the Novaserv integration, people readiness, platform delivery and the EBITDA trajectory.</a:t>
+            </a:r>
+            <a:endParaRPr lang="en-US" sz="1200" dirty="0"/>
+          </a:p>
+          <a:p>
+            <a:pPr indent="0" marL="0">
+              <a:lnSpc>
+                <a:spcPct val="120000"/>
+              </a:lnSpc>
+              <a:buNone/>
+            </a:pPr>
+            <a:endParaRPr lang="en-US" sz="1200" dirty="0"/>
+          </a:p>
+          <a:p>
+            <a:pPr indent="0" marL="0">
+              <a:lnSpc>
+                <a:spcPct val="120000"/>
+              </a:lnSpc>
+              <a:buNone/>
+            </a:pPr>
+            <a:r>
+              <a:rPr lang="en-US" sz="1200" dirty="0">
+                <a:solidFill>
+                  <a:srgbClr val="1A1A1A"/>
+                </a:solidFill>
+                <a:latin typeface="Arial" pitchFamily="34" charset="0"/>
+                <a:ea typeface="Arial" pitchFamily="34" charset="-122"/>
+                <a:cs typeface="Arial" pitchFamily="34" charset="-120"/>
+              </a:rPr>
+              <a:t>If one tile turns red, the program slows; if two do, it stops and the case is re-underwritten.</a:t>
             </a:r>
             <a:endParaRPr lang="en-US" sz="1200" dirty="0"/>
           </a:p>
@@ -25178,7 +25203,7 @@
                 <a:ea typeface="Arial" pitchFamily="34" charset="-122"/>
                 <a:cs typeface="Arial" pitchFamily="34" charset="-120"/>
               </a:rPr>
-              <a:t>EBITDA doubles in the base case.</a:t>
+              <a:t>EBITDA doubles in the base case, with payback in 4.2 years and a +EUR 147M NPV at a 9% discount rate.</a:t>
             </a:r>
             <a:endParaRPr lang="en-US" sz="1200" dirty="0"/>
           </a:p>
@@ -25353,7 +25378,7 @@
                 <a:ea typeface="Arial" pitchFamily="34" charset="-122"/>
                 <a:cs typeface="Arial" pitchFamily="34" charset="-120"/>
               </a:rPr>
-              <a:t>The same case, told through every exhibit family of the kit: native charts, SVG exhibits, craft primitives, dark KPI strip.</a:t>
+              <a:t>The same case, told through every exhibit family of the kit: native charts, editable exhibit primitives, dark KPI strip.</a:t>
             </a:r>
             <a:endParaRPr lang="en-US" sz="1500" dirty="0"/>
           </a:p>
@@ -25466,7 +25491,7 @@
                 <a:ea typeface="Arial" pitchFamily="34" charset="-122"/>
                 <a:cs typeface="Arial" pitchFamily="34" charset="-120"/>
               </a:rPr>
-              <a:t>Standard contracts hold the largest capturable pocket, and Meridio outscores rivals on every capability but price</a:t>
+              <a:t>Standard contracts hold the largest capturable pocket, and Meridio leads everywhere except price and digital reach</a:t>
             </a:r>
             <a:endParaRPr lang="en-US" sz="2100" dirty="0"/>
           </a:p>
@@ -26336,7 +26361,7 @@
           <a:bodyPr wrap="square" lIns="0" tIns="0" rIns="0" bIns="0" rtlCol="0" anchor="ctr"/>
           <a:lstStyle/>
           <a:p>
-            <a:pPr indent="0" marL="0">
+            <a:pPr algn="l" indent="0" marL="0">
               <a:buNone/>
             </a:pPr>
             <a:r>
@@ -26400,7 +26425,7 @@
           <a:bodyPr wrap="square" lIns="0" tIns="0" rIns="0" bIns="0" rtlCol="0" anchor="ctr"/>
           <a:lstStyle/>
           <a:p>
-            <a:pPr indent="0" marL="0">
+            <a:pPr algn="l" indent="0" marL="0">
               <a:buNone/>
             </a:pPr>
             <a:r>
@@ -26464,7 +26489,7 @@
           <a:bodyPr wrap="square" lIns="0" tIns="0" rIns="0" bIns="0" rtlCol="0" anchor="ctr"/>
           <a:lstStyle/>
           <a:p>
-            <a:pPr indent="0" marL="0">
+            <a:pPr algn="l" indent="0" marL="0">
               <a:buNone/>
             </a:pPr>
             <a:r>
@@ -26515,7 +26540,7 @@
         </p:nvSpPr>
         <p:spPr>
           <a:xfrm>
-            <a:off x="10845443" y="4296400"/>
+            <a:off x="9126371" y="4296400"/>
             <a:ext cx="1463040" cy="219456"/>
           </a:xfrm>
           <a:prstGeom prst="rect">
@@ -26528,7 +26553,7 @@
           <a:bodyPr wrap="square" lIns="0" tIns="0" rIns="0" bIns="0" rtlCol="0" anchor="ctr"/>
           <a:lstStyle/>
           <a:p>
-            <a:pPr indent="0" marL="0">
+            <a:pPr algn="r" indent="0" marL="0">
               <a:buNone/>
             </a:pPr>
             <a:r>
@@ -27625,7 +27650,7 @@
           <a:bodyPr wrap="square" lIns="0" tIns="0" rIns="0" bIns="0" rtlCol="0" anchor="ctr"/>
           <a:lstStyle/>
           <a:p>
-            <a:pPr indent="0" marL="0">
+            <a:pPr algn="l" indent="0" marL="0">
               <a:buNone/>
             </a:pPr>
             <a:r>
@@ -27766,7 +27791,7 @@
           <a:bodyPr wrap="square" lIns="0" tIns="0" rIns="0" bIns="0" rtlCol="0" anchor="ctr"/>
           <a:lstStyle/>
           <a:p>
-            <a:pPr indent="0" marL="0">
+            <a:pPr algn="l" indent="0" marL="0">
               <a:buNone/>
             </a:pPr>
             <a:r>
@@ -27907,7 +27932,7 @@
           <a:bodyPr wrap="square" lIns="0" tIns="0" rIns="0" bIns="0" rtlCol="0" anchor="ctr"/>
           <a:lstStyle/>
           <a:p>
-            <a:pPr indent="0" marL="0">
+            <a:pPr algn="l" indent="0" marL="0">
               <a:buNone/>
             </a:pPr>
             <a:r>
@@ -30979,8 +31004,8 @@
         </p:nvSpPr>
         <p:spPr>
           <a:xfrm>
-            <a:off x="9142187" y="2135771"/>
-            <a:ext cx="1913108" cy="1913108"/>
+            <a:off x="9345885" y="2624328"/>
+            <a:ext cx="1505712" cy="1505712"/>
           </a:xfrm>
           <a:prstGeom prst="ellipse">
             <a:avLst/>
@@ -31006,20 +31031,20 @@
         </p:nvSpPr>
         <p:spPr>
           <a:xfrm>
-            <a:off x="8596569" y="3084673"/>
-            <a:ext cx="1913108" cy="1913108"/>
+            <a:off x="8916456" y="3371161"/>
+            <a:ext cx="1505712" cy="1505712"/>
           </a:xfrm>
           <a:prstGeom prst="ellipse">
             <a:avLst/>
           </a:prstGeom>
           <a:solidFill>
-            <a:srgbClr val="76B900">
+            <a:srgbClr val="8CB7FA">
               <a:alpha val="38000"/>
             </a:srgbClr>
           </a:solidFill>
           <a:ln w="12700">
             <a:solidFill>
-              <a:srgbClr val="76B900"/>
+              <a:srgbClr val="8CB7FA"/>
             </a:solidFill>
             <a:prstDash val="solid"/>
           </a:ln>
@@ -31033,20 +31058,20 @@
         </p:nvSpPr>
         <p:spPr>
           <a:xfrm>
-            <a:off x="9687806" y="3084673"/>
-            <a:ext cx="1913108" cy="1913108"/>
+            <a:off x="9775314" y="3371161"/>
+            <a:ext cx="1505712" cy="1505712"/>
           </a:xfrm>
           <a:prstGeom prst="ellipse">
             <a:avLst/>
           </a:prstGeom>
           <a:solidFill>
-            <a:srgbClr val="F2A900">
+            <a:srgbClr val="2057AC">
               <a:alpha val="38000"/>
             </a:srgbClr>
           </a:solidFill>
           <a:ln w="12700">
             <a:solidFill>
-              <a:srgbClr val="F2A900"/>
+              <a:srgbClr val="2057AC"/>
             </a:solidFill>
             <a:prstDash val="solid"/>
           </a:ln>
@@ -31060,7 +31085,7 @@
         </p:nvSpPr>
         <p:spPr>
           <a:xfrm>
-            <a:off x="9367221" y="3700856"/>
+            <a:off x="9367221" y="3828867"/>
             <a:ext cx="1463040" cy="274320"/>
           </a:xfrm>
           <a:prstGeom prst="rect">
@@ -31099,7 +31124,7 @@
         </p:nvSpPr>
         <p:spPr>
           <a:xfrm>
-            <a:off x="9184341" y="1861451"/>
+            <a:off x="9184341" y="2350008"/>
             <a:ext cx="1828800" cy="256032"/>
           </a:xfrm>
           <a:prstGeom prst="rect">
@@ -31138,7 +31163,7 @@
         </p:nvSpPr>
         <p:spPr>
           <a:xfrm>
-            <a:off x="8139369" y="5034356"/>
+            <a:off x="8459256" y="4913449"/>
             <a:ext cx="1828800" cy="256032"/>
           </a:xfrm>
           <a:prstGeom prst="rect">
@@ -31177,7 +31202,7 @@
         </p:nvSpPr>
         <p:spPr>
           <a:xfrm>
-            <a:off x="10229313" y="5034356"/>
+            <a:off x="9909426" y="4913449"/>
             <a:ext cx="1828800" cy="256032"/>
           </a:xfrm>
           <a:prstGeom prst="rect">
@@ -31564,8 +31589,8 @@
         </p:nvSpPr>
         <p:spPr>
           <a:xfrm>
-            <a:off x="320040" y="5001768"/>
-            <a:ext cx="1078492" cy="384048"/>
+            <a:off x="420624" y="5001768"/>
+            <a:ext cx="877324" cy="384048"/>
           </a:xfrm>
           <a:prstGeom prst="rect">
             <a:avLst/>
@@ -31688,8 +31713,8 @@
         </p:nvSpPr>
         <p:spPr>
           <a:xfrm>
-            <a:off x="1197364" y="5001768"/>
-            <a:ext cx="1078492" cy="384048"/>
+            <a:off x="1297948" y="5001768"/>
+            <a:ext cx="877324" cy="384048"/>
           </a:xfrm>
           <a:prstGeom prst="rect">
             <a:avLst/>
@@ -31812,8 +31837,8 @@
         </p:nvSpPr>
         <p:spPr>
           <a:xfrm>
-            <a:off x="2074687" y="5001768"/>
-            <a:ext cx="1078492" cy="384048"/>
+            <a:off x="2175271" y="5001768"/>
+            <a:ext cx="877324" cy="384048"/>
           </a:xfrm>
           <a:prstGeom prst="rect">
             <a:avLst/>
@@ -31936,8 +31961,8 @@
         </p:nvSpPr>
         <p:spPr>
           <a:xfrm>
-            <a:off x="2952011" y="5001768"/>
-            <a:ext cx="1078492" cy="384048"/>
+            <a:off x="3052595" y="5001768"/>
+            <a:ext cx="877324" cy="384048"/>
           </a:xfrm>
           <a:prstGeom prst="rect">
             <a:avLst/>
@@ -32060,8 +32085,8 @@
         </p:nvSpPr>
         <p:spPr>
           <a:xfrm>
-            <a:off x="3829335" y="5001768"/>
-            <a:ext cx="1078492" cy="384048"/>
+            <a:off x="3929919" y="5001768"/>
+            <a:ext cx="877324" cy="384048"/>
           </a:xfrm>
           <a:prstGeom prst="rect">
             <a:avLst/>
@@ -32184,8 +32209,8 @@
         </p:nvSpPr>
         <p:spPr>
           <a:xfrm>
-            <a:off x="4706659" y="5001768"/>
-            <a:ext cx="1078492" cy="384048"/>
+            <a:off x="4807243" y="5001768"/>
+            <a:ext cx="877324" cy="384048"/>
           </a:xfrm>
           <a:prstGeom prst="rect">
             <a:avLst/>
@@ -32308,8 +32333,8 @@
         </p:nvSpPr>
         <p:spPr>
           <a:xfrm>
-            <a:off x="5583982" y="5001768"/>
-            <a:ext cx="1078492" cy="384048"/>
+            <a:off x="5684566" y="5001768"/>
+            <a:ext cx="877324" cy="384048"/>
           </a:xfrm>
           <a:prstGeom prst="rect">
             <a:avLst/>
@@ -32571,7 +32596,7 @@
           <a:bodyPr wrap="square" lIns="0" tIns="0" rIns="0" bIns="0" rtlCol="0" anchor="ctr"/>
           <a:lstStyle/>
           <a:p>
-            <a:pPr indent="0" marL="0">
+            <a:pPr algn="l" indent="0" marL="0">
               <a:buNone/>
             </a:pPr>
             <a:r>
@@ -32630,7 +32655,7 @@
           <a:bodyPr wrap="square" lIns="0" tIns="0" rIns="0" bIns="0" rtlCol="0" anchor="ctr"/>
           <a:lstStyle/>
           <a:p>
-            <a:pPr indent="0" marL="0">
+            <a:pPr algn="l" indent="0" marL="0">
               <a:buNone/>
             </a:pPr>
             <a:r>
@@ -32689,7 +32714,7 @@
           <a:bodyPr wrap="square" lIns="0" tIns="0" rIns="0" bIns="0" rtlCol="0" anchor="ctr"/>
           <a:lstStyle/>
           <a:p>
-            <a:pPr indent="0" marL="0">
+            <a:pPr algn="l" indent="0" marL="0">
               <a:buNone/>
             </a:pPr>
             <a:r>
@@ -32735,7 +32760,7 @@
         </p:nvSpPr>
         <p:spPr>
           <a:xfrm>
-            <a:off x="10714900" y="3330793"/>
+            <a:off x="8538628" y="3330793"/>
             <a:ext cx="1828800" cy="292608"/>
           </a:xfrm>
           <a:prstGeom prst="rect">
@@ -32748,7 +32773,7 @@
           <a:bodyPr wrap="square" lIns="0" tIns="0" rIns="0" bIns="0" rtlCol="0" anchor="ctr"/>
           <a:lstStyle/>
           <a:p>
-            <a:pPr indent="0" marL="0">
+            <a:pPr algn="r" indent="0" marL="0">
               <a:buNone/>
             </a:pPr>
             <a:r>
@@ -32807,7 +32832,7 @@
           <a:bodyPr wrap="square" lIns="0" tIns="0" rIns="0" bIns="0" rtlCol="0" anchor="ctr"/>
           <a:lstStyle/>
           <a:p>
-            <a:pPr indent="0" marL="0">
+            <a:pPr algn="l" indent="0" marL="0">
               <a:buNone/>
             </a:pPr>
             <a:r>
@@ -38141,7 +38166,7 @@
         </p:nvSpPr>
         <p:spPr>
           <a:xfrm>
-            <a:off x="6206317" y="2585923"/>
+            <a:off x="3883741" y="2585923"/>
             <a:ext cx="1828800" cy="292608"/>
           </a:xfrm>
           <a:prstGeom prst="rect">
@@ -38154,7 +38179,7 @@
           <a:bodyPr wrap="square" lIns="0" tIns="0" rIns="0" bIns="0" rtlCol="0" anchor="ctr"/>
           <a:lstStyle/>
           <a:p>
-            <a:pPr indent="0" marL="0">
+            <a:pPr algn="r" indent="0" marL="0">
               <a:buNone/>
             </a:pPr>
             <a:r>
@@ -38200,7 +38225,7 @@
         </p:nvSpPr>
         <p:spPr>
           <a:xfrm>
-            <a:off x="6654120" y="3200034"/>
+            <a:off x="4386408" y="3200034"/>
             <a:ext cx="1828800" cy="292608"/>
           </a:xfrm>
           <a:prstGeom prst="rect">
@@ -38213,7 +38238,7 @@
           <a:bodyPr wrap="square" lIns="0" tIns="0" rIns="0" bIns="0" rtlCol="0" anchor="ctr"/>
           <a:lstStyle/>
           <a:p>
-            <a:pPr indent="0" marL="0">
+            <a:pPr algn="r" indent="0" marL="0">
               <a:buNone/>
             </a:pPr>
             <a:r>
@@ -38272,7 +38297,7 @@
           <a:bodyPr wrap="square" lIns="0" tIns="0" rIns="0" bIns="0" rtlCol="0" anchor="ctr"/>
           <a:lstStyle/>
           <a:p>
-            <a:pPr indent="0" marL="0">
+            <a:pPr algn="l" indent="0" marL="0">
               <a:buNone/>
             </a:pPr>
             <a:r>
@@ -38331,7 +38356,7 @@
           <a:bodyPr wrap="square" lIns="0" tIns="0" rIns="0" bIns="0" rtlCol="0" anchor="ctr"/>
           <a:lstStyle/>
           <a:p>
-            <a:pPr indent="0" marL="0">
+            <a:pPr algn="l" indent="0" marL="0">
               <a:buNone/>
             </a:pPr>
             <a:r>
@@ -38390,7 +38415,7 @@
           <a:bodyPr wrap="square" lIns="0" tIns="0" rIns="0" bIns="0" rtlCol="0" anchor="ctr"/>
           <a:lstStyle/>
           <a:p>
-            <a:pPr indent="0" marL="0">
+            <a:pPr algn="l" indent="0" marL="0">
               <a:buNone/>
             </a:pPr>
             <a:r>
@@ -38449,7 +38474,7 @@
           <a:bodyPr wrap="square" lIns="0" tIns="0" rIns="0" bIns="0" rtlCol="0" anchor="ctr"/>
           <a:lstStyle/>
           <a:p>
-            <a:pPr indent="0" marL="0">
+            <a:pPr algn="l" indent="0" marL="0">
               <a:buNone/>
             </a:pPr>
             <a:r>
@@ -46427,6 +46452,49 @@
                 <a:cs typeface="Arial" pitchFamily="34" charset="-120"/>
               </a:rPr>
               <a:t>94% of sites are within two hours of a Meridio technician, versus 61% for the best-placed competitor. This gap, costly to replicate, justifies a price premium measured at 8-12% in the customer interviews.</a:t>
+            </a:r>
+            <a:endParaRPr lang="en-US" sz="1250" dirty="0"/>
+          </a:p>
+          <a:p>
+            <a:pPr algn="l" indent="0" marL="0">
+              <a:lnSpc>
+                <a:spcPct val="135000"/>
+              </a:lnSpc>
+              <a:spcAft>
+                <a:spcPts val="1200"/>
+              </a:spcAft>
+              <a:buNone/>
+            </a:pPr>
+            <a:r>
+              <a:rPr lang="en-US" sz="1250" b="1" dirty="0">
+                <a:solidFill>
+                  <a:srgbClr val="1A1A1A"/>
+                </a:solidFill>
+                <a:latin typeface="Arial" pitchFamily="34" charset="0"/>
+                <a:ea typeface="Arial" pitchFamily="34" charset="-122"/>
+                <a:cs typeface="Arial" pitchFamily="34" charset="-120"/>
+              </a:rPr>
+              <a:t>The window to monetize it is now. </a:t>
+            </a:r>
+            <a:pPr algn="l" indent="0" marL="0">
+              <a:lnSpc>
+                <a:spcPct val="135000"/>
+              </a:lnSpc>
+              <a:spcAft>
+                <a:spcPts val="1200"/>
+              </a:spcAft>
+              <a:buNone/>
+            </a:pPr>
+            <a:r>
+              <a:rPr lang="en-US" sz="1250" dirty="0">
+                <a:solidFill>
+                  <a:srgbClr val="1A1A1A"/>
+                </a:solidFill>
+                <a:latin typeface="Arial" pitchFamily="34" charset="0"/>
+                <a:ea typeface="Arial" pitchFamily="34" charset="-122"/>
+                <a:cs typeface="Arial" pitchFamily="34" charset="-120"/>
+              </a:rPr>
+              <a:t>Independent maintainers sign roughly 2,300 installed-base contracts per quarter. Each signed contract locks a site for three to five years: the asset does not lose value gradually, it becomes unavailable one signature at a time.</a:t>
             </a:r>
             <a:endParaRPr lang="en-US" sz="1250" dirty="0"/>
           </a:p>

</xml_diff>

<commit_message>
Release v1.6.2: evidence tags [F/I/A/E] never shown on slides
</commit_message>
<xml_diff>
--- a/examples/golden-deck.pptx
+++ b/examples/golden-deck.pptx
@@ -9266,7 +9266,7 @@
                 <a:ea typeface="Arial" pitchFamily="34" charset="-122"/>
                 <a:cs typeface="Arial" pitchFamily="34" charset="-120"/>
               </a:rPr>
-              <a:t>Services margin reaches 46% in 2025 versus 20% for equipment, and has been growing 1.2 points per year since 2021. [F]</a:t>
+              <a:t>Services margin reaches 46% in 2025 versus 20% for equipment, and has been growing 1.2 points per year since 2021.</a:t>
             </a:r>
             <a:endParaRPr lang="en-US" sz="1200" dirty="0"/>
           </a:p>
@@ -9290,7 +9290,7 @@
                 <a:ea typeface="Arial" pitchFamily="34" charset="-122"/>
                 <a:cs typeface="Arial" pitchFamily="34" charset="-120"/>
               </a:rPr>
-              <a:t>The gap comes from the mix: multi-year contracts smooth travel costs and raise technician utilization from 61% to 78%. [I]</a:t>
+              <a:t>The gap comes from the mix: multi-year contracts smooth travel costs and raise technician utilization from 61% to 78%.</a:t>
             </a:r>
             <a:endParaRPr lang="en-US" sz="1200" dirty="0"/>
           </a:p>
@@ -9314,7 +9314,7 @@
                 <a:ea typeface="Arial" pitchFamily="34" charset="-122"/>
                 <a:cs typeface="Arial" pitchFamily="34" charset="-120"/>
               </a:rPr>
-              <a:t>Each point of services mix adds roughly 0.55 point of group margin: the 35% mix target lifts group margin from 28% to 34%. [E]</a:t>
+              <a:t>Each point of services mix adds roughly 0.55 point of group margin: the 35% mix target lifts group margin from 28% to 34%.</a:t>
             </a:r>
             <a:endParaRPr lang="en-US" sz="1200" dirty="0"/>
           </a:p>
@@ -38727,7 +38727,7 @@
                 <a:ea typeface="Arial" pitchFamily="34" charset="-122"/>
                 <a:cs typeface="Arial" pitchFamily="34" charset="-120"/>
               </a:rPr>
-              <a:t>The two invest pockets carry EUR 73M of the EUR 100M capturable: focus beats breadth. [F]</a:t>
+              <a:t>The two invest pockets carry EUR 73M of the EUR 100M capturable: focus beats breadth.</a:t>
             </a:r>
             <a:endParaRPr lang="en-US" sz="1200" dirty="0"/>
           </a:p>
@@ -38751,7 +38751,7 @@
                 <a:ea typeface="Arial" pitchFamily="34" charset="-122"/>
                 <a:cs typeface="Arial" pitchFamily="34" charset="-120"/>
               </a:rPr>
-              <a:t>Benelux is attractive but premature: ability to win stays low until the French platform is proven. [I]</a:t>
+              <a:t>Benelux is attractive but premature: ability to win stays low until the French platform is proven.</a:t>
             </a:r>
             <a:endParaRPr lang="en-US" sz="1200" dirty="0"/>
           </a:p>
@@ -38775,7 +38775,7 @@
                 <a:ea typeface="Arial" pitchFamily="34" charset="-122"/>
                 <a:cs typeface="Arial" pitchFamily="34" charset="-120"/>
               </a:rPr>
-              <a:t>IoT hardware resale fails both tests: exit the line by 2027 and free 6 sales FTEs. [A]</a:t>
+              <a:t>IoT hardware resale fails both tests: exit the line by 2027 and free 6 sales FTEs.</a:t>
             </a:r>
             <a:endParaRPr lang="en-US" sz="1200" dirty="0"/>
           </a:p>

</xml_diff>